<commit_message>
Add LIT-MR-02.1 positive-control case studies
</commit_message>
<xml_diff>
--- a/presentations/gen5_lit_mr_02_1_bollinger_evidence.pptx
+++ b/presentations/gen5_lit_mr_02_1_bollinger_evidence.pptx
@@ -2,37 +2,45 @@
 <file path=ppt/presentation.xml><?xml version="1.0" encoding="utf-8"?>
 <p:presentation xmlns:p="http://schemas.openxmlformats.org/presentationml/2006/main">
   <p:sldMasterIdLst>
-    <p:sldMasterId xmlns:r="http://schemas.openxmlformats.org/officeDocument/2006/relationships" id="2147483648" r:id="Rb0fdfb37a6c74bf5"/>
+    <p:sldMasterId xmlns:r="http://schemas.openxmlformats.org/officeDocument/2006/relationships" id="2147483648" r:id="R0ff1918952ef4807"/>
   </p:sldMasterIdLst>
   <p:notesMasterIdLst>
-    <p:notesMasterId xmlns:r="http://schemas.openxmlformats.org/officeDocument/2006/relationships" r:id="Rba7251fa838a44d3"/>
+    <p:notesMasterId xmlns:r="http://schemas.openxmlformats.org/officeDocument/2006/relationships" r:id="Rdb7b1a1873cb411e"/>
   </p:notesMasterIdLst>
   <p:sldIdLst>
-    <p:sldId xmlns:r="http://schemas.openxmlformats.org/officeDocument/2006/relationships" id="256" r:id="R0130781af4254633"/>
-    <p:sldId xmlns:r="http://schemas.openxmlformats.org/officeDocument/2006/relationships" id="257" r:id="Rf2c46f0ce2f34dc1"/>
-    <p:sldId xmlns:r="http://schemas.openxmlformats.org/officeDocument/2006/relationships" id="258" r:id="R8630a5dcd0a94a13"/>
-    <p:sldId xmlns:r="http://schemas.openxmlformats.org/officeDocument/2006/relationships" id="259" r:id="R116dd3c193c24878"/>
-    <p:sldId xmlns:r="http://schemas.openxmlformats.org/officeDocument/2006/relationships" id="260" r:id="R6a9ea2d31d804382"/>
-    <p:sldId xmlns:r="http://schemas.openxmlformats.org/officeDocument/2006/relationships" id="261" r:id="R84f1f9c538e34184"/>
-    <p:sldId xmlns:r="http://schemas.openxmlformats.org/officeDocument/2006/relationships" id="262" r:id="R7899df83a8a941d3"/>
-    <p:sldId xmlns:r="http://schemas.openxmlformats.org/officeDocument/2006/relationships" id="263" r:id="R4f5474c282e740e8"/>
-    <p:sldId xmlns:r="http://schemas.openxmlformats.org/officeDocument/2006/relationships" id="264" r:id="Rcf66f14337e84ca6"/>
-    <p:sldId xmlns:r="http://schemas.openxmlformats.org/officeDocument/2006/relationships" id="265" r:id="Rb6beaf2aa30d402b"/>
-    <p:sldId xmlns:r="http://schemas.openxmlformats.org/officeDocument/2006/relationships" id="266" r:id="R05c5c90e09be4f06"/>
-    <p:sldId xmlns:r="http://schemas.openxmlformats.org/officeDocument/2006/relationships" id="267" r:id="R6033d8a4c620406a"/>
-    <p:sldId xmlns:r="http://schemas.openxmlformats.org/officeDocument/2006/relationships" id="268" r:id="R3e15764e58cf47c1"/>
-    <p:sldId xmlns:r="http://schemas.openxmlformats.org/officeDocument/2006/relationships" id="269" r:id="Rcec12b984c3a4b27"/>
-    <p:sldId xmlns:r="http://schemas.openxmlformats.org/officeDocument/2006/relationships" id="270" r:id="R37006ac44dfb4bf2"/>
-    <p:sldId xmlns:r="http://schemas.openxmlformats.org/officeDocument/2006/relationships" id="271" r:id="R408268d4b31849e3"/>
-    <p:sldId xmlns:r="http://schemas.openxmlformats.org/officeDocument/2006/relationships" id="272" r:id="R4b6524057d7048e2"/>
-    <p:sldId xmlns:r="http://schemas.openxmlformats.org/officeDocument/2006/relationships" id="273" r:id="R2072f0d46de64ba8"/>
-    <p:sldId xmlns:r="http://schemas.openxmlformats.org/officeDocument/2006/relationships" id="274" r:id="Rad4030a59b8648a6"/>
-    <p:sldId xmlns:r="http://schemas.openxmlformats.org/officeDocument/2006/relationships" id="275" r:id="R8a439ab810104168"/>
-    <p:sldId xmlns:r="http://schemas.openxmlformats.org/officeDocument/2006/relationships" id="276" r:id="R1d4ae6e6b0da4070"/>
-    <p:sldId xmlns:r="http://schemas.openxmlformats.org/officeDocument/2006/relationships" id="277" r:id="R6337b03cee7a4fa2"/>
-    <p:sldId xmlns:r="http://schemas.openxmlformats.org/officeDocument/2006/relationships" id="278" r:id="Rfd70d95e984641b4"/>
-    <p:sldId xmlns:r="http://schemas.openxmlformats.org/officeDocument/2006/relationships" id="279" r:id="Rd517b7513a834c02"/>
-    <p:sldId xmlns:r="http://schemas.openxmlformats.org/officeDocument/2006/relationships" id="280" r:id="R6230da88c2794665"/>
+    <p:sldId xmlns:r="http://schemas.openxmlformats.org/officeDocument/2006/relationships" id="256" r:id="Rba525469a78f4593"/>
+    <p:sldId xmlns:r="http://schemas.openxmlformats.org/officeDocument/2006/relationships" id="257" r:id="Rac7dc99e3c2945db"/>
+    <p:sldId xmlns:r="http://schemas.openxmlformats.org/officeDocument/2006/relationships" id="258" r:id="R0fc6a863c5d14b8a"/>
+    <p:sldId xmlns:r="http://schemas.openxmlformats.org/officeDocument/2006/relationships" id="259" r:id="R340af81d15b04cf0"/>
+    <p:sldId xmlns:r="http://schemas.openxmlformats.org/officeDocument/2006/relationships" id="260" r:id="R5f5e47bd1fde46aa"/>
+    <p:sldId xmlns:r="http://schemas.openxmlformats.org/officeDocument/2006/relationships" id="261" r:id="R4a8b179aa0684b01"/>
+    <p:sldId xmlns:r="http://schemas.openxmlformats.org/officeDocument/2006/relationships" id="262" r:id="R482f6db5378e4390"/>
+    <p:sldId xmlns:r="http://schemas.openxmlformats.org/officeDocument/2006/relationships" id="263" r:id="Rf4dc6912db4e43f6"/>
+    <p:sldId xmlns:r="http://schemas.openxmlformats.org/officeDocument/2006/relationships" id="264" r:id="Rbef6d66ce822439f"/>
+    <p:sldId xmlns:r="http://schemas.openxmlformats.org/officeDocument/2006/relationships" id="265" r:id="R140d588a27ac466f"/>
+    <p:sldId xmlns:r="http://schemas.openxmlformats.org/officeDocument/2006/relationships" id="266" r:id="Raf7eae2e1fc14c03"/>
+    <p:sldId xmlns:r="http://schemas.openxmlformats.org/officeDocument/2006/relationships" id="267" r:id="R3f8e65828b034c0c"/>
+    <p:sldId xmlns:r="http://schemas.openxmlformats.org/officeDocument/2006/relationships" id="268" r:id="Ra0b50b82f28b48ce"/>
+    <p:sldId xmlns:r="http://schemas.openxmlformats.org/officeDocument/2006/relationships" id="269" r:id="R54116230a2fb48f1"/>
+    <p:sldId xmlns:r="http://schemas.openxmlformats.org/officeDocument/2006/relationships" id="270" r:id="Rb11bb6e2ec254291"/>
+    <p:sldId xmlns:r="http://schemas.openxmlformats.org/officeDocument/2006/relationships" id="271" r:id="R559966ba248648c4"/>
+    <p:sldId xmlns:r="http://schemas.openxmlformats.org/officeDocument/2006/relationships" id="272" r:id="R36e1f00029774c5d"/>
+    <p:sldId xmlns:r="http://schemas.openxmlformats.org/officeDocument/2006/relationships" id="273" r:id="R501d17a74ffa4e95"/>
+    <p:sldId xmlns:r="http://schemas.openxmlformats.org/officeDocument/2006/relationships" id="274" r:id="R80e31e3ec9524f43"/>
+    <p:sldId xmlns:r="http://schemas.openxmlformats.org/officeDocument/2006/relationships" id="275" r:id="R6e9ce5f4b3184b05"/>
+    <p:sldId xmlns:r="http://schemas.openxmlformats.org/officeDocument/2006/relationships" id="276" r:id="R2e74613cd04f40fa"/>
+    <p:sldId xmlns:r="http://schemas.openxmlformats.org/officeDocument/2006/relationships" id="277" r:id="R98de95311e4c4ef7"/>
+    <p:sldId xmlns:r="http://schemas.openxmlformats.org/officeDocument/2006/relationships" id="278" r:id="Rba2b5cdbef0e4f64"/>
+    <p:sldId xmlns:r="http://schemas.openxmlformats.org/officeDocument/2006/relationships" id="279" r:id="Rec86ed4710c74328"/>
+    <p:sldId xmlns:r="http://schemas.openxmlformats.org/officeDocument/2006/relationships" id="280" r:id="R8035548227094914"/>
+    <p:sldId xmlns:r="http://schemas.openxmlformats.org/officeDocument/2006/relationships" id="281" r:id="R5f6bf38ac69d48c2"/>
+    <p:sldId xmlns:r="http://schemas.openxmlformats.org/officeDocument/2006/relationships" id="282" r:id="R2a80033bf24f49a6"/>
+    <p:sldId xmlns:r="http://schemas.openxmlformats.org/officeDocument/2006/relationships" id="283" r:id="R6c933ae295984898"/>
+    <p:sldId xmlns:r="http://schemas.openxmlformats.org/officeDocument/2006/relationships" id="284" r:id="Rbead07570f5a4ab1"/>
+    <p:sldId xmlns:r="http://schemas.openxmlformats.org/officeDocument/2006/relationships" id="285" r:id="R8148dca2dbbb4578"/>
+    <p:sldId xmlns:r="http://schemas.openxmlformats.org/officeDocument/2006/relationships" id="286" r:id="Rf945799aa9ba4d34"/>
+    <p:sldId xmlns:r="http://schemas.openxmlformats.org/officeDocument/2006/relationships" id="287" r:id="R997b1c070c794914"/>
+    <p:sldId xmlns:r="http://schemas.openxmlformats.org/officeDocument/2006/relationships" id="288" r:id="Rf5b013401a334102"/>
   </p:sldIdLst>
   <p:sldSz cx="12192000" cy="6858000"/>
   <p:notesSz cx="6858000" cy="9144000"/>
@@ -2086,7 +2094,7 @@
           <a:lstStyle xmlns:a="http://schemas.openxmlformats.org/drawingml/2006/main"/>
           <a:p xmlns:a="http://schemas.openxmlformats.org/drawingml/2006/main">
             <a:r>
-              <a:t>The result is actionable as research governance: the exact source-inspired template is broadly stopped in TRAIN. A future variant must begin from a new mechanism-level hypothesis, not from rescuing a pair or threshold after observing these outcomes.</a:t>
+              <a:t>2018 is documented as a positive-control regime for the unchanged LIT-MR-02.1 mechanism. It is descriptive evidence found after the primary five-year TRAIN decision and therefore cannot reverse that STOP.</a:t>
             </a:r>
           </a:p>
           <a:p xmlns:a="http://schemas.openxmlformats.org/drawingml/2006/main">
@@ -2101,22 +2109,397 @@
           </a:p>
           <a:p xmlns:a="http://schemas.openxmlformats.org/drawingml/2006/main">
             <a:r>
-              <a:t>- C:/Users/Franc/OneDrive/Documents/Francis/Peltata Project/Time-Series-Modeling-Gen5/docs/GEN5_LIT_MR_02_1_PANEL_A_CONTRACT.md</a:t>
-            </a:r>
-          </a:p>
-          <a:p xmlns:a="http://schemas.openxmlformats.org/drawingml/2006/main">
-            <a:r>
-              <a:t>- C:/Users/Franc/OneDrive/Documents/Francis/Peltata Project/Time-Series-Modeling-Gen5/docs/GEN5_LIT_MR_02_1_PANEL_B_CONTRACT.md</a:t>
-            </a:r>
-          </a:p>
-          <a:p xmlns:a="http://schemas.openxmlformats.org/drawingml/2006/main">
-            <a:r>
-              <a:t>- C:/Users/Franc/OneDrive/Documents/Francis/Peltata Project/Time-Series-Modeling-Gen5/runs/research_workbench/literature_grounded/lit_mr_02_1_panel_b_20260728/mr02_panel_report.md</a:t>
-            </a:r>
-          </a:p>
-          <a:p xmlns:a="http://schemas.openxmlformats.org/drawingml/2006/main">
-            <a:r>
-              <a:t>- C:/Users/Franc/OneDrive/Documents/Francis/Peltata Project/Time-Series-Modeling-Gen5/docs/GEN5_LITERATURE_GROUNDED_STRATEGY_RESEARCH_NOMENCLATURE.md</a:t>
+              <a:t>- C:/Users/Franc/OneDrive/Documents/Francis/Peltata Project/Time-Series-Modeling-Gen5/docs/GEN5_LIT_MR_02_1_CASE_STUDIES.md</a:t>
+            </a:r>
+          </a:p>
+          <a:p xmlns:a="http://schemas.openxmlformats.org/drawingml/2006/main">
+            <a:r>
+              <a:t>- C:/Users/Franc/OneDrive/Documents/Francis/Peltata Project/Time-Series-Modeling-Gen5/runs/research_workbench/literature_grounded/lit_mr_02_1_case_studies_20260729/mr02_case_2018_summary.csv</a:t>
+            </a:r>
+          </a:p>
+          <a:p xmlns:a="http://schemas.openxmlformats.org/drawingml/2006/main">
+            <a:r>
+              <a:t>- C:/Users/Franc/OneDrive/Documents/Francis/Peltata Project/Time-Series-Modeling-Gen5/runs/research_workbench/literature_grounded/lit_mr_02_1_case_studies_20260729/mr02_case_studies_report.md</a:t>
+            </a:r>
+          </a:p>
+        </p:txBody>
+      </p:sp>
+      <p:sp>
+        <p:nvSpPr>
+          <p:cNvPr id="4" name="Slide Number Placeholder 3"/>
+          <p:cNvSpPr>
+            <a:spLocks xmlns:a="http://schemas.openxmlformats.org/drawingml/2006/main" noGrp="1"/>
+          </p:cNvSpPr>
+          <p:nvPr>
+            <p:ph type="sldNum" idx="5"/>
+          </p:nvPr>
+        </p:nvSpPr>
+        <p:spPr/>
+        <p:txBody>
+          <a:bodyPr xmlns:a="http://schemas.openxmlformats.org/drawingml/2006/main"/>
+          <a:lstStyle xmlns:a="http://schemas.openxmlformats.org/drawingml/2006/main"/>
+          <a:p xmlns:a="http://schemas.openxmlformats.org/drawingml/2006/main"/>
+        </p:txBody>
+      </p:sp>
+    </p:spTree>
+  </p:cSld>
+  <p:clrMapOvr>
+    <a:masterClrMapping xmlns:a="http://schemas.openxmlformats.org/drawingml/2006/main"/>
+  </p:clrMapOvr>
+</p:notes>
+</file>
+
+<file path=ppt/notesSlides/notesSlide26.xml><?xml version="1.0" encoding="utf-8"?>
+<p:notes xmlns:p="http://schemas.openxmlformats.org/presentationml/2006/main">
+  <p:cSld>
+    <p:spTree>
+      <p:nvGrpSpPr>
+        <p:cNvPr id="1" name=""/>
+        <p:cNvGrpSpPr/>
+        <p:nvPr/>
+      </p:nvGrpSpPr>
+      <p:grpSpPr>
+        <a:xfrm xmlns:a="http://schemas.openxmlformats.org/drawingml/2006/main"/>
+      </p:grpSpPr>
+      <p:sp>
+        <p:nvSpPr>
+          <p:cNvPr id="2" name="Slide Image Placeholder 1"/>
+          <p:cNvSpPr>
+            <a:spLocks xmlns:a="http://schemas.openxmlformats.org/drawingml/2006/main" noGrp="1"/>
+          </p:cNvSpPr>
+          <p:nvPr>
+            <p:ph type="sldImg" idx="0"/>
+          </p:nvPr>
+        </p:nvSpPr>
+        <p:spPr/>
+      </p:sp>
+      <p:sp>
+        <p:nvSpPr>
+          <p:cNvPr id="3" name="Notes Placeholder 2"/>
+          <p:cNvSpPr>
+            <a:spLocks xmlns:a="http://schemas.openxmlformats.org/drawingml/2006/main" noGrp="1"/>
+          </p:cNvSpPr>
+          <p:nvPr>
+            <p:ph type="body" idx="1"/>
+          </p:nvPr>
+        </p:nvSpPr>
+        <p:spPr/>
+        <p:txBody>
+          <a:bodyPr xmlns:a="http://schemas.openxmlformats.org/drawingml/2006/main"/>
+          <a:lstStyle xmlns:a="http://schemas.openxmlformats.org/drawingml/2006/main"/>
+          <a:p xmlns:a="http://schemas.openxmlformats.org/drawingml/2006/main">
+            <a:r>
+              <a:t>The exact frozen primary-cost replay returned 4.82% in calendar 2018, with a 0.736 naive annualized Sharpe, a 7.64% maximum drawdown, and nine winners among 13 completed trades. The five-year context remains mixed and ultimately negative.</a:t>
+            </a:r>
+          </a:p>
+          <a:p xmlns:a="http://schemas.openxmlformats.org/drawingml/2006/main">
+            <a:r>
+              <a:t/>
+            </a:r>
+          </a:p>
+          <a:p xmlns:a="http://schemas.openxmlformats.org/drawingml/2006/main">
+            <a:r>
+              <a:t>[Sources]</a:t>
+            </a:r>
+          </a:p>
+          <a:p xmlns:a="http://schemas.openxmlformats.org/drawingml/2006/main">
+            <a:r>
+              <a:t>- C:/Users/Franc/OneDrive/Documents/Francis/Peltata Project/Time-Series-Modeling-Gen5/docs/GEN5_LIT_MR_02_1_CASE_STUDIES.md</a:t>
+            </a:r>
+          </a:p>
+          <a:p xmlns:a="http://schemas.openxmlformats.org/drawingml/2006/main">
+            <a:r>
+              <a:t>- C:/Users/Franc/OneDrive/Documents/Francis/Peltata Project/Time-Series-Modeling-Gen5/runs/research_workbench/literature_grounded/lit_mr_02_1_case_studies_20260729/mr02_case_2018_summary.csv</a:t>
+            </a:r>
+          </a:p>
+          <a:p xmlns:a="http://schemas.openxmlformats.org/drawingml/2006/main">
+            <a:r>
+              <a:t>- C:/Users/Franc/OneDrive/Documents/Francis/Peltata Project/Time-Series-Modeling-Gen5/runs/research_workbench/literature_grounded/lit_mr_02_1_case_studies_20260729/visuals/mr02_case_2018_five_year_context.png</a:t>
+            </a:r>
+          </a:p>
+        </p:txBody>
+      </p:sp>
+      <p:sp>
+        <p:nvSpPr>
+          <p:cNvPr id="4" name="Slide Number Placeholder 3"/>
+          <p:cNvSpPr>
+            <a:spLocks xmlns:a="http://schemas.openxmlformats.org/drawingml/2006/main" noGrp="1"/>
+          </p:cNvSpPr>
+          <p:nvPr>
+            <p:ph type="sldNum" idx="5"/>
+          </p:nvPr>
+        </p:nvSpPr>
+        <p:spPr/>
+        <p:txBody>
+          <a:bodyPr xmlns:a="http://schemas.openxmlformats.org/drawingml/2006/main"/>
+          <a:lstStyle xmlns:a="http://schemas.openxmlformats.org/drawingml/2006/main"/>
+          <a:p xmlns:a="http://schemas.openxmlformats.org/drawingml/2006/main"/>
+        </p:txBody>
+      </p:sp>
+    </p:spTree>
+  </p:cSld>
+  <p:clrMapOvr>
+    <a:masterClrMapping xmlns:a="http://schemas.openxmlformats.org/drawingml/2006/main"/>
+  </p:clrMapOvr>
+</p:notes>
+</file>
+
+<file path=ppt/notesSlides/notesSlide27.xml><?xml version="1.0" encoding="utf-8"?>
+<p:notes xmlns:p="http://schemas.openxmlformats.org/presentationml/2006/main">
+  <p:cSld>
+    <p:spTree>
+      <p:nvGrpSpPr>
+        <p:cNvPr id="1" name=""/>
+        <p:cNvGrpSpPr/>
+        <p:nvPr/>
+      </p:nvGrpSpPr>
+      <p:grpSpPr>
+        <a:xfrm xmlns:a="http://schemas.openxmlformats.org/drawingml/2006/main"/>
+      </p:grpSpPr>
+      <p:sp>
+        <p:nvSpPr>
+          <p:cNvPr id="2" name="Slide Image Placeholder 1"/>
+          <p:cNvSpPr>
+            <a:spLocks xmlns:a="http://schemas.openxmlformats.org/drawingml/2006/main" noGrp="1"/>
+          </p:cNvSpPr>
+          <p:nvPr>
+            <p:ph type="sldImg" idx="0"/>
+          </p:nvPr>
+        </p:nvSpPr>
+        <p:spPr/>
+      </p:sp>
+      <p:sp>
+        <p:nvSpPr>
+          <p:cNvPr id="3" name="Notes Placeholder 2"/>
+          <p:cNvSpPr>
+            <a:spLocks xmlns:a="http://schemas.openxmlformats.org/drawingml/2006/main" noGrp="1"/>
+          </p:cNvSpPr>
+          <p:nvPr>
+            <p:ph type="body" idx="1"/>
+          </p:nvPr>
+        </p:nvSpPr>
+        <p:spPr/>
+        <p:txBody>
+          <a:bodyPr xmlns:a="http://schemas.openxmlformats.org/drawingml/2006/main"/>
+          <a:lstStyle xmlns:a="http://schemas.openxmlformats.org/drawingml/2006/main"/>
+          <a:p xmlns:a="http://schemas.openxmlformats.org/drawingml/2006/main">
+            <a:r>
+              <a:t>The top panel shows the adaptive raw-price spread and rolling mean plus or minus one standard deviation. The middle panel shows the corresponding z-score state and long/short entries. The bottom panel ties those states to the next-open, cost-aware equity and drawdown path.</a:t>
+            </a:r>
+          </a:p>
+          <a:p xmlns:a="http://schemas.openxmlformats.org/drawingml/2006/main">
+            <a:r>
+              <a:t/>
+            </a:r>
+          </a:p>
+          <a:p xmlns:a="http://schemas.openxmlformats.org/drawingml/2006/main">
+            <a:r>
+              <a:t>[Sources]</a:t>
+            </a:r>
+          </a:p>
+          <a:p xmlns:a="http://schemas.openxmlformats.org/drawingml/2006/main">
+            <a:r>
+              <a:t>- C:/Users/Franc/OneDrive/Documents/Francis/Peltata Project/Time-Series-Modeling-Gen5/docs/GEN5_LIT_MR_02_1_CASE_STUDIES.md</a:t>
+            </a:r>
+          </a:p>
+          <a:p xmlns:a="http://schemas.openxmlformats.org/drawingml/2006/main">
+            <a:r>
+              <a:t>- C:/Users/Franc/OneDrive/Documents/Francis/Peltata Project/Time-Series-Modeling-Gen5/runs/research_workbench/literature_grounded/lit_mr_02_1_case_studies_20260729/mr02_case_2018_summary.csv</a:t>
+            </a:r>
+          </a:p>
+          <a:p xmlns:a="http://schemas.openxmlformats.org/drawingml/2006/main">
+            <a:r>
+              <a:t>- C:/Users/Franc/OneDrive/Documents/Francis/Peltata Project/Time-Series-Modeling-Gen5/runs/research_workbench/literature_grounded/lit_mr_02_1_case_studies_20260729/visuals/mr02_case_2018_strategy_anatomy.png</a:t>
+            </a:r>
+          </a:p>
+        </p:txBody>
+      </p:sp>
+      <p:sp>
+        <p:nvSpPr>
+          <p:cNvPr id="4" name="Slide Number Placeholder 3"/>
+          <p:cNvSpPr>
+            <a:spLocks xmlns:a="http://schemas.openxmlformats.org/drawingml/2006/main" noGrp="1"/>
+          </p:cNvSpPr>
+          <p:nvPr>
+            <p:ph type="sldNum" idx="5"/>
+          </p:nvPr>
+        </p:nvSpPr>
+        <p:spPr/>
+        <p:txBody>
+          <a:bodyPr xmlns:a="http://schemas.openxmlformats.org/drawingml/2006/main"/>
+          <a:lstStyle xmlns:a="http://schemas.openxmlformats.org/drawingml/2006/main"/>
+          <a:p xmlns:a="http://schemas.openxmlformats.org/drawingml/2006/main"/>
+        </p:txBody>
+      </p:sp>
+    </p:spTree>
+  </p:cSld>
+  <p:clrMapOvr>
+    <a:masterClrMapping xmlns:a="http://schemas.openxmlformats.org/drawingml/2006/main"/>
+  </p:clrMapOvr>
+</p:notes>
+</file>
+
+<file path=ppt/notesSlides/notesSlide28.xml><?xml version="1.0" encoding="utf-8"?>
+<p:notes xmlns:p="http://schemas.openxmlformats.org/presentationml/2006/main">
+  <p:cSld>
+    <p:spTree>
+      <p:nvGrpSpPr>
+        <p:cNvPr id="1" name=""/>
+        <p:cNvGrpSpPr/>
+        <p:nvPr/>
+      </p:nvGrpSpPr>
+      <p:grpSpPr>
+        <a:xfrm xmlns:a="http://schemas.openxmlformats.org/drawingml/2006/main"/>
+      </p:grpSpPr>
+      <p:sp>
+        <p:nvSpPr>
+          <p:cNvPr id="2" name="Slide Image Placeholder 1"/>
+          <p:cNvSpPr>
+            <a:spLocks xmlns:a="http://schemas.openxmlformats.org/drawingml/2006/main" noGrp="1"/>
+          </p:cNvSpPr>
+          <p:nvPr>
+            <p:ph type="sldImg" idx="0"/>
+          </p:nvPr>
+        </p:nvSpPr>
+        <p:spPr/>
+      </p:sp>
+      <p:sp>
+        <p:nvSpPr>
+          <p:cNvPr id="3" name="Notes Placeholder 2"/>
+          <p:cNvSpPr>
+            <a:spLocks xmlns:a="http://schemas.openxmlformats.org/drawingml/2006/main" noGrp="1"/>
+          </p:cNvSpPr>
+          <p:nvPr>
+            <p:ph type="body" idx="1"/>
+          </p:nvPr>
+        </p:nvSpPr>
+        <p:spPr/>
+        <p:txBody>
+          <a:bodyPr xmlns:a="http://schemas.openxmlformats.org/drawingml/2006/main"/>
+          <a:lstStyle xmlns:a="http://schemas.openxmlformats.org/drawingml/2006/main"/>
+          <a:p xmlns:a="http://schemas.openxmlformats.org/drawingml/2006/main">
+            <a:r>
+              <a:t>The representative tape is the full 2018 trade set: nine long-spread trades and four short-spread trades. It makes the timing, participation, holding periods, and concentration of gains and losses auditable.</a:t>
+            </a:r>
+          </a:p>
+          <a:p xmlns:a="http://schemas.openxmlformats.org/drawingml/2006/main">
+            <a:r>
+              <a:t/>
+            </a:r>
+          </a:p>
+          <a:p xmlns:a="http://schemas.openxmlformats.org/drawingml/2006/main">
+            <a:r>
+              <a:t>[Sources]</a:t>
+            </a:r>
+          </a:p>
+          <a:p xmlns:a="http://schemas.openxmlformats.org/drawingml/2006/main">
+            <a:r>
+              <a:t>- C:/Users/Franc/OneDrive/Documents/Francis/Peltata Project/Time-Series-Modeling-Gen5/docs/GEN5_LIT_MR_02_1_CASE_STUDIES.md</a:t>
+            </a:r>
+          </a:p>
+          <a:p xmlns:a="http://schemas.openxmlformats.org/drawingml/2006/main">
+            <a:r>
+              <a:t>- C:/Users/Franc/OneDrive/Documents/Francis/Peltata Project/Time-Series-Modeling-Gen5/runs/research_workbench/literature_grounded/lit_mr_02_1_case_studies_20260729/mr02_case_2018_trades.csv</a:t>
+            </a:r>
+          </a:p>
+          <a:p xmlns:a="http://schemas.openxmlformats.org/drawingml/2006/main">
+            <a:r>
+              <a:t>- C:/Users/Franc/OneDrive/Documents/Francis/Peltata Project/Time-Series-Modeling-Gen5/runs/research_workbench/literature_grounded/lit_mr_02_1_case_studies_20260729/visuals/mr02_case_2018_trade_timeline.png</a:t>
+            </a:r>
+          </a:p>
+        </p:txBody>
+      </p:sp>
+      <p:sp>
+        <p:nvSpPr>
+          <p:cNvPr id="4" name="Slide Number Placeholder 3"/>
+          <p:cNvSpPr>
+            <a:spLocks xmlns:a="http://schemas.openxmlformats.org/drawingml/2006/main" noGrp="1"/>
+          </p:cNvSpPr>
+          <p:nvPr>
+            <p:ph type="sldNum" idx="5"/>
+          </p:nvPr>
+        </p:nvSpPr>
+        <p:spPr/>
+        <p:txBody>
+          <a:bodyPr xmlns:a="http://schemas.openxmlformats.org/drawingml/2006/main"/>
+          <a:lstStyle xmlns:a="http://schemas.openxmlformats.org/drawingml/2006/main"/>
+          <a:p xmlns:a="http://schemas.openxmlformats.org/drawingml/2006/main"/>
+        </p:txBody>
+      </p:sp>
+    </p:spTree>
+  </p:cSld>
+  <p:clrMapOvr>
+    <a:masterClrMapping xmlns:a="http://schemas.openxmlformats.org/drawingml/2006/main"/>
+  </p:clrMapOvr>
+</p:notes>
+</file>
+
+<file path=ppt/notesSlides/notesSlide29.xml><?xml version="1.0" encoding="utf-8"?>
+<p:notes xmlns:p="http://schemas.openxmlformats.org/presentationml/2006/main">
+  <p:cSld>
+    <p:spTree>
+      <p:nvGrpSpPr>
+        <p:cNvPr id="1" name=""/>
+        <p:cNvGrpSpPr/>
+        <p:nvPr/>
+      </p:nvGrpSpPr>
+      <p:grpSpPr>
+        <a:xfrm xmlns:a="http://schemas.openxmlformats.org/drawingml/2006/main"/>
+      </p:grpSpPr>
+      <p:sp>
+        <p:nvSpPr>
+          <p:cNvPr id="2" name="Slide Image Placeholder 1"/>
+          <p:cNvSpPr>
+            <a:spLocks xmlns:a="http://schemas.openxmlformats.org/drawingml/2006/main" noGrp="1"/>
+          </p:cNvSpPr>
+          <p:nvPr>
+            <p:ph type="sldImg" idx="0"/>
+          </p:nvPr>
+        </p:nvSpPr>
+        <p:spPr/>
+      </p:sp>
+      <p:sp>
+        <p:nvSpPr>
+          <p:cNvPr id="3" name="Notes Placeholder 2"/>
+          <p:cNvSpPr>
+            <a:spLocks xmlns:a="http://schemas.openxmlformats.org/drawingml/2006/main" noGrp="1"/>
+          </p:cNvSpPr>
+          <p:nvPr>
+            <p:ph type="body" idx="1"/>
+          </p:nvPr>
+        </p:nvSpPr>
+        <p:spPr/>
+        <p:txBody>
+          <a:bodyPr xmlns:a="http://schemas.openxmlformats.org/drawingml/2006/main"/>
+          <a:lstStyle xmlns:a="http://schemas.openxmlformats.org/drawingml/2006/main"/>
+          <a:p xmlns:a="http://schemas.openxmlformats.org/drawingml/2006/main">
+            <a:r>
+              <a:t>The left panel shows cost drag for each completed trade. The right panel separates long- and short-spread outcomes by holding period. Costs reduced every trade, while winners remained present in both directions.</a:t>
+            </a:r>
+          </a:p>
+          <a:p xmlns:a="http://schemas.openxmlformats.org/drawingml/2006/main">
+            <a:r>
+              <a:t/>
+            </a:r>
+          </a:p>
+          <a:p xmlns:a="http://schemas.openxmlformats.org/drawingml/2006/main">
+            <a:r>
+              <a:t>[Sources]</a:t>
+            </a:r>
+          </a:p>
+          <a:p xmlns:a="http://schemas.openxmlformats.org/drawingml/2006/main">
+            <a:r>
+              <a:t>- C:/Users/Franc/OneDrive/Documents/Francis/Peltata Project/Time-Series-Modeling-Gen5/docs/GEN5_LIT_MR_02_1_CASE_STUDIES.md</a:t>
+            </a:r>
+          </a:p>
+          <a:p xmlns:a="http://schemas.openxmlformats.org/drawingml/2006/main">
+            <a:r>
+              <a:t>- C:/Users/Franc/OneDrive/Documents/Francis/Peltata Project/Time-Series-Modeling-Gen5/runs/research_workbench/literature_grounded/lit_mr_02_1_case_studies_20260729/mr02_case_2018_trades.csv</a:t>
+            </a:r>
+          </a:p>
+          <a:p xmlns:a="http://schemas.openxmlformats.org/drawingml/2006/main">
+            <a:r>
+              <a:t>- C:/Users/Franc/OneDrive/Documents/Francis/Peltata Project/Time-Series-Modeling-Gen5/runs/research_workbench/literature_grounded/lit_mr_02_1_case_studies_20260729/visuals/mr02_case_2018_trade_economics.png</a:t>
             </a:r>
           </a:p>
         </p:txBody>
@@ -2207,6 +2590,421 @@
           <a:p xmlns:a="http://schemas.openxmlformats.org/drawingml/2006/main">
             <a:r>
               <a:t>- C:/Users/Franc/OneDrive/Documents/Francis/Peltata Project/Time-Series-Modeling-Gen5/docs/GEN5_LIT_MR_02_1_PANEL_A_CONTRACT.md</a:t>
+            </a:r>
+          </a:p>
+        </p:txBody>
+      </p:sp>
+      <p:sp>
+        <p:nvSpPr>
+          <p:cNvPr id="4" name="Slide Number Placeholder 3"/>
+          <p:cNvSpPr>
+            <a:spLocks xmlns:a="http://schemas.openxmlformats.org/drawingml/2006/main" noGrp="1"/>
+          </p:cNvSpPr>
+          <p:nvPr>
+            <p:ph type="sldNum" idx="5"/>
+          </p:nvPr>
+        </p:nvSpPr>
+        <p:spPr/>
+        <p:txBody>
+          <a:bodyPr xmlns:a="http://schemas.openxmlformats.org/drawingml/2006/main"/>
+          <a:lstStyle xmlns:a="http://schemas.openxmlformats.org/drawingml/2006/main"/>
+          <a:p xmlns:a="http://schemas.openxmlformats.org/drawingml/2006/main"/>
+        </p:txBody>
+      </p:sp>
+    </p:spTree>
+  </p:cSld>
+  <p:clrMapOvr>
+    <a:masterClrMapping xmlns:a="http://schemas.openxmlformats.org/drawingml/2006/main"/>
+  </p:clrMapOvr>
+</p:notes>
+</file>
+
+<file path=ppt/notesSlides/notesSlide30.xml><?xml version="1.0" encoding="utf-8"?>
+<p:notes xmlns:p="http://schemas.openxmlformats.org/presentationml/2006/main">
+  <p:cSld>
+    <p:spTree>
+      <p:nvGrpSpPr>
+        <p:cNvPr id="1" name=""/>
+        <p:cNvGrpSpPr/>
+        <p:nvPr/>
+      </p:nvGrpSpPr>
+      <p:grpSpPr>
+        <a:xfrm xmlns:a="http://schemas.openxmlformats.org/drawingml/2006/main"/>
+      </p:grpSpPr>
+      <p:sp>
+        <p:nvSpPr>
+          <p:cNvPr id="2" name="Slide Image Placeholder 1"/>
+          <p:cNvSpPr>
+            <a:spLocks xmlns:a="http://schemas.openxmlformats.org/drawingml/2006/main" noGrp="1"/>
+          </p:cNvSpPr>
+          <p:nvPr>
+            <p:ph type="sldImg" idx="0"/>
+          </p:nvPr>
+        </p:nvSpPr>
+        <p:spPr/>
+      </p:sp>
+      <p:sp>
+        <p:nvSpPr>
+          <p:cNvPr id="3" name="Notes Placeholder 2"/>
+          <p:cNvSpPr>
+            <a:spLocks xmlns:a="http://schemas.openxmlformats.org/drawingml/2006/main" noGrp="1"/>
+          </p:cNvSpPr>
+          <p:nvPr>
+            <p:ph type="body" idx="1"/>
+          </p:nvPr>
+        </p:nvSpPr>
+        <p:spPr/>
+        <p:txBody>
+          <a:bodyPr xmlns:a="http://schemas.openxmlformats.org/drawingml/2006/main"/>
+          <a:lstStyle xmlns:a="http://schemas.openxmlformats.org/drawingml/2006/main"/>
+          <a:p xmlns:a="http://schemas.openxmlformats.org/drawingml/2006/main">
+            <a:r>
+              <a:t>This section reproduces the exact interval printed in Chan's Example 3.2 using quarantined Yahoo adjusted daily bars. The bars are reference evidence only and do not alter the canonical Alpaca-only Gen5 provider contract.</a:t>
+            </a:r>
+          </a:p>
+          <a:p xmlns:a="http://schemas.openxmlformats.org/drawingml/2006/main">
+            <a:r>
+              <a:t/>
+            </a:r>
+          </a:p>
+          <a:p xmlns:a="http://schemas.openxmlformats.org/drawingml/2006/main">
+            <a:r>
+              <a:t>[Sources]</a:t>
+            </a:r>
+          </a:p>
+          <a:p xmlns:a="http://schemas.openxmlformats.org/drawingml/2006/main">
+            <a:r>
+              <a:t>- C:/Users/Franc/OneDrive/Documents/Francis/Trading Literature/Algorithmic Trading - Winning Strategies and Their Rationale 2013.pdf — printed pages 71–72; PDF pages 89–90</a:t>
+            </a:r>
+          </a:p>
+          <a:p xmlns:a="http://schemas.openxmlformats.org/drawingml/2006/main">
+            <a:r>
+              <a:t>- C:/Users/Franc/OneDrive/Documents/Francis/Peltata Project/Time-Series-Modeling-Gen5/docs/GEN5_LITERATURE_SOURCE_LEDGER.md</a:t>
+            </a:r>
+          </a:p>
+          <a:p xmlns:a="http://schemas.openxmlformats.org/drawingml/2006/main">
+            <a:r>
+              <a:t>- C:/Users/Franc/OneDrive/Documents/Francis/Peltata Project/Time-Series-Modeling-Gen5/runs/research_workbench/literature_grounded/lit_mr_02_1_case_studies_20260729/mr02_source_reference_audit.csv</a:t>
+            </a:r>
+          </a:p>
+          <a:p xmlns:a="http://schemas.openxmlformats.org/drawingml/2006/main">
+            <a:r>
+              <a:t>- C:/Users/Franc/OneDrive/Documents/Francis/Peltata Project/Time-Series-Modeling-Gen5/runs/research_workbench/literature_grounded/lit_mr_02_1_case_studies_20260729/mr02_source_reference_urls.csv</a:t>
+            </a:r>
+          </a:p>
+        </p:txBody>
+      </p:sp>
+      <p:sp>
+        <p:nvSpPr>
+          <p:cNvPr id="4" name="Slide Number Placeholder 3"/>
+          <p:cNvSpPr>
+            <a:spLocks xmlns:a="http://schemas.openxmlformats.org/drawingml/2006/main" noGrp="1"/>
+          </p:cNvSpPr>
+          <p:nvPr>
+            <p:ph type="sldNum" idx="5"/>
+          </p:nvPr>
+        </p:nvSpPr>
+        <p:spPr/>
+        <p:txBody>
+          <a:bodyPr xmlns:a="http://schemas.openxmlformats.org/drawingml/2006/main"/>
+          <a:lstStyle xmlns:a="http://schemas.openxmlformats.org/drawingml/2006/main"/>
+          <a:p xmlns:a="http://schemas.openxmlformats.org/drawingml/2006/main"/>
+        </p:txBody>
+      </p:sp>
+    </p:spTree>
+  </p:cSld>
+  <p:clrMapOvr>
+    <a:masterClrMapping xmlns:a="http://schemas.openxmlformats.org/drawingml/2006/main"/>
+  </p:clrMapOvr>
+</p:notes>
+</file>
+
+<file path=ppt/notesSlides/notesSlide31.xml><?xml version="1.0" encoding="utf-8"?>
+<p:notes xmlns:p="http://schemas.openxmlformats.org/presentationml/2006/main">
+  <p:cSld>
+    <p:spTree>
+      <p:nvGrpSpPr>
+        <p:cNvPr id="1" name=""/>
+        <p:cNvGrpSpPr/>
+        <p:nvPr/>
+      </p:nvGrpSpPr>
+      <p:grpSpPr>
+        <a:xfrm xmlns:a="http://schemas.openxmlformats.org/drawingml/2006/main"/>
+      </p:grpSpPr>
+      <p:sp>
+        <p:nvSpPr>
+          <p:cNvPr id="2" name="Slide Image Placeholder 1"/>
+          <p:cNvSpPr>
+            <a:spLocks xmlns:a="http://schemas.openxmlformats.org/drawingml/2006/main" noGrp="1"/>
+          </p:cNvSpPr>
+          <p:nvPr>
+            <p:ph type="sldImg" idx="0"/>
+          </p:nvPr>
+        </p:nvSpPr>
+        <p:spPr/>
+      </p:sp>
+      <p:sp>
+        <p:nvSpPr>
+          <p:cNvPr id="3" name="Notes Placeholder 2"/>
+          <p:cNvSpPr>
+            <a:spLocks xmlns:a="http://schemas.openxmlformats.org/drawingml/2006/main" noGrp="1"/>
+          </p:cNvSpPr>
+          <p:nvPr>
+            <p:ph type="body" idx="1"/>
+          </p:nvPr>
+        </p:nvSpPr>
+        <p:spPr/>
+        <p:txBody>
+          <a:bodyPr xmlns:a="http://schemas.openxmlformats.org/drawingml/2006/main"/>
+          <a:lstStyle xmlns:a="http://schemas.openxmlformats.org/drawingml/2006/main"/>
+          <a:p xmlns:a="http://schemas.openxmlformats.org/drawingml/2006/main">
+            <a:r>
+              <a:t>The blue line approximates the book's lagged-position, close-to-close, no-cost accounting. The red line applies the same signal mechanism with Gen5 next-open timing and five basis points per one-way weight change. Both accounts remain positive, though their paths and drawdowns differ.</a:t>
+            </a:r>
+          </a:p>
+          <a:p xmlns:a="http://schemas.openxmlformats.org/drawingml/2006/main">
+            <a:r>
+              <a:t/>
+            </a:r>
+          </a:p>
+          <a:p xmlns:a="http://schemas.openxmlformats.org/drawingml/2006/main">
+            <a:r>
+              <a:t>[Sources]</a:t>
+            </a:r>
+          </a:p>
+          <a:p xmlns:a="http://schemas.openxmlformats.org/drawingml/2006/main">
+            <a:r>
+              <a:t>- C:/Users/Franc/OneDrive/Documents/Francis/Trading Literature/Algorithmic Trading - Winning Strategies and Their Rationale 2013.pdf — printed pages 68 and 71–72; PDF pages 86 and 89–90</a:t>
+            </a:r>
+          </a:p>
+          <a:p xmlns:a="http://schemas.openxmlformats.org/drawingml/2006/main">
+            <a:r>
+              <a:t>- C:/Users/Franc/OneDrive/Documents/Francis/Peltata Project/Time-Series-Modeling-Gen5/docs/GEN5_LIT_MR_02_1_CASE_STUDIES.md</a:t>
+            </a:r>
+          </a:p>
+          <a:p xmlns:a="http://schemas.openxmlformats.org/drawingml/2006/main">
+            <a:r>
+              <a:t>- C:/Users/Franc/OneDrive/Documents/Francis/Peltata Project/Time-Series-Modeling-Gen5/runs/research_workbench/literature_grounded/lit_mr_02_1_case_studies_20260729/mr02_source_period_book_style_replay.csv</a:t>
+            </a:r>
+          </a:p>
+          <a:p xmlns:a="http://schemas.openxmlformats.org/drawingml/2006/main">
+            <a:r>
+              <a:t>- C:/Users/Franc/OneDrive/Documents/Francis/Peltata Project/Time-Series-Modeling-Gen5/runs/research_workbench/literature_grounded/lit_mr_02_1_case_studies_20260729/mr02_source_period_gen5_replay.csv</a:t>
+            </a:r>
+          </a:p>
+          <a:p xmlns:a="http://schemas.openxmlformats.org/drawingml/2006/main">
+            <a:r>
+              <a:t>- C:/Users/Franc/OneDrive/Documents/Francis/Peltata Project/Time-Series-Modeling-Gen5/runs/research_workbench/literature_grounded/lit_mr_02_1_case_studies_20260729/visuals/mr02_source_period_reproduction.png</a:t>
+            </a:r>
+          </a:p>
+        </p:txBody>
+      </p:sp>
+      <p:sp>
+        <p:nvSpPr>
+          <p:cNvPr id="4" name="Slide Number Placeholder 3"/>
+          <p:cNvSpPr>
+            <a:spLocks xmlns:a="http://schemas.openxmlformats.org/drawingml/2006/main" noGrp="1"/>
+          </p:cNvSpPr>
+          <p:nvPr>
+            <p:ph type="sldNum" idx="5"/>
+          </p:nvPr>
+        </p:nvSpPr>
+        <p:spPr/>
+        <p:txBody>
+          <a:bodyPr xmlns:a="http://schemas.openxmlformats.org/drawingml/2006/main"/>
+          <a:lstStyle xmlns:a="http://schemas.openxmlformats.org/drawingml/2006/main"/>
+          <a:p xmlns:a="http://schemas.openxmlformats.org/drawingml/2006/main"/>
+        </p:txBody>
+      </p:sp>
+    </p:spTree>
+  </p:cSld>
+  <p:clrMapOvr>
+    <a:masterClrMapping xmlns:a="http://schemas.openxmlformats.org/drawingml/2006/main"/>
+  </p:clrMapOvr>
+</p:notes>
+</file>
+
+<file path=ppt/notesSlides/notesSlide32.xml><?xml version="1.0" encoding="utf-8"?>
+<p:notes xmlns:p="http://schemas.openxmlformats.org/presentationml/2006/main">
+  <p:cSld>
+    <p:spTree>
+      <p:nvGrpSpPr>
+        <p:cNvPr id="1" name=""/>
+        <p:cNvGrpSpPr/>
+        <p:nvPr/>
+      </p:nvGrpSpPr>
+      <p:grpSpPr>
+        <a:xfrm xmlns:a="http://schemas.openxmlformats.org/drawingml/2006/main"/>
+      </p:grpSpPr>
+      <p:sp>
+        <p:nvSpPr>
+          <p:cNvPr id="2" name="Slide Image Placeholder 1"/>
+          <p:cNvSpPr>
+            <a:spLocks xmlns:a="http://schemas.openxmlformats.org/drawingml/2006/main" noGrp="1"/>
+          </p:cNvSpPr>
+          <p:nvPr>
+            <p:ph type="sldImg" idx="0"/>
+          </p:nvPr>
+        </p:nvSpPr>
+        <p:spPr/>
+      </p:sp>
+      <p:sp>
+        <p:nvSpPr>
+          <p:cNvPr id="3" name="Notes Placeholder 2"/>
+          <p:cNvSpPr>
+            <a:spLocks xmlns:a="http://schemas.openxmlformats.org/drawingml/2006/main" noGrp="1"/>
+          </p:cNvSpPr>
+          <p:nvPr>
+            <p:ph type="body" idx="1"/>
+          </p:nvPr>
+        </p:nvSpPr>
+        <p:spPr/>
+        <p:txBody>
+          <a:bodyPr xmlns:a="http://schemas.openxmlformats.org/drawingml/2006/main"/>
+          <a:lstStyle xmlns:a="http://schemas.openxmlformats.org/drawingml/2006/main"/>
+          <a:p xmlns:a="http://schemas.openxmlformats.org/drawingml/2006/main">
+            <a:r>
+              <a:t>Chan reports 17.8% APR and 0.96 Sharpe. Using current Yahoo-adjusted bars, the book-style account reaches 15.07% APR and 0.845 Sharpe; the Gen5 translation reaches 12.93% APR and 0.933 Sharpe. We retain the discrepancy because the original data vintage and preprocessing are not available.</a:t>
+            </a:r>
+          </a:p>
+          <a:p xmlns:a="http://schemas.openxmlformats.org/drawingml/2006/main">
+            <a:r>
+              <a:t/>
+            </a:r>
+          </a:p>
+          <a:p xmlns:a="http://schemas.openxmlformats.org/drawingml/2006/main">
+            <a:r>
+              <a:t>[Sources]</a:t>
+            </a:r>
+          </a:p>
+          <a:p xmlns:a="http://schemas.openxmlformats.org/drawingml/2006/main">
+            <a:r>
+              <a:t>- C:/Users/Franc/OneDrive/Documents/Francis/Trading Literature/Algorithmic Trading - Winning Strategies and Their Rationale 2013.pdf — printed pages 71–72; PDF pages 89–90</a:t>
+            </a:r>
+          </a:p>
+          <a:p xmlns:a="http://schemas.openxmlformats.org/drawingml/2006/main">
+            <a:r>
+              <a:t>- C:/Users/Franc/OneDrive/Documents/Francis/Peltata Project/Time-Series-Modeling-Gen5/docs/GEN5_LIT_MR_02_1_CASE_STUDIES.md</a:t>
+            </a:r>
+          </a:p>
+          <a:p xmlns:a="http://schemas.openxmlformats.org/drawingml/2006/main">
+            <a:r>
+              <a:t>- C:/Users/Franc/OneDrive/Documents/Francis/Peltata Project/Time-Series-Modeling-Gen5/runs/research_workbench/literature_grounded/lit_mr_02_1_case_studies_20260729/mr02_source_period_comparison.csv</a:t>
+            </a:r>
+          </a:p>
+          <a:p xmlns:a="http://schemas.openxmlformats.org/drawingml/2006/main">
+            <a:r>
+              <a:t>- C:/Users/Franc/OneDrive/Documents/Francis/Peltata Project/Time-Series-Modeling-Gen5/runs/research_workbench/literature_grounded/lit_mr_02_1_case_studies_20260729/mr02_source_reference_audit.csv</a:t>
+            </a:r>
+          </a:p>
+          <a:p xmlns:a="http://schemas.openxmlformats.org/drawingml/2006/main">
+            <a:r>
+              <a:t>- C:/Users/Franc/OneDrive/Documents/Francis/Peltata Project/Time-Series-Modeling-Gen5/runs/research_workbench/literature_grounded/lit_mr_02_1_case_studies_20260729/visuals/mr02_source_period_signal_tape.png</a:t>
+            </a:r>
+          </a:p>
+        </p:txBody>
+      </p:sp>
+      <p:sp>
+        <p:nvSpPr>
+          <p:cNvPr id="4" name="Slide Number Placeholder 3"/>
+          <p:cNvSpPr>
+            <a:spLocks xmlns:a="http://schemas.openxmlformats.org/drawingml/2006/main" noGrp="1"/>
+          </p:cNvSpPr>
+          <p:nvPr>
+            <p:ph type="sldNum" idx="5"/>
+          </p:nvPr>
+        </p:nvSpPr>
+        <p:spPr/>
+        <p:txBody>
+          <a:bodyPr xmlns:a="http://schemas.openxmlformats.org/drawingml/2006/main"/>
+          <a:lstStyle xmlns:a="http://schemas.openxmlformats.org/drawingml/2006/main"/>
+          <a:p xmlns:a="http://schemas.openxmlformats.org/drawingml/2006/main"/>
+        </p:txBody>
+      </p:sp>
+    </p:spTree>
+  </p:cSld>
+  <p:clrMapOvr>
+    <a:masterClrMapping xmlns:a="http://schemas.openxmlformats.org/drawingml/2006/main"/>
+  </p:clrMapOvr>
+</p:notes>
+</file>
+
+<file path=ppt/notesSlides/notesSlide33.xml><?xml version="1.0" encoding="utf-8"?>
+<p:notes xmlns:p="http://schemas.openxmlformats.org/presentationml/2006/main">
+  <p:cSld>
+    <p:spTree>
+      <p:nvGrpSpPr>
+        <p:cNvPr id="1" name=""/>
+        <p:cNvGrpSpPr/>
+        <p:nvPr/>
+      </p:nvGrpSpPr>
+      <p:grpSpPr>
+        <a:xfrm xmlns:a="http://schemas.openxmlformats.org/drawingml/2006/main"/>
+      </p:grpSpPr>
+      <p:sp>
+        <p:nvSpPr>
+          <p:cNvPr id="2" name="Slide Image Placeholder 1"/>
+          <p:cNvSpPr>
+            <a:spLocks xmlns:a="http://schemas.openxmlformats.org/drawingml/2006/main" noGrp="1"/>
+          </p:cNvSpPr>
+          <p:nvPr>
+            <p:ph type="sldImg" idx="0"/>
+          </p:nvPr>
+        </p:nvSpPr>
+        <p:spPr/>
+      </p:sp>
+      <p:sp>
+        <p:nvSpPr>
+          <p:cNvPr id="3" name="Notes Placeholder 2"/>
+          <p:cNvSpPr>
+            <a:spLocks xmlns:a="http://schemas.openxmlformats.org/drawingml/2006/main" noGrp="1"/>
+          </p:cNvSpPr>
+          <p:nvPr>
+            <p:ph type="body" idx="1"/>
+          </p:nvPr>
+        </p:nvSpPr>
+        <p:spPr/>
+        <p:txBody>
+          <a:bodyPr xmlns:a="http://schemas.openxmlformats.org/drawingml/2006/main"/>
+          <a:lstStyle xmlns:a="http://schemas.openxmlformats.org/drawingml/2006/main"/>
+          <a:p xmlns:a="http://schemas.openxmlformats.org/drawingml/2006/main">
+            <a:r>
+              <a:t>The source-period reproduction and the 2018 case study establish that the formula can produce a coherent trading result in real historical regimes. They do not create a prospective selection rule, do not clear the predeclared eight-gate modern TRAIN contract, and do not authorize retuning.</a:t>
+            </a:r>
+          </a:p>
+          <a:p xmlns:a="http://schemas.openxmlformats.org/drawingml/2006/main">
+            <a:r>
+              <a:t/>
+            </a:r>
+          </a:p>
+          <a:p xmlns:a="http://schemas.openxmlformats.org/drawingml/2006/main">
+            <a:r>
+              <a:t>[Sources]</a:t>
+            </a:r>
+          </a:p>
+          <a:p xmlns:a="http://schemas.openxmlformats.org/drawingml/2006/main">
+            <a:r>
+              <a:t>- C:/Users/Franc/OneDrive/Documents/Francis/Peltata Project/Time-Series-Modeling-Gen5/docs/GEN5_LIT_MR_02_1_CASE_STUDIES.md</a:t>
+            </a:r>
+          </a:p>
+          <a:p xmlns:a="http://schemas.openxmlformats.org/drawingml/2006/main">
+            <a:r>
+              <a:t>- C:/Users/Franc/OneDrive/Documents/Francis/Peltata Project/Time-Series-Modeling-Gen5/runs/research_workbench/literature_grounded/lit_mr_02_1_case_studies_20260729/mr02_case_studies_report.md</a:t>
+            </a:r>
+          </a:p>
+          <a:p xmlns:a="http://schemas.openxmlformats.org/drawingml/2006/main">
+            <a:r>
+              <a:t>- C:/Users/Franc/OneDrive/Documents/Francis/Peltata Project/Time-Series-Modeling-Gen5/runs/research_workbench/literature_grounded/lit_mr_02_1_case_studies_20260729/mr02_case_2018_summary.csv</a:t>
+            </a:r>
+          </a:p>
+          <a:p xmlns:a="http://schemas.openxmlformats.org/drawingml/2006/main">
+            <a:r>
+              <a:t>- C:/Users/Franc/OneDrive/Documents/Francis/Peltata Project/Time-Series-Modeling-Gen5/runs/research_workbench/literature_grounded/lit_mr_02_1_case_studies_20260729/mr02_source_period_comparison.csv</a:t>
+            </a:r>
+          </a:p>
+          <a:p xmlns:a="http://schemas.openxmlformats.org/drawingml/2006/main">
+            <a:r>
+              <a:t>- C:/Users/Franc/OneDrive/Documents/Francis/Peltata Project/Time-Series-Modeling-Gen5/docs/GEN5_LIT_MR_02_1_ADAPTIVE_SPREAD_BOLLINGER_POC_CONTRACT.md</a:t>
             </a:r>
           </a:p>
         </p:txBody>
@@ -2829,7 +3627,7 @@
   </p:cSld>
   <p:clrMap bg1="lt1" tx1="dk1" bg2="lt2" tx2="dk2" accent1="accent1" accent2="accent2" accent3="accent3" accent4="accent4" accent5="accent5" accent6="accent6" hlink="hlink" folHlink="folHlink"/>
   <p:sldLayoutIdLst>
-    <p:sldLayoutId xmlns:r="http://schemas.openxmlformats.org/officeDocument/2006/relationships" id="2147483649" r:id="R28a5830d6cdd4a2e"/>
+    <p:sldLayoutId xmlns:r="http://schemas.openxmlformats.org/officeDocument/2006/relationships" id="2147483649" r:id="Ra1a0374a32c04fa0"/>
   </p:sldLayoutIdLst>
   <p:txStyles>
     <p:titleStyle>
@@ -4241,7 +5039,7 @@
           <p:nvPr/>
         </p:nvPicPr>
         <p:blipFill>
-          <a:blip xmlns:r="http://schemas.openxmlformats.org/officeDocument/2006/relationships" xmlns:a="http://schemas.openxmlformats.org/drawingml/2006/main" r:embed="R1ad7c4cfa58b49e3"/>
+          <a:blip xmlns:r="http://schemas.openxmlformats.org/officeDocument/2006/relationships" xmlns:a="http://schemas.openxmlformats.org/drawingml/2006/main" r:embed="R71dcec5ac9874291"/>
           <a:stretch xmlns:a="http://schemas.openxmlformats.org/drawingml/2006/main"/>
         </p:blipFill>
         <p:spPr>
@@ -4665,7 +5463,7 @@
           <p:nvPr/>
         </p:nvPicPr>
         <p:blipFill>
-          <a:blip xmlns:r="http://schemas.openxmlformats.org/officeDocument/2006/relationships" xmlns:a="http://schemas.openxmlformats.org/drawingml/2006/main" r:embed="Rbd98b92e54b64f9f"/>
+          <a:blip xmlns:r="http://schemas.openxmlformats.org/officeDocument/2006/relationships" xmlns:a="http://schemas.openxmlformats.org/drawingml/2006/main" r:embed="R13899be0952b4bf4"/>
           <a:stretch xmlns:a="http://schemas.openxmlformats.org/drawingml/2006/main"/>
         </p:blipFill>
         <p:spPr>
@@ -5089,7 +5887,7 @@
           <p:nvPr/>
         </p:nvPicPr>
         <p:blipFill>
-          <a:blip xmlns:r="http://schemas.openxmlformats.org/officeDocument/2006/relationships" xmlns:a="http://schemas.openxmlformats.org/drawingml/2006/main" r:embed="Rf6b1d87a221f4302"/>
+          <a:blip xmlns:r="http://schemas.openxmlformats.org/officeDocument/2006/relationships" xmlns:a="http://schemas.openxmlformats.org/drawingml/2006/main" r:embed="R9c4e1140669747a5"/>
           <a:stretch xmlns:a="http://schemas.openxmlformats.org/drawingml/2006/main"/>
         </p:blipFill>
         <p:spPr>
@@ -5513,7 +6311,7 @@
           <p:nvPr/>
         </p:nvPicPr>
         <p:blipFill>
-          <a:blip xmlns:r="http://schemas.openxmlformats.org/officeDocument/2006/relationships" xmlns:a="http://schemas.openxmlformats.org/drawingml/2006/main" r:embed="R53b7e79685264104"/>
+          <a:blip xmlns:r="http://schemas.openxmlformats.org/officeDocument/2006/relationships" xmlns:a="http://schemas.openxmlformats.org/drawingml/2006/main" r:embed="R45bfa71339624c40"/>
           <a:stretch xmlns:a="http://schemas.openxmlformats.org/drawingml/2006/main"/>
         </p:blipFill>
         <p:spPr>
@@ -5731,7 +6529,7 @@
           <p:nvPr/>
         </p:nvPicPr>
         <p:blipFill>
-          <a:blip xmlns:r="http://schemas.openxmlformats.org/officeDocument/2006/relationships" xmlns:a="http://schemas.openxmlformats.org/drawingml/2006/main" r:embed="R2edcd91e42f14b3b"/>
+          <a:blip xmlns:r="http://schemas.openxmlformats.org/officeDocument/2006/relationships" xmlns:a="http://schemas.openxmlformats.org/drawingml/2006/main" r:embed="R45e6611d26dc46bf"/>
           <a:stretch xmlns:a="http://schemas.openxmlformats.org/drawingml/2006/main"/>
         </p:blipFill>
         <p:spPr>
@@ -7203,7 +8001,7 @@
           <p:nvPr/>
         </p:nvPicPr>
         <p:blipFill>
-          <a:blip xmlns:r="http://schemas.openxmlformats.org/officeDocument/2006/relationships" xmlns:a="http://schemas.openxmlformats.org/drawingml/2006/main" r:embed="R28383a6e6797451f"/>
+          <a:blip xmlns:r="http://schemas.openxmlformats.org/officeDocument/2006/relationships" xmlns:a="http://schemas.openxmlformats.org/drawingml/2006/main" r:embed="R5c81fbcb86254369"/>
           <a:stretch xmlns:a="http://schemas.openxmlformats.org/drawingml/2006/main"/>
         </p:blipFill>
         <p:spPr>
@@ -7258,7 +8056,7 @@
           <p:nvPr/>
         </p:nvPicPr>
         <p:blipFill>
-          <a:blip xmlns:r="http://schemas.openxmlformats.org/officeDocument/2006/relationships" xmlns:a="http://schemas.openxmlformats.org/drawingml/2006/main" r:embed="R04a79aa9b18e4fe6"/>
+          <a:blip xmlns:r="http://schemas.openxmlformats.org/officeDocument/2006/relationships" xmlns:a="http://schemas.openxmlformats.org/drawingml/2006/main" r:embed="R3d69b906cf634785"/>
           <a:stretch xmlns:a="http://schemas.openxmlformats.org/drawingml/2006/main"/>
         </p:blipFill>
         <p:spPr>
@@ -7475,7 +8273,7 @@
           <p:nvPr/>
         </p:nvPicPr>
         <p:blipFill>
-          <a:blip xmlns:r="http://schemas.openxmlformats.org/officeDocument/2006/relationships" xmlns:a="http://schemas.openxmlformats.org/drawingml/2006/main" r:embed="R9cca271d023748ae"/>
+          <a:blip xmlns:r="http://schemas.openxmlformats.org/officeDocument/2006/relationships" xmlns:a="http://schemas.openxmlformats.org/drawingml/2006/main" r:embed="Ra5af1645de194588"/>
           <a:stretch xmlns:a="http://schemas.openxmlformats.org/drawingml/2006/main"/>
         </p:blipFill>
         <p:spPr>
@@ -7530,7 +8328,7 @@
           <p:nvPr/>
         </p:nvPicPr>
         <p:blipFill>
-          <a:blip xmlns:r="http://schemas.openxmlformats.org/officeDocument/2006/relationships" xmlns:a="http://schemas.openxmlformats.org/drawingml/2006/main" r:embed="R9bee013a90d94eca"/>
+          <a:blip xmlns:r="http://schemas.openxmlformats.org/officeDocument/2006/relationships" xmlns:a="http://schemas.openxmlformats.org/drawingml/2006/main" r:embed="Rcc6a4591a7ca41b5"/>
           <a:stretch xmlns:a="http://schemas.openxmlformats.org/drawingml/2006/main"/>
         </p:blipFill>
         <p:spPr>
@@ -9519,14 +10317,14 @@
       </p:sp>
       <p:pic>
         <p:nvPicPr>
-          <p:cNvPr id="27" name=""/>
+          <p:cNvPr id="29" name=""/>
           <p:cNvPicPr>
             <a:picLocks xmlns:a="http://schemas.openxmlformats.org/drawingml/2006/main" noChangeAspect="1"/>
           </p:cNvPicPr>
           <p:nvPr/>
         </p:nvPicPr>
         <p:blipFill>
-          <a:blip xmlns:r="http://schemas.openxmlformats.org/officeDocument/2006/relationships" xmlns:a="http://schemas.openxmlformats.org/drawingml/2006/main" r:embed="R0802a2ace50e47cd"/>
+          <a:blip xmlns:r="http://schemas.openxmlformats.org/officeDocument/2006/relationships" xmlns:a="http://schemas.openxmlformats.org/drawingml/2006/main" r:embed="R8df3f82992d745ee"/>
           <a:stretch xmlns:a="http://schemas.openxmlformats.org/drawingml/2006/main"/>
         </p:blipFill>
         <p:spPr>
@@ -9574,14 +10372,14 @@
       </p:sp>
       <p:pic>
         <p:nvPicPr>
-          <p:cNvPr id="29" name=""/>
+          <p:cNvPr id="31" name=""/>
           <p:cNvPicPr>
             <a:picLocks xmlns:a="http://schemas.openxmlformats.org/drawingml/2006/main" noChangeAspect="1"/>
           </p:cNvPicPr>
           <p:nvPr/>
         </p:nvPicPr>
         <p:blipFill>
-          <a:blip xmlns:r="http://schemas.openxmlformats.org/officeDocument/2006/relationships" xmlns:a="http://schemas.openxmlformats.org/drawingml/2006/main" r:embed="Ra121087fd00e459a"/>
+          <a:blip xmlns:r="http://schemas.openxmlformats.org/officeDocument/2006/relationships" xmlns:a="http://schemas.openxmlformats.org/drawingml/2006/main" r:embed="Rac8e83e25b114709"/>
           <a:stretch xmlns:a="http://schemas.openxmlformats.org/drawingml/2006/main"/>
         </p:blipFill>
         <p:spPr>
@@ -9629,14 +10427,14 @@
       </p:sp>
       <p:pic>
         <p:nvPicPr>
-          <p:cNvPr id="31" name=""/>
+          <p:cNvPr id="33" name=""/>
           <p:cNvPicPr>
             <a:picLocks xmlns:a="http://schemas.openxmlformats.org/drawingml/2006/main" noChangeAspect="1"/>
           </p:cNvPicPr>
           <p:nvPr/>
         </p:nvPicPr>
         <p:blipFill>
-          <a:blip xmlns:r="http://schemas.openxmlformats.org/officeDocument/2006/relationships" xmlns:a="http://schemas.openxmlformats.org/drawingml/2006/main" r:embed="R027c94fab89a4285"/>
+          <a:blip xmlns:r="http://schemas.openxmlformats.org/officeDocument/2006/relationships" xmlns:a="http://schemas.openxmlformats.org/drawingml/2006/main" r:embed="R05f294c1ea664919"/>
           <a:stretch xmlns:a="http://schemas.openxmlformats.org/drawingml/2006/main"/>
         </p:blipFill>
         <p:spPr>
@@ -9846,14 +10644,14 @@
       </p:sp>
       <p:pic>
         <p:nvPicPr>
-          <p:cNvPr id="17" name=""/>
+          <p:cNvPr id="19" name=""/>
           <p:cNvPicPr>
             <a:picLocks xmlns:a="http://schemas.openxmlformats.org/drawingml/2006/main" noChangeAspect="1"/>
           </p:cNvPicPr>
           <p:nvPr/>
         </p:nvPicPr>
         <p:blipFill>
-          <a:blip xmlns:r="http://schemas.openxmlformats.org/officeDocument/2006/relationships" xmlns:a="http://schemas.openxmlformats.org/drawingml/2006/main" r:embed="Rf36add23a4e54eba"/>
+          <a:blip xmlns:r="http://schemas.openxmlformats.org/officeDocument/2006/relationships" xmlns:a="http://schemas.openxmlformats.org/drawingml/2006/main" r:embed="Raef4fd53fe314a8b"/>
           <a:stretch xmlns:a="http://schemas.openxmlformats.org/drawingml/2006/main"/>
         </p:blipFill>
         <p:spPr>
@@ -9901,14 +10699,14 @@
       </p:sp>
       <p:pic>
         <p:nvPicPr>
-          <p:cNvPr id="19" name=""/>
+          <p:cNvPr id="21" name=""/>
           <p:cNvPicPr>
             <a:picLocks xmlns:a="http://schemas.openxmlformats.org/drawingml/2006/main" noChangeAspect="1"/>
           </p:cNvPicPr>
           <p:nvPr/>
         </p:nvPicPr>
         <p:blipFill>
-          <a:blip xmlns:r="http://schemas.openxmlformats.org/officeDocument/2006/relationships" xmlns:a="http://schemas.openxmlformats.org/drawingml/2006/main" r:embed="R26ab10a9a5d04009"/>
+          <a:blip xmlns:r="http://schemas.openxmlformats.org/officeDocument/2006/relationships" xmlns:a="http://schemas.openxmlformats.org/drawingml/2006/main" r:embed="R97365f103a734819"/>
           <a:stretch xmlns:a="http://schemas.openxmlformats.org/drawingml/2006/main"/>
         </p:blipFill>
         <p:spPr>
@@ -9956,14 +10754,14 @@
       </p:sp>
       <p:pic>
         <p:nvPicPr>
-          <p:cNvPr id="21" name=""/>
+          <p:cNvPr id="23" name=""/>
           <p:cNvPicPr>
             <a:picLocks xmlns:a="http://schemas.openxmlformats.org/drawingml/2006/main" noChangeAspect="1"/>
           </p:cNvPicPr>
           <p:nvPr/>
         </p:nvPicPr>
         <p:blipFill>
-          <a:blip xmlns:r="http://schemas.openxmlformats.org/officeDocument/2006/relationships" xmlns:a="http://schemas.openxmlformats.org/drawingml/2006/main" r:embed="R937bd660620541d7"/>
+          <a:blip xmlns:r="http://schemas.openxmlformats.org/officeDocument/2006/relationships" xmlns:a="http://schemas.openxmlformats.org/drawingml/2006/main" r:embed="Reaf46b9b65a8475e"/>
           <a:stretch xmlns:a="http://schemas.openxmlformats.org/drawingml/2006/main"/>
         </p:blipFill>
         <p:spPr>
@@ -10527,7 +11325,7 @@
           <p:cNvPr id="4" name="cover-headline">
             <a:extLst xmlns:a="http://schemas.openxmlformats.org/drawingml/2006/main">
               <a:ext uri="{FF2B5EF4-FFF2-40B4-BE49-F238E27FC236}">
-                <a16:creationId xmlns:a16="http://schemas.microsoft.com/office/drawing/2014/main" id="{E9F43BB9-4202-4A42-9916-7A06678333BD}"/>
+                <a16:creationId xmlns:a16="http://schemas.microsoft.com/office/drawing/2014/main" id="{DA6318FA-2F99-4DF9-A744-06350F910925}"/>
               </a:ext>
             </a:extLst>
           </p:cNvPr>
@@ -10563,8 +11361,23 @@
               </a:defRPr>
             </a:pPr>
             <a:r>
-              <a:t>Breadth strengthened the STOP.
-Do not rescue the rule.</a:t>
+              <a:t>2018:</a:t>
+            </a:r>
+          </a:p>
+          <a:p xmlns:a="http://schemas.openxmlformats.org/drawingml/2006/main">
+            <a:pPr algn="l">
+              <a:buNone/>
+              <a:defRPr sz="5700">
+                <a:solidFill>
+                  <a:srgbClr val="000000"/>
+                </a:solidFill>
+                <a:latin typeface="Helvetica Neue"/>
+                <a:ea typeface="Helvetica Neue"/>
+                <a:cs typeface="Helvetica Neue"/>
+              </a:defRPr>
+            </a:pPr>
+            <a:r>
+              <a:t>the mechanism works</a:t>
             </a:r>
           </a:p>
         </p:txBody>
@@ -10574,7 +11387,7 @@
           <p:cNvPr id="2" name="cover-subtitle">
             <a:extLst xmlns:a="http://schemas.openxmlformats.org/drawingml/2006/main">
               <a:ext uri="{FF2B5EF4-FFF2-40B4-BE49-F238E27FC236}">
-                <a16:creationId xmlns:a16="http://schemas.microsoft.com/office/drawing/2014/main" id="{F6F90063-BA30-438B-9FD3-13AA22719785}"/>
+                <a16:creationId xmlns:a16="http://schemas.microsoft.com/office/drawing/2014/main" id="{E169DF7F-9A3A-4AE2-8055-4ED350724D47}"/>
               </a:ext>
             </a:extLst>
           </p:cNvPr>
@@ -10610,7 +11423,7 @@
               </a:defRPr>
             </a:pPr>
             <a:r>
-              <a:t>Keep LIT-MR-02.1 as a reusable hypothesis-testing template and falsification result. Any new window, transform, hedge model, or exit rule must be frozen as a substantive new variant.</a:t>
+              <a:t>The exact frozen USO-GLD rule produced a positive, cost-aware year. This is a retrospective case study—not a reversal of the five-year STOP.</a:t>
             </a:r>
           </a:p>
         </p:txBody>
@@ -10620,7 +11433,7 @@
           <p:cNvPr id="3" name="cover-eyebrow">
             <a:extLst xmlns:a="http://schemas.openxmlformats.org/drawingml/2006/main">
               <a:ext uri="{FF2B5EF4-FFF2-40B4-BE49-F238E27FC236}">
-                <a16:creationId xmlns:a16="http://schemas.microsoft.com/office/drawing/2014/main" id="{45129715-75DE-4D50-B44D-3AFE3EBA3F0E}"/>
+                <a16:creationId xmlns:a16="http://schemas.microsoft.com/office/drawing/2014/main" id="{D2399950-CA2D-41D2-BB2E-E681018A573E}"/>
               </a:ext>
             </a:extLst>
           </p:cNvPr>
@@ -10656,7 +11469,7 @@
               </a:defRPr>
             </a:pPr>
             <a:r>
-              <a:t>DECISION</a:t>
+              <a:t>POSITIVE CONTROL | 2018 WORKING REGIME</a:t>
             </a:r>
           </a:p>
         </p:txBody>
@@ -10664,7 +11477,863 @@
     </p:spTree>
     <p:extLst>
       <p:ext uri="{BB962C8B-B14F-4D97-AF65-F5344CB8AC3E}">
-        <p14:creationId xmlns:p14="http://schemas.microsoft.com/office/powerpoint/2010/main" val="1664240194"/>
+        <p14:creationId xmlns:p14="http://schemas.microsoft.com/office/powerpoint/2010/main" val="2092893396"/>
+      </p:ext>
+    </p:extLst>
+  </p:cSld>
+</p:sld>
+</file>
+
+<file path=ppt/slides/slide26.xml><?xml version="1.0" encoding="utf-8"?>
+<p:sld xmlns:p="http://schemas.openxmlformats.org/presentationml/2006/main">
+  <p:cSld>
+    <p:spTree>
+      <p:nvGrpSpPr>
+        <p:cNvPr id="1" name=""/>
+        <p:cNvGrpSpPr/>
+        <p:nvPr/>
+      </p:nvGrpSpPr>
+      <p:grpSpPr>
+        <a:xfrm xmlns:a="http://schemas.openxmlformats.org/drawingml/2006/main"/>
+      </p:grpSpPr>
+      <p:sp>
+        <p:nvSpPr>
+          <p:cNvPr id="11" name="footer">
+            <a:extLst xmlns:a="http://schemas.openxmlformats.org/drawingml/2006/main">
+              <a:ext uri="{FF2B5EF4-FFF2-40B4-BE49-F238E27FC236}">
+                <a16:creationId xmlns:a16="http://schemas.microsoft.com/office/drawing/2014/main" id="{231B1CDB-9946-498B-901E-0A0C9C772112}"/>
+              </a:ext>
+            </a:extLst>
+          </p:cNvPr>
+          <p:cNvSpPr>
+            <a:spLocks xmlns:a="http://schemas.openxmlformats.org/drawingml/2006/main" noGrp="1"/>
+          </p:cNvSpPr>
+          <p:nvPr/>
+        </p:nvSpPr>
+        <p:spPr>
+          <a:xfrm xmlns:a="http://schemas.openxmlformats.org/drawingml/2006/main">
+            <a:off x="11279315" y="6279261"/>
+            <a:ext cx="518922" cy="241268"/>
+          </a:xfrm>
+          <a:prstGeom xmlns:a="http://schemas.openxmlformats.org/drawingml/2006/main" prst="rect">
+            <a:avLst/>
+          </a:prstGeom>
+        </p:spPr>
+        <p:txBody>
+          <a:bodyPr xmlns:a="http://schemas.openxmlformats.org/drawingml/2006/main" lIns="0" tIns="0" rIns="0" bIns="0" anchor="b"/>
+          <a:lstStyle xmlns:a="http://schemas.openxmlformats.org/drawingml/2006/main"/>
+          <a:p xmlns:a="http://schemas.openxmlformats.org/drawingml/2006/main">
+            <a:pPr algn="r">
+              <a:buNone/>
+              <a:defRPr sz="1000">
+                <a:solidFill>
+                  <a:srgbClr val="000000"/>
+                </a:solidFill>
+                <a:latin typeface="Helvetica Neue"/>
+                <a:ea typeface="Helvetica Neue"/>
+                <a:cs typeface="Helvetica Neue"/>
+              </a:defRPr>
+            </a:pPr>
+            <a:r>
+              <a:t>26</a:t>
+            </a:r>
+          </a:p>
+        </p:txBody>
+      </p:sp>
+      <p:sp>
+        <p:nvSpPr>
+          <p:cNvPr id="2" name="title">
+            <a:extLst xmlns:a="http://schemas.openxmlformats.org/drawingml/2006/main">
+              <a:ext uri="{FF2B5EF4-FFF2-40B4-BE49-F238E27FC236}">
+                <a16:creationId xmlns:a16="http://schemas.microsoft.com/office/drawing/2014/main" id="{EE1FC061-EE2C-48CF-9799-D8537102BA12}"/>
+              </a:ext>
+            </a:extLst>
+          </p:cNvPr>
+          <p:cNvSpPr>
+            <a:spLocks xmlns:a="http://schemas.openxmlformats.org/drawingml/2006/main" noGrp="1"/>
+          </p:cNvSpPr>
+          <p:nvPr/>
+        </p:nvSpPr>
+        <p:spPr>
+          <a:xfrm xmlns:a="http://schemas.openxmlformats.org/drawingml/2006/main">
+            <a:off x="393668" y="344043"/>
+            <a:ext cx="11404568" cy="1047464"/>
+          </a:xfrm>
+          <a:prstGeom xmlns:a="http://schemas.openxmlformats.org/drawingml/2006/main" prst="rect">
+            <a:avLst/>
+          </a:prstGeom>
+        </p:spPr>
+        <p:txBody>
+          <a:bodyPr xmlns:a="http://schemas.openxmlformats.org/drawingml/2006/main" lIns="0" tIns="0" rIns="0" bIns="0" anchor="t">
+            <a:normAutofit fontScale="100000"/>
+          </a:bodyPr>
+          <a:lstStyle xmlns:a="http://schemas.openxmlformats.org/drawingml/2006/main"/>
+          <a:p xmlns:a="http://schemas.openxmlformats.org/drawingml/2006/main">
+            <a:pPr algn="l">
+              <a:buNone/>
+              <a:defRPr sz="2900">
+                <a:solidFill>
+                  <a:srgbClr val="000000"/>
+                </a:solidFill>
+                <a:latin typeface="Helvetica Neue"/>
+                <a:ea typeface="Helvetica Neue"/>
+                <a:cs typeface="Helvetica Neue"/>
+              </a:defRPr>
+            </a:pPr>
+            <a:r>
+              <a:t>2018 produced a coherent, two-sided working example</a:t>
+            </a:r>
+          </a:p>
+        </p:txBody>
+      </p:sp>
+      <p:sp>
+        <p:nvSpPr>
+          <p:cNvPr id="3" name="left-stat-card">
+            <a:extLst xmlns:a="http://schemas.openxmlformats.org/drawingml/2006/main">
+              <a:ext uri="{FF2B5EF4-FFF2-40B4-BE49-F238E27FC236}">
+                <a16:creationId xmlns:a16="http://schemas.microsoft.com/office/drawing/2014/main" id="{EF0AF18E-87A6-431F-8D4F-59EC894570D3}"/>
+              </a:ext>
+            </a:extLst>
+          </p:cNvPr>
+          <p:cNvSpPr>
+            <a:spLocks xmlns:a="http://schemas.openxmlformats.org/drawingml/2006/main" noGrp="1"/>
+          </p:cNvSpPr>
+          <p:nvPr/>
+        </p:nvSpPr>
+        <p:spPr>
+          <a:xfrm xmlns:a="http://schemas.openxmlformats.org/drawingml/2006/main">
+            <a:off x="6272022" y="3360039"/>
+            <a:ext cx="2581942" cy="2656523"/>
+          </a:xfrm>
+          <a:prstGeom xmlns:a="http://schemas.openxmlformats.org/drawingml/2006/main" prst="roundRect">
+            <a:avLst>
+              <a:gd name="adj" fmla="val 2951"/>
+            </a:avLst>
+          </a:prstGeom>
+          <a:solidFill xmlns:a="http://schemas.openxmlformats.org/drawingml/2006/main">
+            <a:srgbClr val="F2F2F2"/>
+          </a:solidFill>
+        </p:spPr>
+      </p:sp>
+      <p:sp>
+        <p:nvSpPr>
+          <p:cNvPr id="4" name="right-stat-card">
+            <a:extLst xmlns:a="http://schemas.openxmlformats.org/drawingml/2006/main">
+              <a:ext uri="{FF2B5EF4-FFF2-40B4-BE49-F238E27FC236}">
+                <a16:creationId xmlns:a16="http://schemas.microsoft.com/office/drawing/2014/main" id="{9C01B021-FDE1-4776-B2EE-ACB76D126DAD}"/>
+              </a:ext>
+            </a:extLst>
+          </p:cNvPr>
+          <p:cNvSpPr>
+            <a:spLocks xmlns:a="http://schemas.openxmlformats.org/drawingml/2006/main" noGrp="1"/>
+          </p:cNvSpPr>
+          <p:nvPr/>
+        </p:nvSpPr>
+        <p:spPr>
+          <a:xfrm xmlns:a="http://schemas.openxmlformats.org/drawingml/2006/main">
+            <a:off x="9224201" y="3360039"/>
+            <a:ext cx="2581942" cy="2656523"/>
+          </a:xfrm>
+          <a:prstGeom xmlns:a="http://schemas.openxmlformats.org/drawingml/2006/main" prst="roundRect">
+            <a:avLst>
+              <a:gd name="adj" fmla="val 2951"/>
+            </a:avLst>
+          </a:prstGeom>
+          <a:solidFill xmlns:a="http://schemas.openxmlformats.org/drawingml/2006/main">
+            <a:srgbClr val="F2F2F2"/>
+          </a:solidFill>
+        </p:spPr>
+      </p:sp>
+      <p:sp>
+        <p:nvSpPr>
+          <p:cNvPr id="5" name="summary">
+            <a:extLst xmlns:a="http://schemas.openxmlformats.org/drawingml/2006/main">
+              <a:ext uri="{FF2B5EF4-FFF2-40B4-BE49-F238E27FC236}">
+                <a16:creationId xmlns:a16="http://schemas.microsoft.com/office/drawing/2014/main" id="{A2F82FC1-3249-4254-ABAA-A2D0E0F95848}"/>
+              </a:ext>
+            </a:extLst>
+          </p:cNvPr>
+          <p:cNvSpPr>
+            <a:spLocks xmlns:a="http://schemas.openxmlformats.org/drawingml/2006/main" noGrp="1"/>
+          </p:cNvSpPr>
+          <p:nvPr/>
+        </p:nvSpPr>
+        <p:spPr>
+          <a:xfrm xmlns:a="http://schemas.openxmlformats.org/drawingml/2006/main">
+            <a:off x="6261068" y="1714500"/>
+            <a:ext cx="5539835" cy="1381125"/>
+          </a:xfrm>
+          <a:prstGeom xmlns:a="http://schemas.openxmlformats.org/drawingml/2006/main" prst="rect">
+            <a:avLst/>
+          </a:prstGeom>
+        </p:spPr>
+        <p:txBody>
+          <a:bodyPr xmlns:a="http://schemas.openxmlformats.org/drawingml/2006/main" lIns="0" tIns="0" rIns="0" bIns="0" anchor="t">
+            <a:normAutofit fontScale="100000"/>
+          </a:bodyPr>
+          <a:lstStyle xmlns:a="http://schemas.openxmlformats.org/drawingml/2006/main"/>
+          <a:p xmlns:a="http://schemas.openxmlformats.org/drawingml/2006/main">
+            <a:pPr algn="l">
+              <a:buNone/>
+              <a:defRPr sz="1800">
+                <a:solidFill>
+                  <a:srgbClr val="000000"/>
+                </a:solidFill>
+                <a:latin typeface="Helvetica Neue"/>
+                <a:ea typeface="Helvetica Neue"/>
+                <a:cs typeface="Helvetica Neue"/>
+              </a:defRPr>
+            </a:pPr>
+            <a:r>
+              <a:t>The year finished positive after next-open execution and adaptive-hedge turnover costs. Both long- and short-spread trades contributed.</a:t>
+            </a:r>
+          </a:p>
+        </p:txBody>
+      </p:sp>
+      <p:sp>
+        <p:nvSpPr>
+          <p:cNvPr id="6" name="left-stat">
+            <a:extLst xmlns:a="http://schemas.openxmlformats.org/drawingml/2006/main">
+              <a:ext uri="{FF2B5EF4-FFF2-40B4-BE49-F238E27FC236}">
+                <a16:creationId xmlns:a16="http://schemas.microsoft.com/office/drawing/2014/main" id="{06B274F5-6F7E-4432-B0F1-4874DA3CABBF}"/>
+              </a:ext>
+            </a:extLst>
+          </p:cNvPr>
+          <p:cNvSpPr>
+            <a:spLocks xmlns:a="http://schemas.openxmlformats.org/drawingml/2006/main" noGrp="1"/>
+          </p:cNvSpPr>
+          <p:nvPr/>
+        </p:nvSpPr>
+        <p:spPr>
+          <a:xfrm xmlns:a="http://schemas.openxmlformats.org/drawingml/2006/main">
+            <a:off x="6509385" y="3579971"/>
+            <a:ext cx="2133314" cy="1155859"/>
+          </a:xfrm>
+          <a:prstGeom xmlns:a="http://schemas.openxmlformats.org/drawingml/2006/main" prst="rect">
+            <a:avLst/>
+          </a:prstGeom>
+        </p:spPr>
+        <p:txBody>
+          <a:bodyPr xmlns:a="http://schemas.openxmlformats.org/drawingml/2006/main" lIns="0" tIns="0" rIns="0" bIns="0" anchor="b">
+            <a:normAutofit fontScale="100000"/>
+          </a:bodyPr>
+          <a:lstStyle xmlns:a="http://schemas.openxmlformats.org/drawingml/2006/main"/>
+          <a:p xmlns:a="http://schemas.openxmlformats.org/drawingml/2006/main">
+            <a:pPr algn="l">
+              <a:buNone/>
+              <a:defRPr sz="2700">
+                <a:solidFill>
+                  <a:srgbClr val="B42318"/>
+                </a:solidFill>
+                <a:latin typeface="Helvetica Neue"/>
+                <a:ea typeface="Helvetica Neue"/>
+                <a:cs typeface="Helvetica Neue"/>
+              </a:defRPr>
+            </a:pPr>
+            <a:r>
+              <a:t>+4.82%</a:t>
+            </a:r>
+          </a:p>
+        </p:txBody>
+      </p:sp>
+      <p:sp>
+        <p:nvSpPr>
+          <p:cNvPr id="7" name="left-stat-label">
+            <a:extLst xmlns:a="http://schemas.openxmlformats.org/drawingml/2006/main">
+              <a:ext uri="{FF2B5EF4-FFF2-40B4-BE49-F238E27FC236}">
+                <a16:creationId xmlns:a16="http://schemas.microsoft.com/office/drawing/2014/main" id="{99D2BB32-1C11-4B29-AF23-ED9F32D0BCEB}"/>
+              </a:ext>
+            </a:extLst>
+          </p:cNvPr>
+          <p:cNvSpPr>
+            <a:spLocks xmlns:a="http://schemas.openxmlformats.org/drawingml/2006/main" noGrp="1"/>
+          </p:cNvSpPr>
+          <p:nvPr/>
+        </p:nvSpPr>
+        <p:spPr>
+          <a:xfrm xmlns:a="http://schemas.openxmlformats.org/drawingml/2006/main">
+            <a:off x="6575965" y="4953000"/>
+            <a:ext cx="2066735" cy="762000"/>
+          </a:xfrm>
+          <a:prstGeom xmlns:a="http://schemas.openxmlformats.org/drawingml/2006/main" prst="rect">
+            <a:avLst/>
+          </a:prstGeom>
+        </p:spPr>
+        <p:txBody>
+          <a:bodyPr xmlns:a="http://schemas.openxmlformats.org/drawingml/2006/main" lIns="0" tIns="0" rIns="0" bIns="0">
+            <a:normAutofit fontScale="100000"/>
+          </a:bodyPr>
+          <a:lstStyle xmlns:a="http://schemas.openxmlformats.org/drawingml/2006/main"/>
+          <a:p xmlns:a="http://schemas.openxmlformats.org/drawingml/2006/main">
+            <a:pPr algn="l">
+              <a:buNone/>
+              <a:defRPr sz="1500">
+                <a:solidFill>
+                  <a:srgbClr val="000000"/>
+                </a:solidFill>
+                <a:latin typeface="Helvetica Neue"/>
+                <a:ea typeface="Helvetica Neue"/>
+                <a:cs typeface="Helvetica Neue"/>
+              </a:defRPr>
+            </a:pPr>
+            <a:r>
+              <a:t>Primary-cost</a:t>
+            </a:r>
+          </a:p>
+          <a:p xmlns:a="http://schemas.openxmlformats.org/drawingml/2006/main">
+            <a:pPr algn="l">
+              <a:buNone/>
+              <a:defRPr sz="1500">
+                <a:solidFill>
+                  <a:srgbClr val="000000"/>
+                </a:solidFill>
+                <a:latin typeface="Helvetica Neue"/>
+                <a:ea typeface="Helvetica Neue"/>
+                <a:cs typeface="Helvetica Neue"/>
+              </a:defRPr>
+            </a:pPr>
+            <a:r>
+              <a:t>calendar return</a:t>
+            </a:r>
+          </a:p>
+        </p:txBody>
+      </p:sp>
+      <p:sp>
+        <p:nvSpPr>
+          <p:cNvPr id="8" name="right-stat">
+            <a:extLst xmlns:a="http://schemas.openxmlformats.org/drawingml/2006/main">
+              <a:ext uri="{FF2B5EF4-FFF2-40B4-BE49-F238E27FC236}">
+                <a16:creationId xmlns:a16="http://schemas.microsoft.com/office/drawing/2014/main" id="{2EAFD608-776D-46A1-95EA-79AF4E6F5599}"/>
+              </a:ext>
+            </a:extLst>
+          </p:cNvPr>
+          <p:cNvSpPr>
+            <a:spLocks xmlns:a="http://schemas.openxmlformats.org/drawingml/2006/main" noGrp="1"/>
+          </p:cNvSpPr>
+          <p:nvPr/>
+        </p:nvSpPr>
+        <p:spPr>
+          <a:xfrm xmlns:a="http://schemas.openxmlformats.org/drawingml/2006/main">
+            <a:off x="9461564" y="3579971"/>
+            <a:ext cx="2133314" cy="1155859"/>
+          </a:xfrm>
+          <a:prstGeom xmlns:a="http://schemas.openxmlformats.org/drawingml/2006/main" prst="rect">
+            <a:avLst/>
+          </a:prstGeom>
+        </p:spPr>
+        <p:txBody>
+          <a:bodyPr xmlns:a="http://schemas.openxmlformats.org/drawingml/2006/main" lIns="0" tIns="0" rIns="0" bIns="0" anchor="b">
+            <a:normAutofit fontScale="100000"/>
+          </a:bodyPr>
+          <a:lstStyle xmlns:a="http://schemas.openxmlformats.org/drawingml/2006/main"/>
+          <a:p xmlns:a="http://schemas.openxmlformats.org/drawingml/2006/main">
+            <a:pPr algn="l">
+              <a:buNone/>
+              <a:defRPr sz="2700">
+                <a:solidFill>
+                  <a:srgbClr val="B42318"/>
+                </a:solidFill>
+                <a:latin typeface="Helvetica Neue"/>
+                <a:ea typeface="Helvetica Neue"/>
+                <a:cs typeface="Helvetica Neue"/>
+              </a:defRPr>
+            </a:pPr>
+            <a:r>
+              <a:t>69.2%</a:t>
+            </a:r>
+          </a:p>
+        </p:txBody>
+      </p:sp>
+      <p:sp>
+        <p:nvSpPr>
+          <p:cNvPr id="9" name="right-stat-label">
+            <a:extLst xmlns:a="http://schemas.openxmlformats.org/drawingml/2006/main">
+              <a:ext uri="{FF2B5EF4-FFF2-40B4-BE49-F238E27FC236}">
+                <a16:creationId xmlns:a16="http://schemas.microsoft.com/office/drawing/2014/main" id="{691BF8AE-236E-4677-8EAF-3CF0D5A20DB6}"/>
+              </a:ext>
+            </a:extLst>
+          </p:cNvPr>
+          <p:cNvSpPr>
+            <a:spLocks xmlns:a="http://schemas.openxmlformats.org/drawingml/2006/main" noGrp="1"/>
+          </p:cNvSpPr>
+          <p:nvPr/>
+        </p:nvSpPr>
+        <p:spPr>
+          <a:xfrm xmlns:a="http://schemas.openxmlformats.org/drawingml/2006/main">
+            <a:off x="9528143" y="4953000"/>
+            <a:ext cx="2066735" cy="762000"/>
+          </a:xfrm>
+          <a:prstGeom xmlns:a="http://schemas.openxmlformats.org/drawingml/2006/main" prst="rect">
+            <a:avLst/>
+          </a:prstGeom>
+        </p:spPr>
+        <p:txBody>
+          <a:bodyPr xmlns:a="http://schemas.openxmlformats.org/drawingml/2006/main" lIns="0" tIns="0" rIns="0" bIns="0">
+            <a:normAutofit fontScale="100000"/>
+          </a:bodyPr>
+          <a:lstStyle xmlns:a="http://schemas.openxmlformats.org/drawingml/2006/main"/>
+          <a:p xmlns:a="http://schemas.openxmlformats.org/drawingml/2006/main">
+            <a:pPr algn="l">
+              <a:buNone/>
+              <a:defRPr sz="1500">
+                <a:solidFill>
+                  <a:srgbClr val="000000"/>
+                </a:solidFill>
+                <a:latin typeface="Helvetica Neue"/>
+                <a:ea typeface="Helvetica Neue"/>
+                <a:cs typeface="Helvetica Neue"/>
+              </a:defRPr>
+            </a:pPr>
+            <a:r>
+              <a:t>Trade hit rate</a:t>
+            </a:r>
+          </a:p>
+          <a:p xmlns:a="http://schemas.openxmlformats.org/drawingml/2006/main">
+            <a:pPr algn="l">
+              <a:buNone/>
+              <a:defRPr sz="1500">
+                <a:solidFill>
+                  <a:srgbClr val="000000"/>
+                </a:solidFill>
+                <a:latin typeface="Helvetica Neue"/>
+                <a:ea typeface="Helvetica Neue"/>
+                <a:cs typeface="Helvetica Neue"/>
+              </a:defRPr>
+            </a:pPr>
+            <a:r>
+              <a:t>9 wins / 13 trades</a:t>
+            </a:r>
+          </a:p>
+        </p:txBody>
+      </p:sp>
+      <p:pic>
+        <p:nvPicPr>
+          <p:cNvPr id="22" name=""/>
+          <p:cNvPicPr>
+            <a:picLocks xmlns:a="http://schemas.openxmlformats.org/drawingml/2006/main" noChangeAspect="1"/>
+          </p:cNvPicPr>
+          <p:nvPr/>
+        </p:nvPicPr>
+        <p:blipFill>
+          <a:blip xmlns:r="http://schemas.openxmlformats.org/officeDocument/2006/relationships" xmlns:a="http://schemas.openxmlformats.org/drawingml/2006/main" r:embed="Rc81b5756c1a44421"/>
+          <a:stretch xmlns:a="http://schemas.openxmlformats.org/drawingml/2006/main"/>
+        </p:blipFill>
+        <p:spPr>
+          <a:xfrm xmlns:a="http://schemas.openxmlformats.org/drawingml/2006/main">
+            <a:off x="781159" y="2378774"/>
+            <a:ext cx="4743613" cy="2767108"/>
+          </a:xfrm>
+          <a:prstGeom xmlns:a="http://schemas.openxmlformats.org/drawingml/2006/main" prst="rect">
+            <a:avLst/>
+          </a:prstGeom>
+        </p:spPr>
+      </p:pic>
+    </p:spTree>
+    <p:extLst>
+      <p:ext uri="{BB962C8B-B14F-4D97-AF65-F5344CB8AC3E}">
+        <p14:creationId xmlns:p14="http://schemas.microsoft.com/office/powerpoint/2010/main" val="91287502"/>
+      </p:ext>
+    </p:extLst>
+  </p:cSld>
+</p:sld>
+</file>
+
+<file path=ppt/slides/slide27.xml><?xml version="1.0" encoding="utf-8"?>
+<p:sld xmlns:p="http://schemas.openxmlformats.org/presentationml/2006/main">
+  <p:cSld>
+    <p:spTree>
+      <p:nvGrpSpPr>
+        <p:cNvPr id="1" name=""/>
+        <p:cNvGrpSpPr/>
+        <p:nvPr/>
+      </p:nvGrpSpPr>
+      <p:grpSpPr>
+        <a:xfrm xmlns:a="http://schemas.openxmlformats.org/drawingml/2006/main"/>
+      </p:grpSpPr>
+      <p:sp>
+        <p:nvSpPr>
+          <p:cNvPr id="6" name="footer">
+            <a:extLst xmlns:a="http://schemas.openxmlformats.org/drawingml/2006/main">
+              <a:ext uri="{FF2B5EF4-FFF2-40B4-BE49-F238E27FC236}">
+                <a16:creationId xmlns:a16="http://schemas.microsoft.com/office/drawing/2014/main" id="{5D1F4916-B18D-4F3F-8812-75A699D9A639}"/>
+              </a:ext>
+            </a:extLst>
+          </p:cNvPr>
+          <p:cNvSpPr>
+            <a:spLocks xmlns:a="http://schemas.openxmlformats.org/drawingml/2006/main" noGrp="1"/>
+          </p:cNvSpPr>
+          <p:nvPr/>
+        </p:nvSpPr>
+        <p:spPr>
+          <a:xfrm xmlns:a="http://schemas.openxmlformats.org/drawingml/2006/main">
+            <a:off x="11279315" y="6279261"/>
+            <a:ext cx="518922" cy="241268"/>
+          </a:xfrm>
+          <a:prstGeom xmlns:a="http://schemas.openxmlformats.org/drawingml/2006/main" prst="rect">
+            <a:avLst/>
+          </a:prstGeom>
+        </p:spPr>
+        <p:txBody>
+          <a:bodyPr xmlns:a="http://schemas.openxmlformats.org/drawingml/2006/main" lIns="0" tIns="0" rIns="0" bIns="0" anchor="b"/>
+          <a:lstStyle xmlns:a="http://schemas.openxmlformats.org/drawingml/2006/main"/>
+          <a:p xmlns:a="http://schemas.openxmlformats.org/drawingml/2006/main">
+            <a:pPr algn="r">
+              <a:buNone/>
+              <a:defRPr sz="1000">
+                <a:solidFill>
+                  <a:srgbClr val="000000"/>
+                </a:solidFill>
+                <a:latin typeface="Helvetica Neue"/>
+                <a:ea typeface="Helvetica Neue"/>
+                <a:cs typeface="Helvetica Neue"/>
+              </a:defRPr>
+            </a:pPr>
+            <a:r>
+              <a:t>27</a:t>
+            </a:r>
+          </a:p>
+        </p:txBody>
+      </p:sp>
+      <p:sp>
+        <p:nvSpPr>
+          <p:cNvPr id="2" name="title">
+            <a:extLst xmlns:a="http://schemas.openxmlformats.org/drawingml/2006/main">
+              <a:ext uri="{FF2B5EF4-FFF2-40B4-BE49-F238E27FC236}">
+                <a16:creationId xmlns:a16="http://schemas.microsoft.com/office/drawing/2014/main" id="{ECB77D9D-0CB0-4878-9A4A-2687A311CD30}"/>
+              </a:ext>
+            </a:extLst>
+          </p:cNvPr>
+          <p:cNvSpPr>
+            <a:spLocks xmlns:a="http://schemas.openxmlformats.org/drawingml/2006/main" noGrp="1"/>
+          </p:cNvSpPr>
+          <p:nvPr/>
+        </p:nvSpPr>
+        <p:spPr>
+          <a:xfrm xmlns:a="http://schemas.openxmlformats.org/drawingml/2006/main">
+            <a:off x="393668" y="295275"/>
+            <a:ext cx="11404568" cy="876300"/>
+          </a:xfrm>
+          <a:prstGeom xmlns:a="http://schemas.openxmlformats.org/drawingml/2006/main" prst="rect">
+            <a:avLst/>
+          </a:prstGeom>
+        </p:spPr>
+        <p:txBody>
+          <a:bodyPr xmlns:a="http://schemas.openxmlformats.org/drawingml/2006/main" lIns="0" tIns="0" rIns="0" bIns="0" anchor="t">
+            <a:normAutofit fontScale="100000"/>
+          </a:bodyPr>
+          <a:lstStyle xmlns:a="http://schemas.openxmlformats.org/drawingml/2006/main"/>
+          <a:p xmlns:a="http://schemas.openxmlformats.org/drawingml/2006/main">
+            <a:pPr algn="l">
+              <a:buNone/>
+              <a:defRPr sz="2900">
+                <a:solidFill>
+                  <a:srgbClr val="000000"/>
+                </a:solidFill>
+                <a:latin typeface="Helvetica Neue"/>
+                <a:ea typeface="Helvetica Neue"/>
+                <a:cs typeface="Helvetica Neue"/>
+              </a:defRPr>
+            </a:pPr>
+            <a:r>
+              <a:t>The signal, spread, and equity path line up in one view</a:t>
+            </a:r>
+          </a:p>
+        </p:txBody>
+      </p:sp>
+      <p:pic>
+        <p:nvPicPr>
+          <p:cNvPr id="10" name=""/>
+          <p:cNvPicPr>
+            <a:picLocks xmlns:a="http://schemas.openxmlformats.org/drawingml/2006/main" noChangeAspect="1"/>
+          </p:cNvPicPr>
+          <p:nvPr/>
+        </p:nvPicPr>
+        <p:blipFill>
+          <a:blip xmlns:r="http://schemas.openxmlformats.org/officeDocument/2006/relationships" xmlns:a="http://schemas.openxmlformats.org/drawingml/2006/main" r:embed="Re7e1fa4247bc46c4"/>
+          <a:stretch xmlns:a="http://schemas.openxmlformats.org/drawingml/2006/main"/>
+        </p:blipFill>
+        <p:spPr>
+          <a:xfrm xmlns:a="http://schemas.openxmlformats.org/drawingml/2006/main">
+            <a:off x="1891393" y="1162050"/>
+            <a:ext cx="8409214" cy="4905375"/>
+          </a:xfrm>
+          <a:prstGeom xmlns:a="http://schemas.openxmlformats.org/drawingml/2006/main" prst="rect">
+            <a:avLst/>
+          </a:prstGeom>
+        </p:spPr>
+      </p:pic>
+    </p:spTree>
+    <p:extLst>
+      <p:ext uri="{BB962C8B-B14F-4D97-AF65-F5344CB8AC3E}">
+        <p14:creationId xmlns:p14="http://schemas.microsoft.com/office/powerpoint/2010/main" val="463436756"/>
+      </p:ext>
+    </p:extLst>
+  </p:cSld>
+</p:sld>
+</file>
+
+<file path=ppt/slides/slide28.xml><?xml version="1.0" encoding="utf-8"?>
+<p:sld xmlns:p="http://schemas.openxmlformats.org/presentationml/2006/main">
+  <p:cSld>
+    <p:spTree>
+      <p:nvGrpSpPr>
+        <p:cNvPr id="1" name=""/>
+        <p:cNvGrpSpPr/>
+        <p:nvPr/>
+      </p:nvGrpSpPr>
+      <p:grpSpPr>
+        <a:xfrm xmlns:a="http://schemas.openxmlformats.org/drawingml/2006/main"/>
+      </p:grpSpPr>
+      <p:sp>
+        <p:nvSpPr>
+          <p:cNvPr id="6" name="footer">
+            <a:extLst xmlns:a="http://schemas.openxmlformats.org/drawingml/2006/main">
+              <a:ext uri="{FF2B5EF4-FFF2-40B4-BE49-F238E27FC236}">
+                <a16:creationId xmlns:a16="http://schemas.microsoft.com/office/drawing/2014/main" id="{5D1F4916-B18D-4F3F-8812-75A699D9A639}"/>
+              </a:ext>
+            </a:extLst>
+          </p:cNvPr>
+          <p:cNvSpPr>
+            <a:spLocks xmlns:a="http://schemas.openxmlformats.org/drawingml/2006/main" noGrp="1"/>
+          </p:cNvSpPr>
+          <p:nvPr/>
+        </p:nvSpPr>
+        <p:spPr>
+          <a:xfrm xmlns:a="http://schemas.openxmlformats.org/drawingml/2006/main">
+            <a:off x="11279315" y="6279261"/>
+            <a:ext cx="518922" cy="241268"/>
+          </a:xfrm>
+          <a:prstGeom xmlns:a="http://schemas.openxmlformats.org/drawingml/2006/main" prst="rect">
+            <a:avLst/>
+          </a:prstGeom>
+        </p:spPr>
+        <p:txBody>
+          <a:bodyPr xmlns:a="http://schemas.openxmlformats.org/drawingml/2006/main" lIns="0" tIns="0" rIns="0" bIns="0" anchor="b"/>
+          <a:lstStyle xmlns:a="http://schemas.openxmlformats.org/drawingml/2006/main"/>
+          <a:p xmlns:a="http://schemas.openxmlformats.org/drawingml/2006/main">
+            <a:pPr algn="r">
+              <a:buNone/>
+              <a:defRPr sz="1000">
+                <a:solidFill>
+                  <a:srgbClr val="000000"/>
+                </a:solidFill>
+                <a:latin typeface="Helvetica Neue"/>
+                <a:ea typeface="Helvetica Neue"/>
+                <a:cs typeface="Helvetica Neue"/>
+              </a:defRPr>
+            </a:pPr>
+            <a:r>
+              <a:t>28</a:t>
+            </a:r>
+          </a:p>
+        </p:txBody>
+      </p:sp>
+      <p:sp>
+        <p:nvSpPr>
+          <p:cNvPr id="2" name="title">
+            <a:extLst xmlns:a="http://schemas.openxmlformats.org/drawingml/2006/main">
+              <a:ext uri="{FF2B5EF4-FFF2-40B4-BE49-F238E27FC236}">
+                <a16:creationId xmlns:a16="http://schemas.microsoft.com/office/drawing/2014/main" id="{ECB77D9D-0CB0-4878-9A4A-2687A311CD30}"/>
+              </a:ext>
+            </a:extLst>
+          </p:cNvPr>
+          <p:cNvSpPr>
+            <a:spLocks xmlns:a="http://schemas.openxmlformats.org/drawingml/2006/main" noGrp="1"/>
+          </p:cNvSpPr>
+          <p:nvPr/>
+        </p:nvSpPr>
+        <p:spPr>
+          <a:xfrm xmlns:a="http://schemas.openxmlformats.org/drawingml/2006/main">
+            <a:off x="393668" y="295275"/>
+            <a:ext cx="11404568" cy="876300"/>
+          </a:xfrm>
+          <a:prstGeom xmlns:a="http://schemas.openxmlformats.org/drawingml/2006/main" prst="rect">
+            <a:avLst/>
+          </a:prstGeom>
+        </p:spPr>
+        <p:txBody>
+          <a:bodyPr xmlns:a="http://schemas.openxmlformats.org/drawingml/2006/main" lIns="0" tIns="0" rIns="0" bIns="0" anchor="t">
+            <a:normAutofit fontScale="100000"/>
+          </a:bodyPr>
+          <a:lstStyle xmlns:a="http://schemas.openxmlformats.org/drawingml/2006/main"/>
+          <a:p xmlns:a="http://schemas.openxmlformats.org/drawingml/2006/main">
+            <a:pPr algn="l">
+              <a:buNone/>
+              <a:defRPr sz="2900">
+                <a:solidFill>
+                  <a:srgbClr val="000000"/>
+                </a:solidFill>
+                <a:latin typeface="Helvetica Neue"/>
+                <a:ea typeface="Helvetica Neue"/>
+                <a:cs typeface="Helvetica Neue"/>
+              </a:defRPr>
+            </a:pPr>
+            <a:r>
+              <a:t>Every 2018 trade is visible—wins, losses, direction, and duration</a:t>
+            </a:r>
+          </a:p>
+        </p:txBody>
+      </p:sp>
+      <p:pic>
+        <p:nvPicPr>
+          <p:cNvPr id="10" name=""/>
+          <p:cNvPicPr>
+            <a:picLocks xmlns:a="http://schemas.openxmlformats.org/drawingml/2006/main" noChangeAspect="1"/>
+          </p:cNvPicPr>
+          <p:nvPr/>
+        </p:nvPicPr>
+        <p:blipFill>
+          <a:blip xmlns:r="http://schemas.openxmlformats.org/officeDocument/2006/relationships" xmlns:a="http://schemas.openxmlformats.org/drawingml/2006/main" r:embed="R760b192826804a0a"/>
+          <a:stretch xmlns:a="http://schemas.openxmlformats.org/drawingml/2006/main"/>
+        </p:blipFill>
+        <p:spPr>
+          <a:xfrm xmlns:a="http://schemas.openxmlformats.org/drawingml/2006/main">
+            <a:off x="1891393" y="1162050"/>
+            <a:ext cx="8409214" cy="4905375"/>
+          </a:xfrm>
+          <a:prstGeom xmlns:a="http://schemas.openxmlformats.org/drawingml/2006/main" prst="rect">
+            <a:avLst/>
+          </a:prstGeom>
+        </p:spPr>
+      </p:pic>
+    </p:spTree>
+    <p:extLst>
+      <p:ext uri="{BB962C8B-B14F-4D97-AF65-F5344CB8AC3E}">
+        <p14:creationId xmlns:p14="http://schemas.microsoft.com/office/powerpoint/2010/main" val="463436756"/>
+      </p:ext>
+    </p:extLst>
+  </p:cSld>
+</p:sld>
+</file>
+
+<file path=ppt/slides/slide29.xml><?xml version="1.0" encoding="utf-8"?>
+<p:sld xmlns:p="http://schemas.openxmlformats.org/presentationml/2006/main">
+  <p:cSld>
+    <p:spTree>
+      <p:nvGrpSpPr>
+        <p:cNvPr id="1" name=""/>
+        <p:cNvGrpSpPr/>
+        <p:nvPr/>
+      </p:nvGrpSpPr>
+      <p:grpSpPr>
+        <a:xfrm xmlns:a="http://schemas.openxmlformats.org/drawingml/2006/main"/>
+      </p:grpSpPr>
+      <p:sp>
+        <p:nvSpPr>
+          <p:cNvPr id="6" name="footer">
+            <a:extLst xmlns:a="http://schemas.openxmlformats.org/drawingml/2006/main">
+              <a:ext uri="{FF2B5EF4-FFF2-40B4-BE49-F238E27FC236}">
+                <a16:creationId xmlns:a16="http://schemas.microsoft.com/office/drawing/2014/main" id="{5D1F4916-B18D-4F3F-8812-75A699D9A639}"/>
+              </a:ext>
+            </a:extLst>
+          </p:cNvPr>
+          <p:cNvSpPr>
+            <a:spLocks xmlns:a="http://schemas.openxmlformats.org/drawingml/2006/main" noGrp="1"/>
+          </p:cNvSpPr>
+          <p:nvPr/>
+        </p:nvSpPr>
+        <p:spPr>
+          <a:xfrm xmlns:a="http://schemas.openxmlformats.org/drawingml/2006/main">
+            <a:off x="11279315" y="6279261"/>
+            <a:ext cx="518922" cy="241268"/>
+          </a:xfrm>
+          <a:prstGeom xmlns:a="http://schemas.openxmlformats.org/drawingml/2006/main" prst="rect">
+            <a:avLst/>
+          </a:prstGeom>
+        </p:spPr>
+        <p:txBody>
+          <a:bodyPr xmlns:a="http://schemas.openxmlformats.org/drawingml/2006/main" lIns="0" tIns="0" rIns="0" bIns="0" anchor="b"/>
+          <a:lstStyle xmlns:a="http://schemas.openxmlformats.org/drawingml/2006/main"/>
+          <a:p xmlns:a="http://schemas.openxmlformats.org/drawingml/2006/main">
+            <a:pPr algn="r">
+              <a:buNone/>
+              <a:defRPr sz="1000">
+                <a:solidFill>
+                  <a:srgbClr val="000000"/>
+                </a:solidFill>
+                <a:latin typeface="Helvetica Neue"/>
+                <a:ea typeface="Helvetica Neue"/>
+                <a:cs typeface="Helvetica Neue"/>
+              </a:defRPr>
+            </a:pPr>
+            <a:r>
+              <a:t>29</a:t>
+            </a:r>
+          </a:p>
+        </p:txBody>
+      </p:sp>
+      <p:sp>
+        <p:nvSpPr>
+          <p:cNvPr id="2" name="title">
+            <a:extLst xmlns:a="http://schemas.openxmlformats.org/drawingml/2006/main">
+              <a:ext uri="{FF2B5EF4-FFF2-40B4-BE49-F238E27FC236}">
+                <a16:creationId xmlns:a16="http://schemas.microsoft.com/office/drawing/2014/main" id="{ECB77D9D-0CB0-4878-9A4A-2687A311CD30}"/>
+              </a:ext>
+            </a:extLst>
+          </p:cNvPr>
+          <p:cNvSpPr>
+            <a:spLocks xmlns:a="http://schemas.openxmlformats.org/drawingml/2006/main" noGrp="1"/>
+          </p:cNvSpPr>
+          <p:nvPr/>
+        </p:nvSpPr>
+        <p:spPr>
+          <a:xfrm xmlns:a="http://schemas.openxmlformats.org/drawingml/2006/main">
+            <a:off x="393668" y="295275"/>
+            <a:ext cx="11404568" cy="876300"/>
+          </a:xfrm>
+          <a:prstGeom xmlns:a="http://schemas.openxmlformats.org/drawingml/2006/main" prst="rect">
+            <a:avLst/>
+          </a:prstGeom>
+        </p:spPr>
+        <p:txBody>
+          <a:bodyPr xmlns:a="http://schemas.openxmlformats.org/drawingml/2006/main" lIns="0" tIns="0" rIns="0" bIns="0" anchor="t">
+            <a:normAutofit fontScale="100000"/>
+          </a:bodyPr>
+          <a:lstStyle xmlns:a="http://schemas.openxmlformats.org/drawingml/2006/main"/>
+          <a:p xmlns:a="http://schemas.openxmlformats.org/drawingml/2006/main">
+            <a:pPr algn="l">
+              <a:buNone/>
+              <a:defRPr sz="2900">
+                <a:solidFill>
+                  <a:srgbClr val="000000"/>
+                </a:solidFill>
+                <a:latin typeface="Helvetica Neue"/>
+                <a:ea typeface="Helvetica Neue"/>
+                <a:cs typeface="Helvetica Neue"/>
+              </a:defRPr>
+            </a:pPr>
+            <a:r>
+              <a:t>Costs mattered, yet both directions still produced winners</a:t>
+            </a:r>
+          </a:p>
+        </p:txBody>
+      </p:sp>
+      <p:pic>
+        <p:nvPicPr>
+          <p:cNvPr id="10" name=""/>
+          <p:cNvPicPr>
+            <a:picLocks xmlns:a="http://schemas.openxmlformats.org/drawingml/2006/main" noChangeAspect="1"/>
+          </p:cNvPicPr>
+          <p:nvPr/>
+        </p:nvPicPr>
+        <p:blipFill>
+          <a:blip xmlns:r="http://schemas.openxmlformats.org/officeDocument/2006/relationships" xmlns:a="http://schemas.openxmlformats.org/drawingml/2006/main" r:embed="Recf193e704df4636"/>
+          <a:stretch xmlns:a="http://schemas.openxmlformats.org/drawingml/2006/main"/>
+        </p:blipFill>
+        <p:spPr>
+          <a:xfrm xmlns:a="http://schemas.openxmlformats.org/drawingml/2006/main">
+            <a:off x="1891393" y="1162050"/>
+            <a:ext cx="8409214" cy="4905375"/>
+          </a:xfrm>
+          <a:prstGeom xmlns:a="http://schemas.openxmlformats.org/drawingml/2006/main" prst="rect">
+            <a:avLst/>
+          </a:prstGeom>
+        </p:spPr>
+      </p:pic>
+    </p:spTree>
+    <p:extLst>
+      <p:ext uri="{BB962C8B-B14F-4D97-AF65-F5344CB8AC3E}">
+        <p14:creationId xmlns:p14="http://schemas.microsoft.com/office/powerpoint/2010/main" val="463436756"/>
       </p:ext>
     </p:extLst>
   </p:cSld>
@@ -11189,6 +12858,946 @@
     <p:extLst>
       <p:ext uri="{BB962C8B-B14F-4D97-AF65-F5344CB8AC3E}">
         <p14:creationId xmlns:p14="http://schemas.microsoft.com/office/powerpoint/2010/main" val="2098249639"/>
+      </p:ext>
+    </p:extLst>
+  </p:cSld>
+</p:sld>
+</file>
+
+<file path=ppt/slides/slide30.xml><?xml version="1.0" encoding="utf-8"?>
+<p:sld xmlns:p="http://schemas.openxmlformats.org/presentationml/2006/main">
+  <p:cSld>
+    <p:spTree>
+      <p:nvGrpSpPr>
+        <p:cNvPr id="1" name=""/>
+        <p:cNvGrpSpPr/>
+        <p:nvPr/>
+      </p:nvGrpSpPr>
+      <p:grpSpPr>
+        <a:xfrm xmlns:a="http://schemas.openxmlformats.org/drawingml/2006/main"/>
+      </p:grpSpPr>
+      <p:sp>
+        <p:nvSpPr>
+          <p:cNvPr id="4" name="cover-headline">
+            <a:extLst xmlns:a="http://schemas.openxmlformats.org/drawingml/2006/main">
+              <a:ext uri="{FF2B5EF4-FFF2-40B4-BE49-F238E27FC236}">
+                <a16:creationId xmlns:a16="http://schemas.microsoft.com/office/drawing/2014/main" id="{DA6318FA-2F99-4DF9-A744-06350F910925}"/>
+              </a:ext>
+            </a:extLst>
+          </p:cNvPr>
+          <p:cNvSpPr>
+            <a:spLocks xmlns:a="http://schemas.openxmlformats.org/drawingml/2006/main" noGrp="1"/>
+          </p:cNvSpPr>
+          <p:nvPr/>
+        </p:nvSpPr>
+        <p:spPr>
+          <a:xfrm xmlns:a="http://schemas.openxmlformats.org/drawingml/2006/main">
+            <a:off x="393668" y="1738789"/>
+            <a:ext cx="10287000" cy="2491454"/>
+          </a:xfrm>
+          <a:prstGeom xmlns:a="http://schemas.openxmlformats.org/drawingml/2006/main" prst="rect">
+            <a:avLst/>
+          </a:prstGeom>
+        </p:spPr>
+        <p:txBody>
+          <a:bodyPr xmlns:a="http://schemas.openxmlformats.org/drawingml/2006/main" lIns="0" tIns="0" rIns="0" bIns="0" anchor="b">
+            <a:normAutofit fontScale="100000"/>
+          </a:bodyPr>
+          <a:lstStyle xmlns:a="http://schemas.openxmlformats.org/drawingml/2006/main"/>
+          <a:p xmlns:a="http://schemas.openxmlformats.org/drawingml/2006/main">
+            <a:pPr algn="l">
+              <a:buNone/>
+              <a:defRPr sz="5700">
+                <a:solidFill>
+                  <a:srgbClr val="000000"/>
+                </a:solidFill>
+                <a:latin typeface="Helvetica Neue"/>
+                <a:ea typeface="Helvetica Neue"/>
+                <a:cs typeface="Helvetica Neue"/>
+              </a:defRPr>
+            </a:pPr>
+            <a:r>
+              <a:t>2006–2012:</a:t>
+            </a:r>
+          </a:p>
+          <a:p xmlns:a="http://schemas.openxmlformats.org/drawingml/2006/main">
+            <a:pPr algn="l">
+              <a:buNone/>
+              <a:defRPr sz="5700">
+                <a:solidFill>
+                  <a:srgbClr val="000000"/>
+                </a:solidFill>
+                <a:latin typeface="Helvetica Neue"/>
+                <a:ea typeface="Helvetica Neue"/>
+                <a:cs typeface="Helvetica Neue"/>
+              </a:defRPr>
+            </a:pPr>
+            <a:r>
+              <a:t>the published regime</a:t>
+            </a:r>
+          </a:p>
+        </p:txBody>
+      </p:sp>
+      <p:sp>
+        <p:nvSpPr>
+          <p:cNvPr id="2" name="cover-subtitle">
+            <a:extLst xmlns:a="http://schemas.openxmlformats.org/drawingml/2006/main">
+              <a:ext uri="{FF2B5EF4-FFF2-40B4-BE49-F238E27FC236}">
+                <a16:creationId xmlns:a16="http://schemas.microsoft.com/office/drawing/2014/main" id="{E169DF7F-9A3A-4AE2-8055-4ED350724D47}"/>
+              </a:ext>
+            </a:extLst>
+          </p:cNvPr>
+          <p:cNvSpPr>
+            <a:spLocks xmlns:a="http://schemas.openxmlformats.org/drawingml/2006/main" noGrp="1"/>
+          </p:cNvSpPr>
+          <p:nvPr/>
+        </p:nvSpPr>
+        <p:spPr>
+          <a:xfrm xmlns:a="http://schemas.openxmlformats.org/drawingml/2006/main">
+            <a:off x="393668" y="4762500"/>
+            <a:ext cx="8001000" cy="1238250"/>
+          </a:xfrm>
+          <a:prstGeom xmlns:a="http://schemas.openxmlformats.org/drawingml/2006/main" prst="rect">
+            <a:avLst/>
+          </a:prstGeom>
+        </p:spPr>
+        <p:txBody>
+          <a:bodyPr xmlns:a="http://schemas.openxmlformats.org/drawingml/2006/main" lIns="0" tIns="0" rIns="0" bIns="0">
+            <a:normAutofit fontScale="100000"/>
+          </a:bodyPr>
+          <a:lstStyle xmlns:a="http://schemas.openxmlformats.org/drawingml/2006/main"/>
+          <a:p xmlns:a="http://schemas.openxmlformats.org/drawingml/2006/main">
+            <a:pPr algn="l">
+              <a:buNone/>
+              <a:defRPr sz="2250">
+                <a:solidFill>
+                  <a:srgbClr val="000000"/>
+                </a:solidFill>
+                <a:latin typeface="Helvetica Neue"/>
+                <a:ea typeface="Helvetica Neue"/>
+                <a:cs typeface="Helvetica Neue"/>
+              </a:defRPr>
+            </a:pPr>
+            <a:r>
+              <a:t>Yahoo adjusted daily reference bars reproduce the source-era behavior. We show the book-style account and the stricter Gen5 translation separately.</a:t>
+            </a:r>
+          </a:p>
+        </p:txBody>
+      </p:sp>
+      <p:sp>
+        <p:nvSpPr>
+          <p:cNvPr id="3" name="cover-eyebrow">
+            <a:extLst xmlns:a="http://schemas.openxmlformats.org/drawingml/2006/main">
+              <a:ext uri="{FF2B5EF4-FFF2-40B4-BE49-F238E27FC236}">
+                <a16:creationId xmlns:a16="http://schemas.microsoft.com/office/drawing/2014/main" id="{D2399950-CA2D-41D2-BB2E-E681018A573E}"/>
+              </a:ext>
+            </a:extLst>
+          </p:cNvPr>
+          <p:cNvSpPr>
+            <a:spLocks xmlns:a="http://schemas.openxmlformats.org/drawingml/2006/main" noGrp="1"/>
+          </p:cNvSpPr>
+          <p:nvPr/>
+        </p:nvSpPr>
+        <p:spPr>
+          <a:xfrm xmlns:a="http://schemas.openxmlformats.org/drawingml/2006/main">
+            <a:off x="393668" y="392240"/>
+            <a:ext cx="7239000" cy="649129"/>
+          </a:xfrm>
+          <a:prstGeom xmlns:a="http://schemas.openxmlformats.org/drawingml/2006/main" prst="rect">
+            <a:avLst/>
+          </a:prstGeom>
+        </p:spPr>
+        <p:txBody>
+          <a:bodyPr xmlns:a="http://schemas.openxmlformats.org/drawingml/2006/main" lIns="0" tIns="0" rIns="0" bIns="0">
+            <a:normAutofit fontScale="100000"/>
+          </a:bodyPr>
+          <a:lstStyle xmlns:a="http://schemas.openxmlformats.org/drawingml/2006/main"/>
+          <a:p xmlns:a="http://schemas.openxmlformats.org/drawingml/2006/main">
+            <a:pPr algn="l">
+              <a:buNone/>
+              <a:defRPr sz="2250">
+                <a:solidFill>
+                  <a:srgbClr val="000000"/>
+                </a:solidFill>
+                <a:latin typeface="Helvetica Neue"/>
+                <a:ea typeface="Helvetica Neue"/>
+                <a:cs typeface="Helvetica Neue"/>
+              </a:defRPr>
+            </a:pPr>
+            <a:r>
+              <a:t>SOURCE REPRODUCTION | CHAN EXAMPLE 3.2</a:t>
+            </a:r>
+          </a:p>
+        </p:txBody>
+      </p:sp>
+    </p:spTree>
+    <p:extLst>
+      <p:ext uri="{BB962C8B-B14F-4D97-AF65-F5344CB8AC3E}">
+        <p14:creationId xmlns:p14="http://schemas.microsoft.com/office/powerpoint/2010/main" val="2092893396"/>
+      </p:ext>
+    </p:extLst>
+  </p:cSld>
+</p:sld>
+</file>
+
+<file path=ppt/slides/slide31.xml><?xml version="1.0" encoding="utf-8"?>
+<p:sld xmlns:p="http://schemas.openxmlformats.org/presentationml/2006/main">
+  <p:cSld>
+    <p:spTree>
+      <p:nvGrpSpPr>
+        <p:cNvPr id="1" name=""/>
+        <p:cNvGrpSpPr/>
+        <p:nvPr/>
+      </p:nvGrpSpPr>
+      <p:grpSpPr>
+        <a:xfrm xmlns:a="http://schemas.openxmlformats.org/drawingml/2006/main"/>
+      </p:grpSpPr>
+      <p:sp>
+        <p:nvSpPr>
+          <p:cNvPr id="6" name="footer">
+            <a:extLst xmlns:a="http://schemas.openxmlformats.org/drawingml/2006/main">
+              <a:ext uri="{FF2B5EF4-FFF2-40B4-BE49-F238E27FC236}">
+                <a16:creationId xmlns:a16="http://schemas.microsoft.com/office/drawing/2014/main" id="{5D1F4916-B18D-4F3F-8812-75A699D9A639}"/>
+              </a:ext>
+            </a:extLst>
+          </p:cNvPr>
+          <p:cNvSpPr>
+            <a:spLocks xmlns:a="http://schemas.openxmlformats.org/drawingml/2006/main" noGrp="1"/>
+          </p:cNvSpPr>
+          <p:nvPr/>
+        </p:nvSpPr>
+        <p:spPr>
+          <a:xfrm xmlns:a="http://schemas.openxmlformats.org/drawingml/2006/main">
+            <a:off x="11279315" y="6279261"/>
+            <a:ext cx="518922" cy="241268"/>
+          </a:xfrm>
+          <a:prstGeom xmlns:a="http://schemas.openxmlformats.org/drawingml/2006/main" prst="rect">
+            <a:avLst/>
+          </a:prstGeom>
+        </p:spPr>
+        <p:txBody>
+          <a:bodyPr xmlns:a="http://schemas.openxmlformats.org/drawingml/2006/main" lIns="0" tIns="0" rIns="0" bIns="0" anchor="b"/>
+          <a:lstStyle xmlns:a="http://schemas.openxmlformats.org/drawingml/2006/main"/>
+          <a:p xmlns:a="http://schemas.openxmlformats.org/drawingml/2006/main">
+            <a:pPr algn="r">
+              <a:buNone/>
+              <a:defRPr sz="1000">
+                <a:solidFill>
+                  <a:srgbClr val="000000"/>
+                </a:solidFill>
+                <a:latin typeface="Helvetica Neue"/>
+                <a:ea typeface="Helvetica Neue"/>
+                <a:cs typeface="Helvetica Neue"/>
+              </a:defRPr>
+            </a:pPr>
+            <a:r>
+              <a:t>31</a:t>
+            </a:r>
+          </a:p>
+        </p:txBody>
+      </p:sp>
+      <p:sp>
+        <p:nvSpPr>
+          <p:cNvPr id="2" name="title">
+            <a:extLst xmlns:a="http://schemas.openxmlformats.org/drawingml/2006/main">
+              <a:ext uri="{FF2B5EF4-FFF2-40B4-BE49-F238E27FC236}">
+                <a16:creationId xmlns:a16="http://schemas.microsoft.com/office/drawing/2014/main" id="{ECB77D9D-0CB0-4878-9A4A-2687A311CD30}"/>
+              </a:ext>
+            </a:extLst>
+          </p:cNvPr>
+          <p:cNvSpPr>
+            <a:spLocks xmlns:a="http://schemas.openxmlformats.org/drawingml/2006/main" noGrp="1"/>
+          </p:cNvSpPr>
+          <p:nvPr/>
+        </p:nvSpPr>
+        <p:spPr>
+          <a:xfrm xmlns:a="http://schemas.openxmlformats.org/drawingml/2006/main">
+            <a:off x="393668" y="295275"/>
+            <a:ext cx="11404568" cy="876300"/>
+          </a:xfrm>
+          <a:prstGeom xmlns:a="http://schemas.openxmlformats.org/drawingml/2006/main" prst="rect">
+            <a:avLst/>
+          </a:prstGeom>
+        </p:spPr>
+        <p:txBody>
+          <a:bodyPr xmlns:a="http://schemas.openxmlformats.org/drawingml/2006/main" lIns="0" tIns="0" rIns="0" bIns="0" anchor="t">
+            <a:normAutofit fontScale="100000"/>
+          </a:bodyPr>
+          <a:lstStyle xmlns:a="http://schemas.openxmlformats.org/drawingml/2006/main"/>
+          <a:p xmlns:a="http://schemas.openxmlformats.org/drawingml/2006/main">
+            <a:pPr algn="l">
+              <a:buNone/>
+              <a:defRPr sz="2900">
+                <a:solidFill>
+                  <a:srgbClr val="000000"/>
+                </a:solidFill>
+                <a:latin typeface="Helvetica Neue"/>
+                <a:ea typeface="Helvetica Neue"/>
+                <a:cs typeface="Helvetica Neue"/>
+              </a:defRPr>
+            </a:pPr>
+            <a:r>
+              <a:t>The source-period edge survives Gen5 timing and costs</a:t>
+            </a:r>
+          </a:p>
+        </p:txBody>
+      </p:sp>
+      <p:pic>
+        <p:nvPicPr>
+          <p:cNvPr id="10" name=""/>
+          <p:cNvPicPr>
+            <a:picLocks xmlns:a="http://schemas.openxmlformats.org/drawingml/2006/main" noChangeAspect="1"/>
+          </p:cNvPicPr>
+          <p:nvPr/>
+        </p:nvPicPr>
+        <p:blipFill>
+          <a:blip xmlns:r="http://schemas.openxmlformats.org/officeDocument/2006/relationships" xmlns:a="http://schemas.openxmlformats.org/drawingml/2006/main" r:embed="R5b90afa89cdb4fc6"/>
+          <a:stretch xmlns:a="http://schemas.openxmlformats.org/drawingml/2006/main"/>
+        </p:blipFill>
+        <p:spPr>
+          <a:xfrm xmlns:a="http://schemas.openxmlformats.org/drawingml/2006/main">
+            <a:off x="1891393" y="1162050"/>
+            <a:ext cx="8409214" cy="4905375"/>
+          </a:xfrm>
+          <a:prstGeom xmlns:a="http://schemas.openxmlformats.org/drawingml/2006/main" prst="rect">
+            <a:avLst/>
+          </a:prstGeom>
+        </p:spPr>
+      </p:pic>
+    </p:spTree>
+    <p:extLst>
+      <p:ext uri="{BB962C8B-B14F-4D97-AF65-F5344CB8AC3E}">
+        <p14:creationId xmlns:p14="http://schemas.microsoft.com/office/powerpoint/2010/main" val="463436756"/>
+      </p:ext>
+    </p:extLst>
+  </p:cSld>
+</p:sld>
+</file>
+
+<file path=ppt/slides/slide32.xml><?xml version="1.0" encoding="utf-8"?>
+<p:sld xmlns:p="http://schemas.openxmlformats.org/presentationml/2006/main">
+  <p:cSld>
+    <p:spTree>
+      <p:nvGrpSpPr>
+        <p:cNvPr id="1" name=""/>
+        <p:cNvGrpSpPr/>
+        <p:nvPr/>
+      </p:nvGrpSpPr>
+      <p:grpSpPr>
+        <a:xfrm xmlns:a="http://schemas.openxmlformats.org/drawingml/2006/main"/>
+      </p:grpSpPr>
+      <p:sp>
+        <p:nvSpPr>
+          <p:cNvPr id="11" name="footer">
+            <a:extLst xmlns:a="http://schemas.openxmlformats.org/drawingml/2006/main">
+              <a:ext uri="{FF2B5EF4-FFF2-40B4-BE49-F238E27FC236}">
+                <a16:creationId xmlns:a16="http://schemas.microsoft.com/office/drawing/2014/main" id="{231B1CDB-9946-498B-901E-0A0C9C772112}"/>
+              </a:ext>
+            </a:extLst>
+          </p:cNvPr>
+          <p:cNvSpPr>
+            <a:spLocks xmlns:a="http://schemas.openxmlformats.org/drawingml/2006/main" noGrp="1"/>
+          </p:cNvSpPr>
+          <p:nvPr/>
+        </p:nvSpPr>
+        <p:spPr>
+          <a:xfrm xmlns:a="http://schemas.openxmlformats.org/drawingml/2006/main">
+            <a:off x="11279315" y="6279261"/>
+            <a:ext cx="518922" cy="241268"/>
+          </a:xfrm>
+          <a:prstGeom xmlns:a="http://schemas.openxmlformats.org/drawingml/2006/main" prst="rect">
+            <a:avLst/>
+          </a:prstGeom>
+        </p:spPr>
+        <p:txBody>
+          <a:bodyPr xmlns:a="http://schemas.openxmlformats.org/drawingml/2006/main" lIns="0" tIns="0" rIns="0" bIns="0" anchor="b"/>
+          <a:lstStyle xmlns:a="http://schemas.openxmlformats.org/drawingml/2006/main"/>
+          <a:p xmlns:a="http://schemas.openxmlformats.org/drawingml/2006/main">
+            <a:pPr algn="r">
+              <a:buNone/>
+              <a:defRPr sz="1000">
+                <a:solidFill>
+                  <a:srgbClr val="000000"/>
+                </a:solidFill>
+                <a:latin typeface="Helvetica Neue"/>
+                <a:ea typeface="Helvetica Neue"/>
+                <a:cs typeface="Helvetica Neue"/>
+              </a:defRPr>
+            </a:pPr>
+            <a:r>
+              <a:t>32</a:t>
+            </a:r>
+          </a:p>
+        </p:txBody>
+      </p:sp>
+      <p:sp>
+        <p:nvSpPr>
+          <p:cNvPr id="2" name="title">
+            <a:extLst xmlns:a="http://schemas.openxmlformats.org/drawingml/2006/main">
+              <a:ext uri="{FF2B5EF4-FFF2-40B4-BE49-F238E27FC236}">
+                <a16:creationId xmlns:a16="http://schemas.microsoft.com/office/drawing/2014/main" id="{EE1FC061-EE2C-48CF-9799-D8537102BA12}"/>
+              </a:ext>
+            </a:extLst>
+          </p:cNvPr>
+          <p:cNvSpPr>
+            <a:spLocks xmlns:a="http://schemas.openxmlformats.org/drawingml/2006/main" noGrp="1"/>
+          </p:cNvSpPr>
+          <p:nvPr/>
+        </p:nvSpPr>
+        <p:spPr>
+          <a:xfrm xmlns:a="http://schemas.openxmlformats.org/drawingml/2006/main">
+            <a:off x="393668" y="344043"/>
+            <a:ext cx="11404568" cy="1047464"/>
+          </a:xfrm>
+          <a:prstGeom xmlns:a="http://schemas.openxmlformats.org/drawingml/2006/main" prst="rect">
+            <a:avLst/>
+          </a:prstGeom>
+        </p:spPr>
+        <p:txBody>
+          <a:bodyPr xmlns:a="http://schemas.openxmlformats.org/drawingml/2006/main" lIns="0" tIns="0" rIns="0" bIns="0" anchor="t">
+            <a:normAutofit fontScale="100000"/>
+          </a:bodyPr>
+          <a:lstStyle xmlns:a="http://schemas.openxmlformats.org/drawingml/2006/main"/>
+          <a:p xmlns:a="http://schemas.openxmlformats.org/drawingml/2006/main">
+            <a:pPr algn="l">
+              <a:buNone/>
+              <a:defRPr sz="2900">
+                <a:solidFill>
+                  <a:srgbClr val="000000"/>
+                </a:solidFill>
+                <a:latin typeface="Helvetica Neue"/>
+                <a:ea typeface="Helvetica Neue"/>
+                <a:cs typeface="Helvetica Neue"/>
+              </a:defRPr>
+            </a:pPr>
+            <a:r>
+              <a:t>The reproduction lands near Chan’s published headline</a:t>
+            </a:r>
+          </a:p>
+        </p:txBody>
+      </p:sp>
+      <p:sp>
+        <p:nvSpPr>
+          <p:cNvPr id="3" name="left-stat-card">
+            <a:extLst xmlns:a="http://schemas.openxmlformats.org/drawingml/2006/main">
+              <a:ext uri="{FF2B5EF4-FFF2-40B4-BE49-F238E27FC236}">
+                <a16:creationId xmlns:a16="http://schemas.microsoft.com/office/drawing/2014/main" id="{EF0AF18E-87A6-431F-8D4F-59EC894570D3}"/>
+              </a:ext>
+            </a:extLst>
+          </p:cNvPr>
+          <p:cNvSpPr>
+            <a:spLocks xmlns:a="http://schemas.openxmlformats.org/drawingml/2006/main" noGrp="1"/>
+          </p:cNvSpPr>
+          <p:nvPr/>
+        </p:nvSpPr>
+        <p:spPr>
+          <a:xfrm xmlns:a="http://schemas.openxmlformats.org/drawingml/2006/main">
+            <a:off x="6272022" y="3360039"/>
+            <a:ext cx="2581942" cy="2656523"/>
+          </a:xfrm>
+          <a:prstGeom xmlns:a="http://schemas.openxmlformats.org/drawingml/2006/main" prst="roundRect">
+            <a:avLst>
+              <a:gd name="adj" fmla="val 2951"/>
+            </a:avLst>
+          </a:prstGeom>
+          <a:solidFill xmlns:a="http://schemas.openxmlformats.org/drawingml/2006/main">
+            <a:srgbClr val="F2F2F2"/>
+          </a:solidFill>
+        </p:spPr>
+      </p:sp>
+      <p:sp>
+        <p:nvSpPr>
+          <p:cNvPr id="4" name="right-stat-card">
+            <a:extLst xmlns:a="http://schemas.openxmlformats.org/drawingml/2006/main">
+              <a:ext uri="{FF2B5EF4-FFF2-40B4-BE49-F238E27FC236}">
+                <a16:creationId xmlns:a16="http://schemas.microsoft.com/office/drawing/2014/main" id="{9C01B021-FDE1-4776-B2EE-ACB76D126DAD}"/>
+              </a:ext>
+            </a:extLst>
+          </p:cNvPr>
+          <p:cNvSpPr>
+            <a:spLocks xmlns:a="http://schemas.openxmlformats.org/drawingml/2006/main" noGrp="1"/>
+          </p:cNvSpPr>
+          <p:nvPr/>
+        </p:nvSpPr>
+        <p:spPr>
+          <a:xfrm xmlns:a="http://schemas.openxmlformats.org/drawingml/2006/main">
+            <a:off x="9224201" y="3360039"/>
+            <a:ext cx="2581942" cy="2656523"/>
+          </a:xfrm>
+          <a:prstGeom xmlns:a="http://schemas.openxmlformats.org/drawingml/2006/main" prst="roundRect">
+            <a:avLst>
+              <a:gd name="adj" fmla="val 2951"/>
+            </a:avLst>
+          </a:prstGeom>
+          <a:solidFill xmlns:a="http://schemas.openxmlformats.org/drawingml/2006/main">
+            <a:srgbClr val="F2F2F2"/>
+          </a:solidFill>
+        </p:spPr>
+      </p:sp>
+      <p:sp>
+        <p:nvSpPr>
+          <p:cNvPr id="5" name="summary">
+            <a:extLst xmlns:a="http://schemas.openxmlformats.org/drawingml/2006/main">
+              <a:ext uri="{FF2B5EF4-FFF2-40B4-BE49-F238E27FC236}">
+                <a16:creationId xmlns:a16="http://schemas.microsoft.com/office/drawing/2014/main" id="{A2F82FC1-3249-4254-ABAA-A2D0E0F95848}"/>
+              </a:ext>
+            </a:extLst>
+          </p:cNvPr>
+          <p:cNvSpPr>
+            <a:spLocks xmlns:a="http://schemas.openxmlformats.org/drawingml/2006/main" noGrp="1"/>
+          </p:cNvSpPr>
+          <p:nvPr/>
+        </p:nvSpPr>
+        <p:spPr>
+          <a:xfrm xmlns:a="http://schemas.openxmlformats.org/drawingml/2006/main">
+            <a:off x="6261068" y="1714500"/>
+            <a:ext cx="5539835" cy="1381125"/>
+          </a:xfrm>
+          <a:prstGeom xmlns:a="http://schemas.openxmlformats.org/drawingml/2006/main" prst="rect">
+            <a:avLst/>
+          </a:prstGeom>
+        </p:spPr>
+        <p:txBody>
+          <a:bodyPr xmlns:a="http://schemas.openxmlformats.org/drawingml/2006/main" lIns="0" tIns="0" rIns="0" bIns="0" anchor="t">
+            <a:normAutofit fontScale="100000"/>
+          </a:bodyPr>
+          <a:lstStyle xmlns:a="http://schemas.openxmlformats.org/drawingml/2006/main"/>
+          <a:p xmlns:a="http://schemas.openxmlformats.org/drawingml/2006/main">
+            <a:pPr algn="l">
+              <a:buNone/>
+              <a:defRPr sz="1800">
+                <a:solidFill>
+                  <a:srgbClr val="000000"/>
+                </a:solidFill>
+                <a:latin typeface="Helvetica Neue"/>
+                <a:ea typeface="Helvetica Neue"/>
+                <a:cs typeface="Helvetica Neue"/>
+              </a:defRPr>
+            </a:pPr>
+            <a:r>
+              <a:t>Current Yahoo-adjusted data does not match the original data vintage exactly. The difference is retained—not tuned away.</a:t>
+            </a:r>
+          </a:p>
+        </p:txBody>
+      </p:sp>
+      <p:sp>
+        <p:nvSpPr>
+          <p:cNvPr id="6" name="left-stat">
+            <a:extLst xmlns:a="http://schemas.openxmlformats.org/drawingml/2006/main">
+              <a:ext uri="{FF2B5EF4-FFF2-40B4-BE49-F238E27FC236}">
+                <a16:creationId xmlns:a16="http://schemas.microsoft.com/office/drawing/2014/main" id="{06B274F5-6F7E-4432-B0F1-4874DA3CABBF}"/>
+              </a:ext>
+            </a:extLst>
+          </p:cNvPr>
+          <p:cNvSpPr>
+            <a:spLocks xmlns:a="http://schemas.openxmlformats.org/drawingml/2006/main" noGrp="1"/>
+          </p:cNvSpPr>
+          <p:nvPr/>
+        </p:nvSpPr>
+        <p:spPr>
+          <a:xfrm xmlns:a="http://schemas.openxmlformats.org/drawingml/2006/main">
+            <a:off x="6509385" y="3579971"/>
+            <a:ext cx="2133314" cy="1155859"/>
+          </a:xfrm>
+          <a:prstGeom xmlns:a="http://schemas.openxmlformats.org/drawingml/2006/main" prst="rect">
+            <a:avLst/>
+          </a:prstGeom>
+        </p:spPr>
+        <p:txBody>
+          <a:bodyPr xmlns:a="http://schemas.openxmlformats.org/drawingml/2006/main" lIns="0" tIns="0" rIns="0" bIns="0" anchor="b">
+            <a:normAutofit fontScale="100000"/>
+          </a:bodyPr>
+          <a:lstStyle xmlns:a="http://schemas.openxmlformats.org/drawingml/2006/main"/>
+          <a:p xmlns:a="http://schemas.openxmlformats.org/drawingml/2006/main">
+            <a:pPr algn="l">
+              <a:buNone/>
+              <a:defRPr sz="2700">
+                <a:solidFill>
+                  <a:srgbClr val="B42318"/>
+                </a:solidFill>
+                <a:latin typeface="Helvetica Neue"/>
+                <a:ea typeface="Helvetica Neue"/>
+                <a:cs typeface="Helvetica Neue"/>
+              </a:defRPr>
+            </a:pPr>
+            <a:r>
+              <a:t>15.07%</a:t>
+            </a:r>
+          </a:p>
+        </p:txBody>
+      </p:sp>
+      <p:sp>
+        <p:nvSpPr>
+          <p:cNvPr id="7" name="left-stat-label">
+            <a:extLst xmlns:a="http://schemas.openxmlformats.org/drawingml/2006/main">
+              <a:ext uri="{FF2B5EF4-FFF2-40B4-BE49-F238E27FC236}">
+                <a16:creationId xmlns:a16="http://schemas.microsoft.com/office/drawing/2014/main" id="{99D2BB32-1C11-4B29-AF23-ED9F32D0BCEB}"/>
+              </a:ext>
+            </a:extLst>
+          </p:cNvPr>
+          <p:cNvSpPr>
+            <a:spLocks xmlns:a="http://schemas.openxmlformats.org/drawingml/2006/main" noGrp="1"/>
+          </p:cNvSpPr>
+          <p:nvPr/>
+        </p:nvSpPr>
+        <p:spPr>
+          <a:xfrm xmlns:a="http://schemas.openxmlformats.org/drawingml/2006/main">
+            <a:off x="6575965" y="4953000"/>
+            <a:ext cx="2066735" cy="762000"/>
+          </a:xfrm>
+          <a:prstGeom xmlns:a="http://schemas.openxmlformats.org/drawingml/2006/main" prst="rect">
+            <a:avLst/>
+          </a:prstGeom>
+        </p:spPr>
+        <p:txBody>
+          <a:bodyPr xmlns:a="http://schemas.openxmlformats.org/drawingml/2006/main" lIns="0" tIns="0" rIns="0" bIns="0">
+            <a:normAutofit fontScale="100000"/>
+          </a:bodyPr>
+          <a:lstStyle xmlns:a="http://schemas.openxmlformats.org/drawingml/2006/main"/>
+          <a:p xmlns:a="http://schemas.openxmlformats.org/drawingml/2006/main">
+            <a:pPr algn="l">
+              <a:buNone/>
+              <a:defRPr sz="1500">
+                <a:solidFill>
+                  <a:srgbClr val="000000"/>
+                </a:solidFill>
+                <a:latin typeface="Helvetica Neue"/>
+                <a:ea typeface="Helvetica Neue"/>
+                <a:cs typeface="Helvetica Neue"/>
+              </a:defRPr>
+            </a:pPr>
+            <a:r>
+              <a:t>Book-style APR</a:t>
+            </a:r>
+          </a:p>
+          <a:p xmlns:a="http://schemas.openxmlformats.org/drawingml/2006/main">
+            <a:pPr algn="l">
+              <a:buNone/>
+              <a:defRPr sz="1500">
+                <a:solidFill>
+                  <a:srgbClr val="000000"/>
+                </a:solidFill>
+                <a:latin typeface="Helvetica Neue"/>
+                <a:ea typeface="Helvetica Neue"/>
+                <a:cs typeface="Helvetica Neue"/>
+              </a:defRPr>
+            </a:pPr>
+            <a:r>
+              <a:t>Sharpe 0.845</a:t>
+            </a:r>
+          </a:p>
+        </p:txBody>
+      </p:sp>
+      <p:sp>
+        <p:nvSpPr>
+          <p:cNvPr id="8" name="right-stat">
+            <a:extLst xmlns:a="http://schemas.openxmlformats.org/drawingml/2006/main">
+              <a:ext uri="{FF2B5EF4-FFF2-40B4-BE49-F238E27FC236}">
+                <a16:creationId xmlns:a16="http://schemas.microsoft.com/office/drawing/2014/main" id="{2EAFD608-776D-46A1-95EA-79AF4E6F5599}"/>
+              </a:ext>
+            </a:extLst>
+          </p:cNvPr>
+          <p:cNvSpPr>
+            <a:spLocks xmlns:a="http://schemas.openxmlformats.org/drawingml/2006/main" noGrp="1"/>
+          </p:cNvSpPr>
+          <p:nvPr/>
+        </p:nvSpPr>
+        <p:spPr>
+          <a:xfrm xmlns:a="http://schemas.openxmlformats.org/drawingml/2006/main">
+            <a:off x="9461564" y="3579971"/>
+            <a:ext cx="2133314" cy="1155859"/>
+          </a:xfrm>
+          <a:prstGeom xmlns:a="http://schemas.openxmlformats.org/drawingml/2006/main" prst="rect">
+            <a:avLst/>
+          </a:prstGeom>
+        </p:spPr>
+        <p:txBody>
+          <a:bodyPr xmlns:a="http://schemas.openxmlformats.org/drawingml/2006/main" lIns="0" tIns="0" rIns="0" bIns="0" anchor="b">
+            <a:normAutofit fontScale="100000"/>
+          </a:bodyPr>
+          <a:lstStyle xmlns:a="http://schemas.openxmlformats.org/drawingml/2006/main"/>
+          <a:p xmlns:a="http://schemas.openxmlformats.org/drawingml/2006/main">
+            <a:pPr algn="l">
+              <a:buNone/>
+              <a:defRPr sz="2700">
+                <a:solidFill>
+                  <a:srgbClr val="B42318"/>
+                </a:solidFill>
+                <a:latin typeface="Helvetica Neue"/>
+                <a:ea typeface="Helvetica Neue"/>
+                <a:cs typeface="Helvetica Neue"/>
+              </a:defRPr>
+            </a:pPr>
+            <a:r>
+              <a:t>12.93%</a:t>
+            </a:r>
+          </a:p>
+        </p:txBody>
+      </p:sp>
+      <p:sp>
+        <p:nvSpPr>
+          <p:cNvPr id="9" name="right-stat-label">
+            <a:extLst xmlns:a="http://schemas.openxmlformats.org/drawingml/2006/main">
+              <a:ext uri="{FF2B5EF4-FFF2-40B4-BE49-F238E27FC236}">
+                <a16:creationId xmlns:a16="http://schemas.microsoft.com/office/drawing/2014/main" id="{691BF8AE-236E-4677-8EAF-3CF0D5A20DB6}"/>
+              </a:ext>
+            </a:extLst>
+          </p:cNvPr>
+          <p:cNvSpPr>
+            <a:spLocks xmlns:a="http://schemas.openxmlformats.org/drawingml/2006/main" noGrp="1"/>
+          </p:cNvSpPr>
+          <p:nvPr/>
+        </p:nvSpPr>
+        <p:spPr>
+          <a:xfrm xmlns:a="http://schemas.openxmlformats.org/drawingml/2006/main">
+            <a:off x="9528143" y="4953000"/>
+            <a:ext cx="2066735" cy="762000"/>
+          </a:xfrm>
+          <a:prstGeom xmlns:a="http://schemas.openxmlformats.org/drawingml/2006/main" prst="rect">
+            <a:avLst/>
+          </a:prstGeom>
+        </p:spPr>
+        <p:txBody>
+          <a:bodyPr xmlns:a="http://schemas.openxmlformats.org/drawingml/2006/main" lIns="0" tIns="0" rIns="0" bIns="0">
+            <a:normAutofit fontScale="100000"/>
+          </a:bodyPr>
+          <a:lstStyle xmlns:a="http://schemas.openxmlformats.org/drawingml/2006/main"/>
+          <a:p xmlns:a="http://schemas.openxmlformats.org/drawingml/2006/main">
+            <a:pPr algn="l">
+              <a:buNone/>
+              <a:defRPr sz="1500">
+                <a:solidFill>
+                  <a:srgbClr val="000000"/>
+                </a:solidFill>
+                <a:latin typeface="Helvetica Neue"/>
+                <a:ea typeface="Helvetica Neue"/>
+                <a:cs typeface="Helvetica Neue"/>
+              </a:defRPr>
+            </a:pPr>
+            <a:r>
+              <a:t>Gen5 APR</a:t>
+            </a:r>
+          </a:p>
+          <a:p xmlns:a="http://schemas.openxmlformats.org/drawingml/2006/main">
+            <a:pPr algn="l">
+              <a:buNone/>
+              <a:defRPr sz="1500">
+                <a:solidFill>
+                  <a:srgbClr val="000000"/>
+                </a:solidFill>
+                <a:latin typeface="Helvetica Neue"/>
+                <a:ea typeface="Helvetica Neue"/>
+                <a:cs typeface="Helvetica Neue"/>
+              </a:defRPr>
+            </a:pPr>
+            <a:r>
+              <a:t>Sharpe 0.933</a:t>
+            </a:r>
+          </a:p>
+        </p:txBody>
+      </p:sp>
+      <p:pic>
+        <p:nvPicPr>
+          <p:cNvPr id="22" name=""/>
+          <p:cNvPicPr>
+            <a:picLocks xmlns:a="http://schemas.openxmlformats.org/drawingml/2006/main" noChangeAspect="1"/>
+          </p:cNvPicPr>
+          <p:nvPr/>
+        </p:nvPicPr>
+        <p:blipFill>
+          <a:blip xmlns:r="http://schemas.openxmlformats.org/officeDocument/2006/relationships" xmlns:a="http://schemas.openxmlformats.org/drawingml/2006/main" r:embed="Redc828645bd54289"/>
+          <a:stretch xmlns:a="http://schemas.openxmlformats.org/drawingml/2006/main"/>
+        </p:blipFill>
+        <p:spPr>
+          <a:xfrm xmlns:a="http://schemas.openxmlformats.org/drawingml/2006/main">
+            <a:off x="781159" y="2378774"/>
+            <a:ext cx="4743613" cy="2767108"/>
+          </a:xfrm>
+          <a:prstGeom xmlns:a="http://schemas.openxmlformats.org/drawingml/2006/main" prst="rect">
+            <a:avLst/>
+          </a:prstGeom>
+        </p:spPr>
+      </p:pic>
+    </p:spTree>
+    <p:extLst>
+      <p:ext uri="{BB962C8B-B14F-4D97-AF65-F5344CB8AC3E}">
+        <p14:creationId xmlns:p14="http://schemas.microsoft.com/office/powerpoint/2010/main" val="91287502"/>
+      </p:ext>
+    </p:extLst>
+  </p:cSld>
+</p:sld>
+</file>
+
+<file path=ppt/slides/slide33.xml><?xml version="1.0" encoding="utf-8"?>
+<p:sld xmlns:p="http://schemas.openxmlformats.org/presentationml/2006/main">
+  <p:cSld>
+    <p:spTree>
+      <p:nvGrpSpPr>
+        <p:cNvPr id="1" name=""/>
+        <p:cNvGrpSpPr/>
+        <p:nvPr/>
+      </p:nvGrpSpPr>
+      <p:grpSpPr>
+        <a:xfrm xmlns:a="http://schemas.openxmlformats.org/drawingml/2006/main"/>
+      </p:grpSpPr>
+      <p:sp>
+        <p:nvSpPr>
+          <p:cNvPr id="4" name="cover-headline">
+            <a:extLst xmlns:a="http://schemas.openxmlformats.org/drawingml/2006/main">
+              <a:ext uri="{FF2B5EF4-FFF2-40B4-BE49-F238E27FC236}">
+                <a16:creationId xmlns:a16="http://schemas.microsoft.com/office/drawing/2014/main" id="{E9F43BB9-4202-4A42-9916-7A06678333BD}"/>
+              </a:ext>
+            </a:extLst>
+          </p:cNvPr>
+          <p:cNvSpPr>
+            <a:spLocks xmlns:a="http://schemas.openxmlformats.org/drawingml/2006/main" noGrp="1"/>
+          </p:cNvSpPr>
+          <p:nvPr/>
+        </p:nvSpPr>
+        <p:spPr>
+          <a:xfrm xmlns:a="http://schemas.openxmlformats.org/drawingml/2006/main">
+            <a:off x="393668" y="1738789"/>
+            <a:ext cx="10287000" cy="2491454"/>
+          </a:xfrm>
+          <a:prstGeom xmlns:a="http://schemas.openxmlformats.org/drawingml/2006/main" prst="rect">
+            <a:avLst/>
+          </a:prstGeom>
+        </p:spPr>
+        <p:txBody>
+          <a:bodyPr xmlns:a="http://schemas.openxmlformats.org/drawingml/2006/main" lIns="0" tIns="0" rIns="0" bIns="0" anchor="b">
+            <a:normAutofit fontScale="100000"/>
+          </a:bodyPr>
+          <a:lstStyle xmlns:a="http://schemas.openxmlformats.org/drawingml/2006/main"/>
+          <a:p xmlns:a="http://schemas.openxmlformats.org/drawingml/2006/main">
+            <a:pPr algn="l">
+              <a:buNone/>
+              <a:defRPr sz="5700">
+                <a:solidFill>
+                  <a:srgbClr val="000000"/>
+                </a:solidFill>
+                <a:latin typeface="Helvetica Neue"/>
+                <a:ea typeface="Helvetica Neue"/>
+                <a:cs typeface="Helvetica Neue"/>
+              </a:defRPr>
+            </a:pPr>
+            <a:r>
+              <a:t>The mechanism can work.</a:t>
+            </a:r>
+          </a:p>
+          <a:p xmlns:a="http://schemas.openxmlformats.org/drawingml/2006/main">
+            <a:pPr algn="l">
+              <a:buNone/>
+              <a:defRPr sz="5700">
+                <a:solidFill>
+                  <a:srgbClr val="000000"/>
+                </a:solidFill>
+                <a:latin typeface="Helvetica Neue"/>
+                <a:ea typeface="Helvetica Neue"/>
+                <a:cs typeface="Helvetica Neue"/>
+              </a:defRPr>
+            </a:pPr>
+            <a:r>
+              <a:t>It did not persist broadly.</a:t>
+            </a:r>
+          </a:p>
+        </p:txBody>
+      </p:sp>
+      <p:sp>
+        <p:nvSpPr>
+          <p:cNvPr id="2" name="cover-subtitle">
+            <a:extLst xmlns:a="http://schemas.openxmlformats.org/drawingml/2006/main">
+              <a:ext uri="{FF2B5EF4-FFF2-40B4-BE49-F238E27FC236}">
+                <a16:creationId xmlns:a16="http://schemas.microsoft.com/office/drawing/2014/main" id="{F6F90063-BA30-438B-9FD3-13AA22719785}"/>
+              </a:ext>
+            </a:extLst>
+          </p:cNvPr>
+          <p:cNvSpPr>
+            <a:spLocks xmlns:a="http://schemas.openxmlformats.org/drawingml/2006/main" noGrp="1"/>
+          </p:cNvSpPr>
+          <p:nvPr/>
+        </p:nvSpPr>
+        <p:spPr>
+          <a:xfrm xmlns:a="http://schemas.openxmlformats.org/drawingml/2006/main">
+            <a:off x="393668" y="4762500"/>
+            <a:ext cx="8001000" cy="1238250"/>
+          </a:xfrm>
+          <a:prstGeom xmlns:a="http://schemas.openxmlformats.org/drawingml/2006/main" prst="rect">
+            <a:avLst/>
+          </a:prstGeom>
+        </p:spPr>
+        <p:txBody>
+          <a:bodyPr xmlns:a="http://schemas.openxmlformats.org/drawingml/2006/main" lIns="0" tIns="0" rIns="0" bIns="0">
+            <a:normAutofit fontScale="100000"/>
+          </a:bodyPr>
+          <a:lstStyle xmlns:a="http://schemas.openxmlformats.org/drawingml/2006/main"/>
+          <a:p xmlns:a="http://schemas.openxmlformats.org/drawingml/2006/main">
+            <a:pPr algn="l">
+              <a:buNone/>
+              <a:defRPr sz="2250">
+                <a:solidFill>
+                  <a:srgbClr val="000000"/>
+                </a:solidFill>
+                <a:latin typeface="Helvetica Neue"/>
+                <a:ea typeface="Helvetica Neue"/>
+                <a:cs typeface="Helvetica Neue"/>
+              </a:defRPr>
+            </a:pPr>
+            <a:r>
+              <a:t>Keep the 2018 and 2006–2012 results as positive controls. Keep the five-year and 27-pair STOPs intact, and move on without rescuing or retuning LIT-MR-02.1.</a:t>
+            </a:r>
+          </a:p>
+        </p:txBody>
+      </p:sp>
+      <p:sp>
+        <p:nvSpPr>
+          <p:cNvPr id="3" name="cover-eyebrow">
+            <a:extLst xmlns:a="http://schemas.openxmlformats.org/drawingml/2006/main">
+              <a:ext uri="{FF2B5EF4-FFF2-40B4-BE49-F238E27FC236}">
+                <a16:creationId xmlns:a16="http://schemas.microsoft.com/office/drawing/2014/main" id="{45129715-75DE-4D50-B44D-3AFE3EBA3F0E}"/>
+              </a:ext>
+            </a:extLst>
+          </p:cNvPr>
+          <p:cNvSpPr>
+            <a:spLocks xmlns:a="http://schemas.openxmlformats.org/drawingml/2006/main" noGrp="1"/>
+          </p:cNvSpPr>
+          <p:nvPr/>
+        </p:nvSpPr>
+        <p:spPr>
+          <a:xfrm xmlns:a="http://schemas.openxmlformats.org/drawingml/2006/main">
+            <a:off x="393668" y="392240"/>
+            <a:ext cx="7239000" cy="649129"/>
+          </a:xfrm>
+          <a:prstGeom xmlns:a="http://schemas.openxmlformats.org/drawingml/2006/main" prst="rect">
+            <a:avLst/>
+          </a:prstGeom>
+        </p:spPr>
+        <p:txBody>
+          <a:bodyPr xmlns:a="http://schemas.openxmlformats.org/drawingml/2006/main" lIns="0" tIns="0" rIns="0" bIns="0">
+            <a:normAutofit fontScale="100000"/>
+          </a:bodyPr>
+          <a:lstStyle xmlns:a="http://schemas.openxmlformats.org/drawingml/2006/main"/>
+          <a:p xmlns:a="http://schemas.openxmlformats.org/drawingml/2006/main">
+            <a:pPr algn="l">
+              <a:buNone/>
+              <a:defRPr sz="2250">
+                <a:solidFill>
+                  <a:srgbClr val="000000"/>
+                </a:solidFill>
+                <a:latin typeface="Helvetica Neue"/>
+                <a:ea typeface="Helvetica Neue"/>
+                <a:cs typeface="Helvetica Neue"/>
+              </a:defRPr>
+            </a:pPr>
+            <a:r>
+              <a:t>DECISION</a:t>
+            </a:r>
+          </a:p>
+        </p:txBody>
+      </p:sp>
+    </p:spTree>
+    <p:extLst>
+      <p:ext uri="{BB962C8B-B14F-4D97-AF65-F5344CB8AC3E}">
+        <p14:creationId xmlns:p14="http://schemas.microsoft.com/office/powerpoint/2010/main" val="1664240194"/>
       </p:ext>
     </p:extLst>
   </p:cSld>
@@ -11919,7 +14528,7 @@
           <p:nvPr/>
         </p:nvPicPr>
         <p:blipFill>
-          <a:blip xmlns:r="http://schemas.openxmlformats.org/officeDocument/2006/relationships" xmlns:a="http://schemas.openxmlformats.org/drawingml/2006/main" r:embed="R57944cef7cf54554"/>
+          <a:blip xmlns:r="http://schemas.openxmlformats.org/officeDocument/2006/relationships" xmlns:a="http://schemas.openxmlformats.org/drawingml/2006/main" r:embed="Rf426af2b6bc94e07"/>
           <a:stretch xmlns:a="http://schemas.openxmlformats.org/drawingml/2006/main"/>
         </p:blipFill>
         <p:spPr>
@@ -11974,7 +14583,7 @@
           <p:nvPr/>
         </p:nvPicPr>
         <p:blipFill>
-          <a:blip xmlns:r="http://schemas.openxmlformats.org/officeDocument/2006/relationships" xmlns:a="http://schemas.openxmlformats.org/drawingml/2006/main" r:embed="Ra9ed94faefcd414b"/>
+          <a:blip xmlns:r="http://schemas.openxmlformats.org/officeDocument/2006/relationships" xmlns:a="http://schemas.openxmlformats.org/drawingml/2006/main" r:embed="R26ea4091070d4101"/>
           <a:stretch xmlns:a="http://schemas.openxmlformats.org/drawingml/2006/main"/>
         </p:blipFill>
         <p:spPr>

</xml_diff>

<commit_message>
Add relationship atlas and Johansen triplet POCs
</commit_message>
<xml_diff>
--- a/presentations/gen5_lit_mr_02_1_bollinger_evidence.pptx
+++ b/presentations/gen5_lit_mr_02_1_bollinger_evidence.pptx
@@ -2,45 +2,51 @@
 <file path=ppt/presentation.xml><?xml version="1.0" encoding="utf-8"?>
 <p:presentation xmlns:p="http://schemas.openxmlformats.org/presentationml/2006/main">
   <p:sldMasterIdLst>
-    <p:sldMasterId xmlns:r="http://schemas.openxmlformats.org/officeDocument/2006/relationships" id="2147483648" r:id="R0ff1918952ef4807"/>
+    <p:sldMasterId xmlns:r="http://schemas.openxmlformats.org/officeDocument/2006/relationships" id="2147483648" r:id="Recff753aecec4cee"/>
   </p:sldMasterIdLst>
   <p:notesMasterIdLst>
-    <p:notesMasterId xmlns:r="http://schemas.openxmlformats.org/officeDocument/2006/relationships" r:id="Rdb7b1a1873cb411e"/>
+    <p:notesMasterId xmlns:r="http://schemas.openxmlformats.org/officeDocument/2006/relationships" r:id="R2ef1eeee6f3843a1"/>
   </p:notesMasterIdLst>
   <p:sldIdLst>
-    <p:sldId xmlns:r="http://schemas.openxmlformats.org/officeDocument/2006/relationships" id="256" r:id="Rba525469a78f4593"/>
-    <p:sldId xmlns:r="http://schemas.openxmlformats.org/officeDocument/2006/relationships" id="257" r:id="Rac7dc99e3c2945db"/>
-    <p:sldId xmlns:r="http://schemas.openxmlformats.org/officeDocument/2006/relationships" id="258" r:id="R0fc6a863c5d14b8a"/>
-    <p:sldId xmlns:r="http://schemas.openxmlformats.org/officeDocument/2006/relationships" id="259" r:id="R340af81d15b04cf0"/>
-    <p:sldId xmlns:r="http://schemas.openxmlformats.org/officeDocument/2006/relationships" id="260" r:id="R5f5e47bd1fde46aa"/>
-    <p:sldId xmlns:r="http://schemas.openxmlformats.org/officeDocument/2006/relationships" id="261" r:id="R4a8b179aa0684b01"/>
-    <p:sldId xmlns:r="http://schemas.openxmlformats.org/officeDocument/2006/relationships" id="262" r:id="R482f6db5378e4390"/>
-    <p:sldId xmlns:r="http://schemas.openxmlformats.org/officeDocument/2006/relationships" id="263" r:id="Rf4dc6912db4e43f6"/>
-    <p:sldId xmlns:r="http://schemas.openxmlformats.org/officeDocument/2006/relationships" id="264" r:id="Rbef6d66ce822439f"/>
-    <p:sldId xmlns:r="http://schemas.openxmlformats.org/officeDocument/2006/relationships" id="265" r:id="R140d588a27ac466f"/>
-    <p:sldId xmlns:r="http://schemas.openxmlformats.org/officeDocument/2006/relationships" id="266" r:id="Raf7eae2e1fc14c03"/>
-    <p:sldId xmlns:r="http://schemas.openxmlformats.org/officeDocument/2006/relationships" id="267" r:id="R3f8e65828b034c0c"/>
-    <p:sldId xmlns:r="http://schemas.openxmlformats.org/officeDocument/2006/relationships" id="268" r:id="Ra0b50b82f28b48ce"/>
-    <p:sldId xmlns:r="http://schemas.openxmlformats.org/officeDocument/2006/relationships" id="269" r:id="R54116230a2fb48f1"/>
-    <p:sldId xmlns:r="http://schemas.openxmlformats.org/officeDocument/2006/relationships" id="270" r:id="Rb11bb6e2ec254291"/>
-    <p:sldId xmlns:r="http://schemas.openxmlformats.org/officeDocument/2006/relationships" id="271" r:id="R559966ba248648c4"/>
-    <p:sldId xmlns:r="http://schemas.openxmlformats.org/officeDocument/2006/relationships" id="272" r:id="R36e1f00029774c5d"/>
-    <p:sldId xmlns:r="http://schemas.openxmlformats.org/officeDocument/2006/relationships" id="273" r:id="R501d17a74ffa4e95"/>
-    <p:sldId xmlns:r="http://schemas.openxmlformats.org/officeDocument/2006/relationships" id="274" r:id="R80e31e3ec9524f43"/>
-    <p:sldId xmlns:r="http://schemas.openxmlformats.org/officeDocument/2006/relationships" id="275" r:id="R6e9ce5f4b3184b05"/>
-    <p:sldId xmlns:r="http://schemas.openxmlformats.org/officeDocument/2006/relationships" id="276" r:id="R2e74613cd04f40fa"/>
-    <p:sldId xmlns:r="http://schemas.openxmlformats.org/officeDocument/2006/relationships" id="277" r:id="R98de95311e4c4ef7"/>
-    <p:sldId xmlns:r="http://schemas.openxmlformats.org/officeDocument/2006/relationships" id="278" r:id="Rba2b5cdbef0e4f64"/>
-    <p:sldId xmlns:r="http://schemas.openxmlformats.org/officeDocument/2006/relationships" id="279" r:id="Rec86ed4710c74328"/>
-    <p:sldId xmlns:r="http://schemas.openxmlformats.org/officeDocument/2006/relationships" id="280" r:id="R8035548227094914"/>
-    <p:sldId xmlns:r="http://schemas.openxmlformats.org/officeDocument/2006/relationships" id="281" r:id="R5f6bf38ac69d48c2"/>
-    <p:sldId xmlns:r="http://schemas.openxmlformats.org/officeDocument/2006/relationships" id="282" r:id="R2a80033bf24f49a6"/>
-    <p:sldId xmlns:r="http://schemas.openxmlformats.org/officeDocument/2006/relationships" id="283" r:id="R6c933ae295984898"/>
-    <p:sldId xmlns:r="http://schemas.openxmlformats.org/officeDocument/2006/relationships" id="284" r:id="Rbead07570f5a4ab1"/>
-    <p:sldId xmlns:r="http://schemas.openxmlformats.org/officeDocument/2006/relationships" id="285" r:id="R8148dca2dbbb4578"/>
-    <p:sldId xmlns:r="http://schemas.openxmlformats.org/officeDocument/2006/relationships" id="286" r:id="Rf945799aa9ba4d34"/>
-    <p:sldId xmlns:r="http://schemas.openxmlformats.org/officeDocument/2006/relationships" id="287" r:id="R997b1c070c794914"/>
-    <p:sldId xmlns:r="http://schemas.openxmlformats.org/officeDocument/2006/relationships" id="288" r:id="Rf5b013401a334102"/>
+    <p:sldId xmlns:r="http://schemas.openxmlformats.org/officeDocument/2006/relationships" id="256" r:id="Ra61263b49e094a32"/>
+    <p:sldId xmlns:r="http://schemas.openxmlformats.org/officeDocument/2006/relationships" id="257" r:id="R40840131fa164931"/>
+    <p:sldId xmlns:r="http://schemas.openxmlformats.org/officeDocument/2006/relationships" id="258" r:id="R2f588c39f1fb45e1"/>
+    <p:sldId xmlns:r="http://schemas.openxmlformats.org/officeDocument/2006/relationships" id="259" r:id="R7b022bc4d61d4a90"/>
+    <p:sldId xmlns:r="http://schemas.openxmlformats.org/officeDocument/2006/relationships" id="260" r:id="Rdf476f790bab420b"/>
+    <p:sldId xmlns:r="http://schemas.openxmlformats.org/officeDocument/2006/relationships" id="261" r:id="Rd23997abb0164d11"/>
+    <p:sldId xmlns:r="http://schemas.openxmlformats.org/officeDocument/2006/relationships" id="262" r:id="R0ac23751d4bd4a80"/>
+    <p:sldId xmlns:r="http://schemas.openxmlformats.org/officeDocument/2006/relationships" id="263" r:id="R9eda095615234dce"/>
+    <p:sldId xmlns:r="http://schemas.openxmlformats.org/officeDocument/2006/relationships" id="264" r:id="R4270662c9a8b4ed5"/>
+    <p:sldId xmlns:r="http://schemas.openxmlformats.org/officeDocument/2006/relationships" id="265" r:id="R23ac30411cf8461c"/>
+    <p:sldId xmlns:r="http://schemas.openxmlformats.org/officeDocument/2006/relationships" id="266" r:id="R4478d82e932b441c"/>
+    <p:sldId xmlns:r="http://schemas.openxmlformats.org/officeDocument/2006/relationships" id="267" r:id="R54035be7dcac48c4"/>
+    <p:sldId xmlns:r="http://schemas.openxmlformats.org/officeDocument/2006/relationships" id="268" r:id="Rc4986935cde24ff3"/>
+    <p:sldId xmlns:r="http://schemas.openxmlformats.org/officeDocument/2006/relationships" id="269" r:id="Rf6f964c24dae449f"/>
+    <p:sldId xmlns:r="http://schemas.openxmlformats.org/officeDocument/2006/relationships" id="270" r:id="R8f4274737dd14f29"/>
+    <p:sldId xmlns:r="http://schemas.openxmlformats.org/officeDocument/2006/relationships" id="271" r:id="R4d9d18eeb1fc4bad"/>
+    <p:sldId xmlns:r="http://schemas.openxmlformats.org/officeDocument/2006/relationships" id="272" r:id="R0a9a0e039c664c55"/>
+    <p:sldId xmlns:r="http://schemas.openxmlformats.org/officeDocument/2006/relationships" id="273" r:id="R71061c3856054dd8"/>
+    <p:sldId xmlns:r="http://schemas.openxmlformats.org/officeDocument/2006/relationships" id="274" r:id="Rcddf92a154d34c34"/>
+    <p:sldId xmlns:r="http://schemas.openxmlformats.org/officeDocument/2006/relationships" id="275" r:id="Rf39be58a8a834629"/>
+    <p:sldId xmlns:r="http://schemas.openxmlformats.org/officeDocument/2006/relationships" id="276" r:id="R4b0ce1daf0f746c0"/>
+    <p:sldId xmlns:r="http://schemas.openxmlformats.org/officeDocument/2006/relationships" id="277" r:id="R278386d82f2142fa"/>
+    <p:sldId xmlns:r="http://schemas.openxmlformats.org/officeDocument/2006/relationships" id="278" r:id="Ra79224eaa71447af"/>
+    <p:sldId xmlns:r="http://schemas.openxmlformats.org/officeDocument/2006/relationships" id="279" r:id="Rc6dbf72810b1421f"/>
+    <p:sldId xmlns:r="http://schemas.openxmlformats.org/officeDocument/2006/relationships" id="280" r:id="R270294d737644d2a"/>
+    <p:sldId xmlns:r="http://schemas.openxmlformats.org/officeDocument/2006/relationships" id="281" r:id="R177f0d036b974123"/>
+    <p:sldId xmlns:r="http://schemas.openxmlformats.org/officeDocument/2006/relationships" id="282" r:id="R310f18afe272401c"/>
+    <p:sldId xmlns:r="http://schemas.openxmlformats.org/officeDocument/2006/relationships" id="283" r:id="Rf5f51eac483f4d77"/>
+    <p:sldId xmlns:r="http://schemas.openxmlformats.org/officeDocument/2006/relationships" id="284" r:id="Rb0afc1daf1fb4793"/>
+    <p:sldId xmlns:r="http://schemas.openxmlformats.org/officeDocument/2006/relationships" id="285" r:id="Rc682c14c2cb148da"/>
+    <p:sldId xmlns:r="http://schemas.openxmlformats.org/officeDocument/2006/relationships" id="286" r:id="Rd19b543396a34276"/>
+    <p:sldId xmlns:r="http://schemas.openxmlformats.org/officeDocument/2006/relationships" id="287" r:id="R0d592c7a58674688"/>
+    <p:sldId xmlns:r="http://schemas.openxmlformats.org/officeDocument/2006/relationships" id="288" r:id="R6d6723ba404f4fd2"/>
+    <p:sldId xmlns:r="http://schemas.openxmlformats.org/officeDocument/2006/relationships" id="289" r:id="R4e4cc931083e4e98"/>
+    <p:sldId xmlns:r="http://schemas.openxmlformats.org/officeDocument/2006/relationships" id="290" r:id="R322d7d0ed59e42ae"/>
+    <p:sldId xmlns:r="http://schemas.openxmlformats.org/officeDocument/2006/relationships" id="291" r:id="R535eb97c3bd44199"/>
+    <p:sldId xmlns:r="http://schemas.openxmlformats.org/officeDocument/2006/relationships" id="292" r:id="Rd01389a7ddc348b3"/>
+    <p:sldId xmlns:r="http://schemas.openxmlformats.org/officeDocument/2006/relationships" id="293" r:id="R0364766d4cab4777"/>
+    <p:sldId xmlns:r="http://schemas.openxmlformats.org/officeDocument/2006/relationships" id="294" r:id="Rf35d415ef6884874"/>
   </p:sldIdLst>
   <p:sldSz cx="12192000" cy="6858000"/>
   <p:notesSz cx="6858000" cy="9144000"/>
@@ -474,7 +480,7 @@
           <a:lstStyle xmlns:a="http://schemas.openxmlformats.org/drawingml/2006/main"/>
           <a:p xmlns:a="http://schemas.openxmlformats.org/drawingml/2006/main">
             <a:r>
-              <a:t>This revision preserves the canonical example and Panel A, explains the exact gate logic, and adds the predeclared 15-pair diversified Panel B.</a:t>
+              <a:t>The deck now preserves the original example, Panels A and B, the 2018 and source-period positive controls, and Relationship Atlas 01 as a separate frozen instance batch.</a:t>
             </a:r>
           </a:p>
           <a:p xmlns:a="http://schemas.openxmlformats.org/drawingml/2006/main">
@@ -494,12 +500,12 @@
           </a:p>
           <a:p xmlns:a="http://schemas.openxmlformats.org/drawingml/2006/main">
             <a:r>
-              <a:t>- C:/Users/Franc/OneDrive/Documents/Francis/Peltata Project/Time-Series-Modeling-Gen5/docs/GEN5_LIT_MR_02_1_PANEL_A_CONTRACT.md</a:t>
-            </a:r>
-          </a:p>
-          <a:p xmlns:a="http://schemas.openxmlformats.org/drawingml/2006/main">
-            <a:r>
-              <a:t>- C:/Users/Franc/OneDrive/Documents/Francis/Peltata Project/Time-Series-Modeling-Gen5/docs/GEN5_LIT_MR_02_1_PANEL_B_CONTRACT.md</a:t>
+              <a:t>- C:/Users/Franc/OneDrive/Documents/Francis/Peltata Project/Time-Series-Modeling-Gen5/docs/GEN5_LIT_MR_02_1_RELATIONSHIP_ATLAS_01_CONTRACT.md</a:t>
+            </a:r>
+          </a:p>
+          <a:p xmlns:a="http://schemas.openxmlformats.org/drawingml/2006/main">
+            <a:r>
+              <a:t>- C:/Users/Franc/OneDrive/Documents/Francis/Peltata Project/Time-Series-Modeling-Gen5/docs/GEN5_4_DECISION_DIALOGUE_INDEX.md — D73 and D75</a:t>
             </a:r>
           </a:p>
         </p:txBody>
@@ -3005,6 +3011,581 @@
           <a:p xmlns:a="http://schemas.openxmlformats.org/drawingml/2006/main">
             <a:r>
               <a:t>- C:/Users/Franc/OneDrive/Documents/Francis/Peltata Project/Time-Series-Modeling-Gen5/docs/GEN5_LIT_MR_02_1_ADAPTIVE_SPREAD_BOLLINGER_POC_CONTRACT.md</a:t>
+            </a:r>
+          </a:p>
+        </p:txBody>
+      </p:sp>
+      <p:sp>
+        <p:nvSpPr>
+          <p:cNvPr id="4" name="Slide Number Placeholder 3"/>
+          <p:cNvSpPr>
+            <a:spLocks xmlns:a="http://schemas.openxmlformats.org/drawingml/2006/main" noGrp="1"/>
+          </p:cNvSpPr>
+          <p:nvPr>
+            <p:ph type="sldNum" idx="5"/>
+          </p:nvPr>
+        </p:nvSpPr>
+        <p:spPr/>
+        <p:txBody>
+          <a:bodyPr xmlns:a="http://schemas.openxmlformats.org/drawingml/2006/main"/>
+          <a:lstStyle xmlns:a="http://schemas.openxmlformats.org/drawingml/2006/main"/>
+          <a:p xmlns:a="http://schemas.openxmlformats.org/drawingml/2006/main"/>
+        </p:txBody>
+      </p:sp>
+    </p:spTree>
+  </p:cSld>
+  <p:clrMapOvr>
+    <a:masterClrMapping xmlns:a="http://schemas.openxmlformats.org/drawingml/2006/main"/>
+  </p:clrMapOvr>
+</p:notes>
+</file>
+
+<file path=ppt/notesSlides/notesSlide34.xml><?xml version="1.0" encoding="utf-8"?>
+<p:notes xmlns:p="http://schemas.openxmlformats.org/presentationml/2006/main">
+  <p:cSld>
+    <p:spTree>
+      <p:nvGrpSpPr>
+        <p:cNvPr id="1" name=""/>
+        <p:cNvGrpSpPr/>
+        <p:nvPr/>
+      </p:nvGrpSpPr>
+      <p:grpSpPr>
+        <a:xfrm xmlns:a="http://schemas.openxmlformats.org/drawingml/2006/main"/>
+      </p:grpSpPr>
+      <p:sp>
+        <p:nvSpPr>
+          <p:cNvPr id="2" name="Slide Image Placeholder 1"/>
+          <p:cNvSpPr>
+            <a:spLocks xmlns:a="http://schemas.openxmlformats.org/drawingml/2006/main" noGrp="1"/>
+          </p:cNvSpPr>
+          <p:nvPr>
+            <p:ph type="sldImg" idx="0"/>
+          </p:nvPr>
+        </p:nvSpPr>
+        <p:spPr/>
+      </p:sp>
+      <p:sp>
+        <p:nvSpPr>
+          <p:cNvPr id="3" name="Notes Placeholder 2"/>
+          <p:cNvSpPr>
+            <a:spLocks xmlns:a="http://schemas.openxmlformats.org/drawingml/2006/main" noGrp="1"/>
+          </p:cNvSpPr>
+          <p:nvPr>
+            <p:ph type="body" idx="1"/>
+          </p:nvPr>
+        </p:nvSpPr>
+        <p:spPr/>
+        <p:txBody>
+          <a:bodyPr xmlns:a="http://schemas.openxmlformats.org/drawingml/2006/main"/>
+          <a:lstStyle xmlns:a="http://schemas.openxmlformats.org/drawingml/2006/main"/>
+          <a:p xmlns:a="http://schemas.openxmlformats.org/drawingml/2006/main">
+            <a:r>
+              <a:t>This section is a high-throughput demonstration of disciplined hypothesis generation. It does not change the pair mechanics or mine outcomes.</a:t>
+            </a:r>
+          </a:p>
+          <a:p xmlns:a="http://schemas.openxmlformats.org/drawingml/2006/main">
+            <a:r>
+              <a:t/>
+            </a:r>
+          </a:p>
+          <a:p xmlns:a="http://schemas.openxmlformats.org/drawingml/2006/main">
+            <a:r>
+              <a:t>[Sources]</a:t>
+            </a:r>
+          </a:p>
+          <a:p xmlns:a="http://schemas.openxmlformats.org/drawingml/2006/main">
+            <a:r>
+              <a:t>- C:/Users/Franc/OneDrive/Documents/Francis/Peltata Project/Time-Series-Modeling-Gen5/docs/GEN5_LIT_MR_02_1_RELATIONSHIP_ATLAS_01_CONTRACT.md</a:t>
+            </a:r>
+          </a:p>
+          <a:p xmlns:a="http://schemas.openxmlformats.org/drawingml/2006/main">
+            <a:r>
+              <a:t>- C:/Users/Franc/OneDrive/Documents/Francis/Peltata Project/Time-Series-Modeling-Gen5/runs/research_workbench/literature_grounded/lit_mr_02_1_relationship_atlas_01_20260729/mr02_panel_pair_registry.csv</a:t>
+            </a:r>
+          </a:p>
+          <a:p xmlns:a="http://schemas.openxmlformats.org/drawingml/2006/main">
+            <a:r>
+              <a:t>- C:/Users/Franc/OneDrive/Documents/Francis/Peltata Project/Time-Series-Modeling-Gen5/docs/GEN5_4_DECISION_DIALOGUE_INDEX.md — D73</a:t>
+            </a:r>
+          </a:p>
+        </p:txBody>
+      </p:sp>
+      <p:sp>
+        <p:nvSpPr>
+          <p:cNvPr id="4" name="Slide Number Placeholder 3"/>
+          <p:cNvSpPr>
+            <a:spLocks xmlns:a="http://schemas.openxmlformats.org/drawingml/2006/main" noGrp="1"/>
+          </p:cNvSpPr>
+          <p:nvPr>
+            <p:ph type="sldNum" idx="5"/>
+          </p:nvPr>
+        </p:nvSpPr>
+        <p:spPr/>
+        <p:txBody>
+          <a:bodyPr xmlns:a="http://schemas.openxmlformats.org/drawingml/2006/main"/>
+          <a:lstStyle xmlns:a="http://schemas.openxmlformats.org/drawingml/2006/main"/>
+          <a:p xmlns:a="http://schemas.openxmlformats.org/drawingml/2006/main"/>
+        </p:txBody>
+      </p:sp>
+    </p:spTree>
+  </p:cSld>
+  <p:clrMapOvr>
+    <a:masterClrMapping xmlns:a="http://schemas.openxmlformats.org/drawingml/2006/main"/>
+  </p:clrMapOvr>
+</p:notes>
+</file>
+
+<file path=ppt/notesSlides/notesSlide35.xml><?xml version="1.0" encoding="utf-8"?>
+<p:notes xmlns:p="http://schemas.openxmlformats.org/presentationml/2006/main">
+  <p:cSld>
+    <p:spTree>
+      <p:nvGrpSpPr>
+        <p:cNvPr id="1" name=""/>
+        <p:cNvGrpSpPr/>
+        <p:nvPr/>
+      </p:nvGrpSpPr>
+      <p:grpSpPr>
+        <a:xfrm xmlns:a="http://schemas.openxmlformats.org/drawingml/2006/main"/>
+      </p:grpSpPr>
+      <p:sp>
+        <p:nvSpPr>
+          <p:cNvPr id="2" name="Slide Image Placeholder 1"/>
+          <p:cNvSpPr>
+            <a:spLocks xmlns:a="http://schemas.openxmlformats.org/drawingml/2006/main" noGrp="1"/>
+          </p:cNvSpPr>
+          <p:nvPr>
+            <p:ph type="sldImg" idx="0"/>
+          </p:nvPr>
+        </p:nvSpPr>
+        <p:spPr/>
+      </p:sp>
+      <p:sp>
+        <p:nvSpPr>
+          <p:cNvPr id="3" name="Notes Placeholder 2"/>
+          <p:cNvSpPr>
+            <a:spLocks xmlns:a="http://schemas.openxmlformats.org/drawingml/2006/main" noGrp="1"/>
+          </p:cNvSpPr>
+          <p:nvPr>
+            <p:ph type="body" idx="1"/>
+          </p:nvPr>
+        </p:nvSpPr>
+        <p:spPr/>
+        <p:txBody>
+          <a:bodyPr xmlns:a="http://schemas.openxmlformats.org/drawingml/2006/main"/>
+          <a:lstStyle xmlns:a="http://schemas.openxmlformats.org/drawingml/2006/main"/>
+          <a:p xmlns:a="http://schemas.openxmlformats.org/drawingml/2006/main">
+            <a:r>
+              <a:t>The generator is categorical and economic, not performance-ranked. ETF–component and producer/asset-proxy relationships are explicitly distinguished from ETF–ETF and stock–stock hypotheses.</a:t>
+            </a:r>
+          </a:p>
+          <a:p xmlns:a="http://schemas.openxmlformats.org/drawingml/2006/main">
+            <a:r>
+              <a:t/>
+            </a:r>
+          </a:p>
+          <a:p xmlns:a="http://schemas.openxmlformats.org/drawingml/2006/main">
+            <a:r>
+              <a:t>[Sources]</a:t>
+            </a:r>
+          </a:p>
+          <a:p xmlns:a="http://schemas.openxmlformats.org/drawingml/2006/main">
+            <a:r>
+              <a:t>- C:/Users/Franc/OneDrive/Documents/Francis/Peltata Project/Time-Series-Modeling-Gen5/docs/GEN5_LIT_MR_02_1_RELATIONSHIP_ATLAS_01_CONTRACT.md</a:t>
+            </a:r>
+          </a:p>
+          <a:p xmlns:a="http://schemas.openxmlformats.org/drawingml/2006/main">
+            <a:r>
+              <a:t>- C:/Users/Franc/OneDrive/Documents/Francis/Peltata Project/Time-Series-Modeling-Gen5/runs/research_workbench/literature_grounded/lit_mr_02_1_relationship_atlas_01_20260729/mr02_panel_pair_registry.csv</a:t>
+            </a:r>
+          </a:p>
+          <a:p xmlns:a="http://schemas.openxmlformats.org/drawingml/2006/main">
+            <a:r>
+              <a:t>- C:/Users/Franc/OneDrive/Documents/Francis/Peltata Project/Time-Series-Modeling-Gen5/docs/GEN5_4_DECISION_DIALOGUE_INDEX.md — D73</a:t>
+            </a:r>
+          </a:p>
+        </p:txBody>
+      </p:sp>
+      <p:sp>
+        <p:nvSpPr>
+          <p:cNvPr id="4" name="Slide Number Placeholder 3"/>
+          <p:cNvSpPr>
+            <a:spLocks xmlns:a="http://schemas.openxmlformats.org/drawingml/2006/main" noGrp="1"/>
+          </p:cNvSpPr>
+          <p:nvPr>
+            <p:ph type="sldNum" idx="5"/>
+          </p:nvPr>
+        </p:nvSpPr>
+        <p:spPr/>
+        <p:txBody>
+          <a:bodyPr xmlns:a="http://schemas.openxmlformats.org/drawingml/2006/main"/>
+          <a:lstStyle xmlns:a="http://schemas.openxmlformats.org/drawingml/2006/main"/>
+          <a:p xmlns:a="http://schemas.openxmlformats.org/drawingml/2006/main"/>
+        </p:txBody>
+      </p:sp>
+    </p:spTree>
+  </p:cSld>
+  <p:clrMapOvr>
+    <a:masterClrMapping xmlns:a="http://schemas.openxmlformats.org/drawingml/2006/main"/>
+  </p:clrMapOvr>
+</p:notes>
+</file>
+
+<file path=ppt/notesSlides/notesSlide36.xml><?xml version="1.0" encoding="utf-8"?>
+<p:notes xmlns:p="http://schemas.openxmlformats.org/presentationml/2006/main">
+  <p:cSld>
+    <p:spTree>
+      <p:nvGrpSpPr>
+        <p:cNvPr id="1" name=""/>
+        <p:cNvGrpSpPr/>
+        <p:nvPr/>
+      </p:nvGrpSpPr>
+      <p:grpSpPr>
+        <a:xfrm xmlns:a="http://schemas.openxmlformats.org/drawingml/2006/main"/>
+      </p:grpSpPr>
+      <p:sp>
+        <p:nvSpPr>
+          <p:cNvPr id="2" name="Slide Image Placeholder 1"/>
+          <p:cNvSpPr>
+            <a:spLocks xmlns:a="http://schemas.openxmlformats.org/drawingml/2006/main" noGrp="1"/>
+          </p:cNvSpPr>
+          <p:nvPr>
+            <p:ph type="sldImg" idx="0"/>
+          </p:nvPr>
+        </p:nvSpPr>
+        <p:spPr/>
+      </p:sp>
+      <p:sp>
+        <p:nvSpPr>
+          <p:cNvPr id="3" name="Notes Placeholder 2"/>
+          <p:cNvSpPr>
+            <a:spLocks xmlns:a="http://schemas.openxmlformats.org/drawingml/2006/main" noGrp="1"/>
+          </p:cNvSpPr>
+          <p:nvPr>
+            <p:ph type="body" idx="1"/>
+          </p:nvPr>
+        </p:nvSpPr>
+        <p:spPr/>
+        <p:txBody>
+          <a:bodyPr xmlns:a="http://schemas.openxmlformats.org/drawingml/2006/main"/>
+          <a:lstStyle xmlns:a="http://schemas.openxmlformats.org/drawingml/2006/main"/>
+          <a:p xmlns:a="http://schemas.openxmlformats.org/drawingml/2006/main">
+            <a:r>
+              <a:t>Only the producer/asset-proxy cell contained a positive mean-net pair. No category produced a full eight-gate pass. The chart is descriptive; the atlas did not select a winning cell.</a:t>
+            </a:r>
+          </a:p>
+          <a:p xmlns:a="http://schemas.openxmlformats.org/drawingml/2006/main">
+            <a:r>
+              <a:t/>
+            </a:r>
+          </a:p>
+          <a:p xmlns:a="http://schemas.openxmlformats.org/drawingml/2006/main">
+            <a:r>
+              <a:t>[Sources]</a:t>
+            </a:r>
+          </a:p>
+          <a:p xmlns:a="http://schemas.openxmlformats.org/drawingml/2006/main">
+            <a:r>
+              <a:t>- C:/Users/Franc/OneDrive/Documents/Francis/Peltata Project/Time-Series-Modeling-Gen5/runs/research_workbench/literature_grounded/lit_mr_02_1_relationship_atlas_01_20260729/mr02_panel_category_summary.csv</a:t>
+            </a:r>
+          </a:p>
+          <a:p xmlns:a="http://schemas.openxmlformats.org/drawingml/2006/main">
+            <a:r>
+              <a:t>- C:/Users/Franc/OneDrive/Documents/Francis/Peltata Project/Time-Series-Modeling-Gen5/runs/research_workbench/literature_grounded/lit_mr_02_1_relationship_atlas_01_20260729/visuals/mr02_panel_category_summary.png</a:t>
+            </a:r>
+          </a:p>
+          <a:p xmlns:a="http://schemas.openxmlformats.org/drawingml/2006/main">
+            <a:r>
+              <a:t>- C:/Users/Franc/OneDrive/Documents/Francis/Peltata Project/Time-Series-Modeling-Gen5/docs/GEN5_LIT_MR_02_1_RELATIONSHIP_ATLAS_01_CONTRACT.md</a:t>
+            </a:r>
+          </a:p>
+        </p:txBody>
+      </p:sp>
+      <p:sp>
+        <p:nvSpPr>
+          <p:cNvPr id="4" name="Slide Number Placeholder 3"/>
+          <p:cNvSpPr>
+            <a:spLocks xmlns:a="http://schemas.openxmlformats.org/drawingml/2006/main" noGrp="1"/>
+          </p:cNvSpPr>
+          <p:nvPr>
+            <p:ph type="sldNum" idx="5"/>
+          </p:nvPr>
+        </p:nvSpPr>
+        <p:spPr/>
+        <p:txBody>
+          <a:bodyPr xmlns:a="http://schemas.openxmlformats.org/drawingml/2006/main"/>
+          <a:lstStyle xmlns:a="http://schemas.openxmlformats.org/drawingml/2006/main"/>
+          <a:p xmlns:a="http://schemas.openxmlformats.org/drawingml/2006/main"/>
+        </p:txBody>
+      </p:sp>
+    </p:spTree>
+  </p:cSld>
+  <p:clrMapOvr>
+    <a:masterClrMapping xmlns:a="http://schemas.openxmlformats.org/drawingml/2006/main"/>
+  </p:clrMapOvr>
+</p:notes>
+</file>
+
+<file path=ppt/notesSlides/notesSlide37.xml><?xml version="1.0" encoding="utf-8"?>
+<p:notes xmlns:p="http://schemas.openxmlformats.org/presentationml/2006/main">
+  <p:cSld>
+    <p:spTree>
+      <p:nvGrpSpPr>
+        <p:cNvPr id="1" name=""/>
+        <p:cNvGrpSpPr/>
+        <p:nvPr/>
+      </p:nvGrpSpPr>
+      <p:grpSpPr>
+        <a:xfrm xmlns:a="http://schemas.openxmlformats.org/drawingml/2006/main"/>
+      </p:grpSpPr>
+      <p:sp>
+        <p:nvSpPr>
+          <p:cNvPr id="2" name="Slide Image Placeholder 1"/>
+          <p:cNvSpPr>
+            <a:spLocks xmlns:a="http://schemas.openxmlformats.org/drawingml/2006/main" noGrp="1"/>
+          </p:cNvSpPr>
+          <p:nvPr>
+            <p:ph type="sldImg" idx="0"/>
+          </p:nvPr>
+        </p:nvSpPr>
+        <p:spPr/>
+      </p:sp>
+      <p:sp>
+        <p:nvSpPr>
+          <p:cNvPr id="3" name="Notes Placeholder 2"/>
+          <p:cNvSpPr>
+            <a:spLocks xmlns:a="http://schemas.openxmlformats.org/drawingml/2006/main" noGrp="1"/>
+          </p:cNvSpPr>
+          <p:nvPr>
+            <p:ph type="body" idx="1"/>
+          </p:nvPr>
+        </p:nvSpPr>
+        <p:spPr/>
+        <p:txBody>
+          <a:bodyPr xmlns:a="http://schemas.openxmlformats.org/drawingml/2006/main"/>
+          <a:lstStyle xmlns:a="http://schemas.openxmlformats.org/drawingml/2006/main"/>
+          <a:p xmlns:a="http://schemas.openxmlformats.org/drawingml/2006/main">
+            <a:r>
+              <a:t>SIL–SLV averaged +56.8 bp per completed trade, but its 95% interval was approximately -19.3 to +143.3 bp. It passed six of eight gates and was not selected because the contract requires all eight.</a:t>
+            </a:r>
+          </a:p>
+          <a:p xmlns:a="http://schemas.openxmlformats.org/drawingml/2006/main">
+            <a:r>
+              <a:t/>
+            </a:r>
+          </a:p>
+          <a:p xmlns:a="http://schemas.openxmlformats.org/drawingml/2006/main">
+            <a:r>
+              <a:t>[Sources]</a:t>
+            </a:r>
+          </a:p>
+          <a:p xmlns:a="http://schemas.openxmlformats.org/drawingml/2006/main">
+            <a:r>
+              <a:t>- C:/Users/Franc/OneDrive/Documents/Francis/Peltata Project/Time-Series-Modeling-Gen5/runs/research_workbench/literature_grounded/lit_mr_02_1_relationship_atlas_01_20260729/mr02_panel_pair_summary.csv</a:t>
+            </a:r>
+          </a:p>
+          <a:p xmlns:a="http://schemas.openxmlformats.org/drawingml/2006/main">
+            <a:r>
+              <a:t>- C:/Users/Franc/OneDrive/Documents/Francis/Peltata Project/Time-Series-Modeling-Gen5/runs/research_workbench/literature_grounded/lit_mr_02_1_relationship_atlas_01_20260729/visuals/mr02_panel_pair_net_return_ci.png</a:t>
+            </a:r>
+          </a:p>
+          <a:p xmlns:a="http://schemas.openxmlformats.org/drawingml/2006/main">
+            <a:r>
+              <a:t>- C:/Users/Franc/OneDrive/Documents/Francis/Peltata Project/Time-Series-Modeling-Gen5/docs/GEN5_4_DECISION_DIALOGUE_INDEX.md — D75</a:t>
+            </a:r>
+          </a:p>
+        </p:txBody>
+      </p:sp>
+      <p:sp>
+        <p:nvSpPr>
+          <p:cNvPr id="4" name="Slide Number Placeholder 3"/>
+          <p:cNvSpPr>
+            <a:spLocks xmlns:a="http://schemas.openxmlformats.org/drawingml/2006/main" noGrp="1"/>
+          </p:cNvSpPr>
+          <p:nvPr>
+            <p:ph type="sldNum" idx="5"/>
+          </p:nvPr>
+        </p:nvSpPr>
+        <p:spPr/>
+        <p:txBody>
+          <a:bodyPr xmlns:a="http://schemas.openxmlformats.org/drawingml/2006/main"/>
+          <a:lstStyle xmlns:a="http://schemas.openxmlformats.org/drawingml/2006/main"/>
+          <a:p xmlns:a="http://schemas.openxmlformats.org/drawingml/2006/main"/>
+        </p:txBody>
+      </p:sp>
+    </p:spTree>
+  </p:cSld>
+  <p:clrMapOvr>
+    <a:masterClrMapping xmlns:a="http://schemas.openxmlformats.org/drawingml/2006/main"/>
+  </p:clrMapOvr>
+</p:notes>
+</file>
+
+<file path=ppt/notesSlides/notesSlide38.xml><?xml version="1.0" encoding="utf-8"?>
+<p:notes xmlns:p="http://schemas.openxmlformats.org/presentationml/2006/main">
+  <p:cSld>
+    <p:spTree>
+      <p:nvGrpSpPr>
+        <p:cNvPr id="1" name=""/>
+        <p:cNvGrpSpPr/>
+        <p:nvPr/>
+      </p:nvGrpSpPr>
+      <p:grpSpPr>
+        <a:xfrm xmlns:a="http://schemas.openxmlformats.org/drawingml/2006/main"/>
+      </p:grpSpPr>
+      <p:sp>
+        <p:nvSpPr>
+          <p:cNvPr id="2" name="Slide Image Placeholder 1"/>
+          <p:cNvSpPr>
+            <a:spLocks xmlns:a="http://schemas.openxmlformats.org/drawingml/2006/main" noGrp="1"/>
+          </p:cNvSpPr>
+          <p:nvPr>
+            <p:ph type="sldImg" idx="0"/>
+          </p:nvPr>
+        </p:nvSpPr>
+        <p:spPr/>
+      </p:sp>
+      <p:sp>
+        <p:nvSpPr>
+          <p:cNvPr id="3" name="Notes Placeholder 2"/>
+          <p:cNvSpPr>
+            <a:spLocks xmlns:a="http://schemas.openxmlformats.org/drawingml/2006/main" noGrp="1"/>
+          </p:cNvSpPr>
+          <p:nvPr>
+            <p:ph type="body" idx="1"/>
+          </p:nvPr>
+        </p:nvSpPr>
+        <p:spPr/>
+        <p:txBody>
+          <a:bodyPr xmlns:a="http://schemas.openxmlformats.org/drawingml/2006/main"/>
+          <a:lstStyle xmlns:a="http://schemas.openxmlformats.org/drawingml/2006/main"/>
+          <a:p xmlns:a="http://schemas.openxmlformats.org/drawingml/2006/main">
+            <a:r>
+              <a:t>The cold/partial-cache WARNs record the pre-refresh state. The runner refreshed all affected 2016–2020 ranges, each pair passed requested coverage, and the analysis health used by the gates was PASS.</a:t>
+            </a:r>
+          </a:p>
+          <a:p xmlns:a="http://schemas.openxmlformats.org/drawingml/2006/main">
+            <a:r>
+              <a:t/>
+            </a:r>
+          </a:p>
+          <a:p xmlns:a="http://schemas.openxmlformats.org/drawingml/2006/main">
+            <a:r>
+              <a:t>[Sources]</a:t>
+            </a:r>
+          </a:p>
+          <a:p xmlns:a="http://schemas.openxmlformats.org/drawingml/2006/main">
+            <a:r>
+              <a:t>- C:/Users/Franc/OneDrive/Documents/Francis/Peltata Project/Time-Series-Modeling-Gen5/runs/research_workbench/literature_grounded/lit_mr_02_1_relationship_atlas_01_20260729/mr02_panel_gate_detail.csv</a:t>
+            </a:r>
+          </a:p>
+          <a:p xmlns:a="http://schemas.openxmlformats.org/drawingml/2006/main">
+            <a:r>
+              <a:t>- C:/Users/Franc/OneDrive/Documents/Francis/Peltata Project/Time-Series-Modeling-Gen5/runs/research_workbench/literature_grounded/lit_mr_02_1_relationship_atlas_01_20260729/mr02_panel_pair_coverage.csv</a:t>
+            </a:r>
+          </a:p>
+          <a:p xmlns:a="http://schemas.openxmlformats.org/drawingml/2006/main">
+            <a:r>
+              <a:t>- C:/Users/Franc/OneDrive/Documents/Francis/Peltata Project/Time-Series-Modeling-Gen5/runs/research_workbench/literature_grounded/lit_mr_02_1_relationship_atlas_01_20260729/mr02_panel_workbench_query_health.csv</a:t>
+            </a:r>
+          </a:p>
+          <a:p xmlns:a="http://schemas.openxmlformats.org/drawingml/2006/main">
+            <a:r>
+              <a:t>- C:/Users/Franc/OneDrive/Documents/Francis/Peltata Project/Time-Series-Modeling-Gen5/docs/GEN5_4_DECISION_DIALOGUE_INDEX.md — D75</a:t>
+            </a:r>
+          </a:p>
+        </p:txBody>
+      </p:sp>
+      <p:sp>
+        <p:nvSpPr>
+          <p:cNvPr id="4" name="Slide Number Placeholder 3"/>
+          <p:cNvSpPr>
+            <a:spLocks xmlns:a="http://schemas.openxmlformats.org/drawingml/2006/main" noGrp="1"/>
+          </p:cNvSpPr>
+          <p:nvPr>
+            <p:ph type="sldNum" idx="5"/>
+          </p:nvPr>
+        </p:nvSpPr>
+        <p:spPr/>
+        <p:txBody>
+          <a:bodyPr xmlns:a="http://schemas.openxmlformats.org/drawingml/2006/main"/>
+          <a:lstStyle xmlns:a="http://schemas.openxmlformats.org/drawingml/2006/main"/>
+          <a:p xmlns:a="http://schemas.openxmlformats.org/drawingml/2006/main"/>
+        </p:txBody>
+      </p:sp>
+    </p:spTree>
+  </p:cSld>
+  <p:clrMapOvr>
+    <a:masterClrMapping xmlns:a="http://schemas.openxmlformats.org/drawingml/2006/main"/>
+  </p:clrMapOvr>
+</p:notes>
+</file>
+
+<file path=ppt/notesSlides/notesSlide39.xml><?xml version="1.0" encoding="utf-8"?>
+<p:notes xmlns:p="http://schemas.openxmlformats.org/presentationml/2006/main">
+  <p:cSld>
+    <p:spTree>
+      <p:nvGrpSpPr>
+        <p:cNvPr id="1" name=""/>
+        <p:cNvGrpSpPr/>
+        <p:nvPr/>
+      </p:nvGrpSpPr>
+      <p:grpSpPr>
+        <a:xfrm xmlns:a="http://schemas.openxmlformats.org/drawingml/2006/main"/>
+      </p:grpSpPr>
+      <p:sp>
+        <p:nvSpPr>
+          <p:cNvPr id="2" name="Slide Image Placeholder 1"/>
+          <p:cNvSpPr>
+            <a:spLocks xmlns:a="http://schemas.openxmlformats.org/drawingml/2006/main" noGrp="1"/>
+          </p:cNvSpPr>
+          <p:nvPr>
+            <p:ph type="sldImg" idx="0"/>
+          </p:nvPr>
+        </p:nvSpPr>
+        <p:spPr/>
+      </p:sp>
+      <p:sp>
+        <p:nvSpPr>
+          <p:cNvPr id="3" name="Notes Placeholder 2"/>
+          <p:cNvSpPr>
+            <a:spLocks xmlns:a="http://schemas.openxmlformats.org/drawingml/2006/main" noGrp="1"/>
+          </p:cNvSpPr>
+          <p:nvPr>
+            <p:ph type="body" idx="1"/>
+          </p:nvPr>
+        </p:nvSpPr>
+        <p:spPr/>
+        <p:txBody>
+          <a:bodyPr xmlns:a="http://schemas.openxmlformats.org/drawingml/2006/main"/>
+          <a:lstStyle xmlns:a="http://schemas.openxmlformats.org/drawingml/2006/main"/>
+          <a:p xmlns:a="http://schemas.openxmlformats.org/drawingml/2006/main">
+            <a:r>
+              <a:t>The research mechanism succeeded operationally: hypotheses were generated, labeled, frozen, and fully reported. The trading mechanism did not earn OOS evaluation.</a:t>
+            </a:r>
+          </a:p>
+          <a:p xmlns:a="http://schemas.openxmlformats.org/drawingml/2006/main">
+            <a:r>
+              <a:t/>
+            </a:r>
+          </a:p>
+          <a:p xmlns:a="http://schemas.openxmlformats.org/drawingml/2006/main">
+            <a:r>
+              <a:t>[Sources]</a:t>
+            </a:r>
+          </a:p>
+          <a:p xmlns:a="http://schemas.openxmlformats.org/drawingml/2006/main">
+            <a:r>
+              <a:t>- C:/Users/Franc/OneDrive/Documents/Francis/Peltata Project/Time-Series-Modeling-Gen5/runs/research_workbench/literature_grounded/lit_mr_02_1_relationship_atlas_01_20260729/mr02_panel_report.md</a:t>
+            </a:r>
+          </a:p>
+          <a:p xmlns:a="http://schemas.openxmlformats.org/drawingml/2006/main">
+            <a:r>
+              <a:t>- C:/Users/Franc/OneDrive/Documents/Francis/Peltata Project/Time-Series-Modeling-Gen5/docs/GEN5_LIT_MR_02_1_RELATIONSHIP_ATLAS_01_CONTRACT.md</a:t>
+            </a:r>
+          </a:p>
+          <a:p xmlns:a="http://schemas.openxmlformats.org/drawingml/2006/main">
+            <a:r>
+              <a:t>- C:/Users/Franc/OneDrive/Documents/Francis/Peltata Project/Time-Series-Modeling-Gen5/docs/GEN5_4_DECISION_DIALOGUE_INDEX.md — D75</a:t>
             </a:r>
           </a:p>
         </p:txBody>
@@ -3627,7 +4208,7 @@
   </p:cSld>
   <p:clrMap bg1="lt1" tx1="dk1" bg2="lt2" tx2="dk2" accent1="accent1" accent2="accent2" accent3="accent3" accent4="accent4" accent5="accent5" accent6="accent6" hlink="hlink" folHlink="folHlink"/>
   <p:sldLayoutIdLst>
-    <p:sldLayoutId xmlns:r="http://schemas.openxmlformats.org/officeDocument/2006/relationships" id="2147483649" r:id="Ra1a0374a32c04fa0"/>
+    <p:sldLayoutId xmlns:r="http://schemas.openxmlformats.org/officeDocument/2006/relationships" id="2147483649" r:id="R5cc82d5a655c4aa4"/>
   </p:sldLayoutIdLst>
   <p:txStyles>
     <p:titleStyle>
@@ -4254,7 +4835,7 @@
               </a:defRPr>
             </a:pPr>
             <a:r>
-              <a:t>USO-GLD remains the canonical literature example. Two predeclared panels test the same 20-session template across 27 primary ETF relationships.</a:t>
+              <a:t>USO-GLD remains the canonical literature example. Two panels, two positive controls, and a 25-pair relationship atlas now test what the exact 20-session template can and cannot do.</a:t>
             </a:r>
           </a:p>
         </p:txBody>
@@ -5039,7 +5620,7 @@
           <p:nvPr/>
         </p:nvPicPr>
         <p:blipFill>
-          <a:blip xmlns:r="http://schemas.openxmlformats.org/officeDocument/2006/relationships" xmlns:a="http://schemas.openxmlformats.org/drawingml/2006/main" r:embed="R71dcec5ac9874291"/>
+          <a:blip xmlns:r="http://schemas.openxmlformats.org/officeDocument/2006/relationships" xmlns:a="http://schemas.openxmlformats.org/drawingml/2006/main" r:embed="Re31f76706eef43ed"/>
           <a:stretch xmlns:a="http://schemas.openxmlformats.org/drawingml/2006/main"/>
         </p:blipFill>
         <p:spPr>
@@ -5463,7 +6044,7 @@
           <p:nvPr/>
         </p:nvPicPr>
         <p:blipFill>
-          <a:blip xmlns:r="http://schemas.openxmlformats.org/officeDocument/2006/relationships" xmlns:a="http://schemas.openxmlformats.org/drawingml/2006/main" r:embed="R13899be0952b4bf4"/>
+          <a:blip xmlns:r="http://schemas.openxmlformats.org/officeDocument/2006/relationships" xmlns:a="http://schemas.openxmlformats.org/drawingml/2006/main" r:embed="R02cc9caa30884832"/>
           <a:stretch xmlns:a="http://schemas.openxmlformats.org/drawingml/2006/main"/>
         </p:blipFill>
         <p:spPr>
@@ -5887,7 +6468,7 @@
           <p:nvPr/>
         </p:nvPicPr>
         <p:blipFill>
-          <a:blip xmlns:r="http://schemas.openxmlformats.org/officeDocument/2006/relationships" xmlns:a="http://schemas.openxmlformats.org/drawingml/2006/main" r:embed="R9c4e1140669747a5"/>
+          <a:blip xmlns:r="http://schemas.openxmlformats.org/officeDocument/2006/relationships" xmlns:a="http://schemas.openxmlformats.org/drawingml/2006/main" r:embed="R62bd80f18e0545c5"/>
           <a:stretch xmlns:a="http://schemas.openxmlformats.org/drawingml/2006/main"/>
         </p:blipFill>
         <p:spPr>
@@ -6311,7 +6892,7 @@
           <p:nvPr/>
         </p:nvPicPr>
         <p:blipFill>
-          <a:blip xmlns:r="http://schemas.openxmlformats.org/officeDocument/2006/relationships" xmlns:a="http://schemas.openxmlformats.org/drawingml/2006/main" r:embed="R45bfa71339624c40"/>
+          <a:blip xmlns:r="http://schemas.openxmlformats.org/officeDocument/2006/relationships" xmlns:a="http://schemas.openxmlformats.org/drawingml/2006/main" r:embed="Racb7175d045a4f3a"/>
           <a:stretch xmlns:a="http://schemas.openxmlformats.org/drawingml/2006/main"/>
         </p:blipFill>
         <p:spPr>
@@ -6529,7 +7110,7 @@
           <p:nvPr/>
         </p:nvPicPr>
         <p:blipFill>
-          <a:blip xmlns:r="http://schemas.openxmlformats.org/officeDocument/2006/relationships" xmlns:a="http://schemas.openxmlformats.org/drawingml/2006/main" r:embed="R45e6611d26dc46bf"/>
+          <a:blip xmlns:r="http://schemas.openxmlformats.org/officeDocument/2006/relationships" xmlns:a="http://schemas.openxmlformats.org/drawingml/2006/main" r:embed="Raba8d41ff27945bf"/>
           <a:stretch xmlns:a="http://schemas.openxmlformats.org/drawingml/2006/main"/>
         </p:blipFill>
         <p:spPr>
@@ -8001,7 +8582,7 @@
           <p:nvPr/>
         </p:nvPicPr>
         <p:blipFill>
-          <a:blip xmlns:r="http://schemas.openxmlformats.org/officeDocument/2006/relationships" xmlns:a="http://schemas.openxmlformats.org/drawingml/2006/main" r:embed="R5c81fbcb86254369"/>
+          <a:blip xmlns:r="http://schemas.openxmlformats.org/officeDocument/2006/relationships" xmlns:a="http://schemas.openxmlformats.org/drawingml/2006/main" r:embed="Ra39a3de3ed27442d"/>
           <a:stretch xmlns:a="http://schemas.openxmlformats.org/drawingml/2006/main"/>
         </p:blipFill>
         <p:spPr>
@@ -8056,7 +8637,7 @@
           <p:nvPr/>
         </p:nvPicPr>
         <p:blipFill>
-          <a:blip xmlns:r="http://schemas.openxmlformats.org/officeDocument/2006/relationships" xmlns:a="http://schemas.openxmlformats.org/drawingml/2006/main" r:embed="R3d69b906cf634785"/>
+          <a:blip xmlns:r="http://schemas.openxmlformats.org/officeDocument/2006/relationships" xmlns:a="http://schemas.openxmlformats.org/drawingml/2006/main" r:embed="R66936a1f1ce64ded"/>
           <a:stretch xmlns:a="http://schemas.openxmlformats.org/drawingml/2006/main"/>
         </p:blipFill>
         <p:spPr>
@@ -8273,7 +8854,7 @@
           <p:nvPr/>
         </p:nvPicPr>
         <p:blipFill>
-          <a:blip xmlns:r="http://schemas.openxmlformats.org/officeDocument/2006/relationships" xmlns:a="http://schemas.openxmlformats.org/drawingml/2006/main" r:embed="Ra5af1645de194588"/>
+          <a:blip xmlns:r="http://schemas.openxmlformats.org/officeDocument/2006/relationships" xmlns:a="http://schemas.openxmlformats.org/drawingml/2006/main" r:embed="Rbd2aed99ddc043b1"/>
           <a:stretch xmlns:a="http://schemas.openxmlformats.org/drawingml/2006/main"/>
         </p:blipFill>
         <p:spPr>
@@ -8328,7 +8909,7 @@
           <p:nvPr/>
         </p:nvPicPr>
         <p:blipFill>
-          <a:blip xmlns:r="http://schemas.openxmlformats.org/officeDocument/2006/relationships" xmlns:a="http://schemas.openxmlformats.org/drawingml/2006/main" r:embed="Rcc6a4591a7ca41b5"/>
+          <a:blip xmlns:r="http://schemas.openxmlformats.org/officeDocument/2006/relationships" xmlns:a="http://schemas.openxmlformats.org/drawingml/2006/main" r:embed="Rd04e5a0ac68d41bd"/>
           <a:stretch xmlns:a="http://schemas.openxmlformats.org/drawingml/2006/main"/>
         </p:blipFill>
         <p:spPr>
@@ -10324,7 +10905,7 @@
           <p:nvPr/>
         </p:nvPicPr>
         <p:blipFill>
-          <a:blip xmlns:r="http://schemas.openxmlformats.org/officeDocument/2006/relationships" xmlns:a="http://schemas.openxmlformats.org/drawingml/2006/main" r:embed="R8df3f82992d745ee"/>
+          <a:blip xmlns:r="http://schemas.openxmlformats.org/officeDocument/2006/relationships" xmlns:a="http://schemas.openxmlformats.org/drawingml/2006/main" r:embed="Rc197fb6debf94337"/>
           <a:stretch xmlns:a="http://schemas.openxmlformats.org/drawingml/2006/main"/>
         </p:blipFill>
         <p:spPr>
@@ -10379,7 +10960,7 @@
           <p:nvPr/>
         </p:nvPicPr>
         <p:blipFill>
-          <a:blip xmlns:r="http://schemas.openxmlformats.org/officeDocument/2006/relationships" xmlns:a="http://schemas.openxmlformats.org/drawingml/2006/main" r:embed="Rac8e83e25b114709"/>
+          <a:blip xmlns:r="http://schemas.openxmlformats.org/officeDocument/2006/relationships" xmlns:a="http://schemas.openxmlformats.org/drawingml/2006/main" r:embed="R9e526d70f7d14a3c"/>
           <a:stretch xmlns:a="http://schemas.openxmlformats.org/drawingml/2006/main"/>
         </p:blipFill>
         <p:spPr>
@@ -10434,7 +11015,7 @@
           <p:nvPr/>
         </p:nvPicPr>
         <p:blipFill>
-          <a:blip xmlns:r="http://schemas.openxmlformats.org/officeDocument/2006/relationships" xmlns:a="http://schemas.openxmlformats.org/drawingml/2006/main" r:embed="R05f294c1ea664919"/>
+          <a:blip xmlns:r="http://schemas.openxmlformats.org/officeDocument/2006/relationships" xmlns:a="http://schemas.openxmlformats.org/drawingml/2006/main" r:embed="R49bdd644c4354c8f"/>
           <a:stretch xmlns:a="http://schemas.openxmlformats.org/drawingml/2006/main"/>
         </p:blipFill>
         <p:spPr>
@@ -10651,7 +11232,7 @@
           <p:nvPr/>
         </p:nvPicPr>
         <p:blipFill>
-          <a:blip xmlns:r="http://schemas.openxmlformats.org/officeDocument/2006/relationships" xmlns:a="http://schemas.openxmlformats.org/drawingml/2006/main" r:embed="Raef4fd53fe314a8b"/>
+          <a:blip xmlns:r="http://schemas.openxmlformats.org/officeDocument/2006/relationships" xmlns:a="http://schemas.openxmlformats.org/drawingml/2006/main" r:embed="R2a9ded3584474426"/>
           <a:stretch xmlns:a="http://schemas.openxmlformats.org/drawingml/2006/main"/>
         </p:blipFill>
         <p:spPr>
@@ -10706,7 +11287,7 @@
           <p:nvPr/>
         </p:nvPicPr>
         <p:blipFill>
-          <a:blip xmlns:r="http://schemas.openxmlformats.org/officeDocument/2006/relationships" xmlns:a="http://schemas.openxmlformats.org/drawingml/2006/main" r:embed="R97365f103a734819"/>
+          <a:blip xmlns:r="http://schemas.openxmlformats.org/officeDocument/2006/relationships" xmlns:a="http://schemas.openxmlformats.org/drawingml/2006/main" r:embed="R5500d513365844d1"/>
           <a:stretch xmlns:a="http://schemas.openxmlformats.org/drawingml/2006/main"/>
         </p:blipFill>
         <p:spPr>
@@ -10761,7 +11342,7 @@
           <p:nvPr/>
         </p:nvPicPr>
         <p:blipFill>
-          <a:blip xmlns:r="http://schemas.openxmlformats.org/officeDocument/2006/relationships" xmlns:a="http://schemas.openxmlformats.org/drawingml/2006/main" r:embed="Reaf46b9b65a8475e"/>
+          <a:blip xmlns:r="http://schemas.openxmlformats.org/officeDocument/2006/relationships" xmlns:a="http://schemas.openxmlformats.org/drawingml/2006/main" r:embed="R4e5e34c597044fa6"/>
           <a:stretch xmlns:a="http://schemas.openxmlformats.org/drawingml/2006/main"/>
         </p:blipFill>
         <p:spPr>
@@ -11915,7 +12496,7 @@
           <p:nvPr/>
         </p:nvPicPr>
         <p:blipFill>
-          <a:blip xmlns:r="http://schemas.openxmlformats.org/officeDocument/2006/relationships" xmlns:a="http://schemas.openxmlformats.org/drawingml/2006/main" r:embed="Rc81b5756c1a44421"/>
+          <a:blip xmlns:r="http://schemas.openxmlformats.org/officeDocument/2006/relationships" xmlns:a="http://schemas.openxmlformats.org/drawingml/2006/main" r:embed="R95c51f777206421c"/>
           <a:stretch xmlns:a="http://schemas.openxmlformats.org/drawingml/2006/main"/>
         </p:blipFill>
         <p:spPr>
@@ -12049,7 +12630,7 @@
           <p:nvPr/>
         </p:nvPicPr>
         <p:blipFill>
-          <a:blip xmlns:r="http://schemas.openxmlformats.org/officeDocument/2006/relationships" xmlns:a="http://schemas.openxmlformats.org/drawingml/2006/main" r:embed="Re7e1fa4247bc46c4"/>
+          <a:blip xmlns:r="http://schemas.openxmlformats.org/officeDocument/2006/relationships" xmlns:a="http://schemas.openxmlformats.org/drawingml/2006/main" r:embed="Ra44f53a5f694413a"/>
           <a:stretch xmlns:a="http://schemas.openxmlformats.org/drawingml/2006/main"/>
         </p:blipFill>
         <p:spPr>
@@ -12183,7 +12764,7 @@
           <p:nvPr/>
         </p:nvPicPr>
         <p:blipFill>
-          <a:blip xmlns:r="http://schemas.openxmlformats.org/officeDocument/2006/relationships" xmlns:a="http://schemas.openxmlformats.org/drawingml/2006/main" r:embed="R760b192826804a0a"/>
+          <a:blip xmlns:r="http://schemas.openxmlformats.org/officeDocument/2006/relationships" xmlns:a="http://schemas.openxmlformats.org/drawingml/2006/main" r:embed="R186e7b107bec4fae"/>
           <a:stretch xmlns:a="http://schemas.openxmlformats.org/drawingml/2006/main"/>
         </p:blipFill>
         <p:spPr>
@@ -12317,7 +12898,7 @@
           <p:nvPr/>
         </p:nvPicPr>
         <p:blipFill>
-          <a:blip xmlns:r="http://schemas.openxmlformats.org/officeDocument/2006/relationships" xmlns:a="http://schemas.openxmlformats.org/drawingml/2006/main" r:embed="Recf193e704df4636"/>
+          <a:blip xmlns:r="http://schemas.openxmlformats.org/officeDocument/2006/relationships" xmlns:a="http://schemas.openxmlformats.org/drawingml/2006/main" r:embed="Rd2ed605e315f4efc"/>
           <a:stretch xmlns:a="http://schemas.openxmlformats.org/drawingml/2006/main"/>
         </p:blipFill>
         <p:spPr>
@@ -13151,7 +13732,7 @@
           <p:nvPr/>
         </p:nvPicPr>
         <p:blipFill>
-          <a:blip xmlns:r="http://schemas.openxmlformats.org/officeDocument/2006/relationships" xmlns:a="http://schemas.openxmlformats.org/drawingml/2006/main" r:embed="R5b90afa89cdb4fc6"/>
+          <a:blip xmlns:r="http://schemas.openxmlformats.org/officeDocument/2006/relationships" xmlns:a="http://schemas.openxmlformats.org/drawingml/2006/main" r:embed="R65358a4d80c1491c"/>
           <a:stretch xmlns:a="http://schemas.openxmlformats.org/drawingml/2006/main"/>
         </p:blipFill>
         <p:spPr>
@@ -13605,7 +14186,7 @@
           <p:nvPr/>
         </p:nvPicPr>
         <p:blipFill>
-          <a:blip xmlns:r="http://schemas.openxmlformats.org/officeDocument/2006/relationships" xmlns:a="http://schemas.openxmlformats.org/drawingml/2006/main" r:embed="Redc828645bd54289"/>
+          <a:blip xmlns:r="http://schemas.openxmlformats.org/officeDocument/2006/relationships" xmlns:a="http://schemas.openxmlformats.org/drawingml/2006/main" r:embed="Rd8c2b16c2766497c"/>
           <a:stretch xmlns:a="http://schemas.openxmlformats.org/drawingml/2006/main"/>
         </p:blipFill>
         <p:spPr>
@@ -13804,6 +14385,2179 @@
 </p:sld>
 </file>
 
+<file path=ppt/slides/slide34.xml><?xml version="1.0" encoding="utf-8"?>
+<p:sld xmlns:p="http://schemas.openxmlformats.org/presentationml/2006/main">
+  <p:cSld>
+    <p:spTree>
+      <p:nvGrpSpPr>
+        <p:cNvPr id="1" name=""/>
+        <p:cNvGrpSpPr/>
+        <p:nvPr/>
+      </p:nvGrpSpPr>
+      <p:grpSpPr>
+        <a:xfrm xmlns:a="http://schemas.openxmlformats.org/drawingml/2006/main"/>
+      </p:grpSpPr>
+      <p:sp>
+        <p:nvSpPr>
+          <p:cNvPr id="4" name="cover-headline">
+            <a:extLst xmlns:a="http://schemas.openxmlformats.org/drawingml/2006/main">
+              <a:ext uri="{FF2B5EF4-FFF2-40B4-BE49-F238E27FC236}">
+                <a16:creationId xmlns:a16="http://schemas.microsoft.com/office/drawing/2014/main" id="{DA6318FA-2F99-4DF9-A744-06350F910925}"/>
+              </a:ext>
+            </a:extLst>
+          </p:cNvPr>
+          <p:cNvSpPr>
+            <a:spLocks xmlns:a="http://schemas.openxmlformats.org/drawingml/2006/main" noGrp="1"/>
+          </p:cNvSpPr>
+          <p:nvPr/>
+        </p:nvSpPr>
+        <p:spPr>
+          <a:xfrm xmlns:a="http://schemas.openxmlformats.org/drawingml/2006/main">
+            <a:off x="393668" y="1738789"/>
+            <a:ext cx="10287000" cy="2491454"/>
+          </a:xfrm>
+          <a:prstGeom xmlns:a="http://schemas.openxmlformats.org/drawingml/2006/main" prst="rect">
+            <a:avLst/>
+          </a:prstGeom>
+        </p:spPr>
+        <p:txBody>
+          <a:bodyPr xmlns:a="http://schemas.openxmlformats.org/drawingml/2006/main" lIns="0" tIns="0" rIns="0" bIns="0" anchor="b">
+            <a:normAutofit fontScale="100000"/>
+          </a:bodyPr>
+          <a:lstStyle xmlns:a="http://schemas.openxmlformats.org/drawingml/2006/main"/>
+          <a:p xmlns:a="http://schemas.openxmlformats.org/drawingml/2006/main">
+            <a:pPr algn="l">
+              <a:buNone/>
+              <a:defRPr sz="5700">
+                <a:solidFill>
+                  <a:srgbClr val="000000"/>
+                </a:solidFill>
+                <a:latin typeface="Helvetica Neue"/>
+                <a:ea typeface="Helvetica Neue"/>
+                <a:cs typeface="Helvetica Neue"/>
+              </a:defRPr>
+            </a:pPr>
+            <a:r>
+              <a:t>Relationship Atlas 01:</a:t>
+            </a:r>
+          </a:p>
+          <a:p xmlns:a="http://schemas.openxmlformats.org/drawingml/2006/main">
+            <a:pPr algn="l">
+              <a:buNone/>
+              <a:defRPr sz="5700">
+                <a:solidFill>
+                  <a:srgbClr val="000000"/>
+                </a:solidFill>
+                <a:latin typeface="Helvetica Neue"/>
+                <a:ea typeface="Helvetica Neue"/>
+                <a:cs typeface="Helvetica Neue"/>
+              </a:defRPr>
+            </a:pPr>
+            <a:r>
+              <a:t>hypotheses, not fishing</a:t>
+            </a:r>
+          </a:p>
+        </p:txBody>
+      </p:sp>
+      <p:sp>
+        <p:nvSpPr>
+          <p:cNvPr id="2" name="cover-subtitle">
+            <a:extLst xmlns:a="http://schemas.openxmlformats.org/drawingml/2006/main">
+              <a:ext uri="{FF2B5EF4-FFF2-40B4-BE49-F238E27FC236}">
+                <a16:creationId xmlns:a16="http://schemas.microsoft.com/office/drawing/2014/main" id="{E169DF7F-9A3A-4AE2-8055-4ED350724D47}"/>
+              </a:ext>
+            </a:extLst>
+          </p:cNvPr>
+          <p:cNvSpPr>
+            <a:spLocks xmlns:a="http://schemas.openxmlformats.org/drawingml/2006/main" noGrp="1"/>
+          </p:cNvSpPr>
+          <p:nvPr/>
+        </p:nvSpPr>
+        <p:spPr>
+          <a:xfrm xmlns:a="http://schemas.openxmlformats.org/drawingml/2006/main">
+            <a:off x="393668" y="4762500"/>
+            <a:ext cx="8001000" cy="1238250"/>
+          </a:xfrm>
+          <a:prstGeom xmlns:a="http://schemas.openxmlformats.org/drawingml/2006/main" prst="rect">
+            <a:avLst/>
+          </a:prstGeom>
+        </p:spPr>
+        <p:txBody>
+          <a:bodyPr xmlns:a="http://schemas.openxmlformats.org/drawingml/2006/main" lIns="0" tIns="0" rIns="0" bIns="0">
+            <a:normAutofit fontScale="100000"/>
+          </a:bodyPr>
+          <a:lstStyle xmlns:a="http://schemas.openxmlformats.org/drawingml/2006/main"/>
+          <a:p xmlns:a="http://schemas.openxmlformats.org/drawingml/2006/main">
+            <a:pPr algn="l">
+              <a:buNone/>
+              <a:defRPr sz="2250">
+                <a:solidFill>
+                  <a:srgbClr val="000000"/>
+                </a:solidFill>
+                <a:latin typeface="Helvetica Neue"/>
+                <a:ea typeface="Helvetica Neue"/>
+                <a:cs typeface="Helvetica Neue"/>
+              </a:defRPr>
+            </a:pPr>
+            <a:r>
+              <a:t>A finite generator crosses instrument topology with economic mechanism, then reports every 2016–2020 TRAIN result in frozen order.</a:t>
+            </a:r>
+          </a:p>
+        </p:txBody>
+      </p:sp>
+      <p:sp>
+        <p:nvSpPr>
+          <p:cNvPr id="3" name="cover-eyebrow">
+            <a:extLst xmlns:a="http://schemas.openxmlformats.org/drawingml/2006/main">
+              <a:ext uri="{FF2B5EF4-FFF2-40B4-BE49-F238E27FC236}">
+                <a16:creationId xmlns:a16="http://schemas.microsoft.com/office/drawing/2014/main" id="{D2399950-CA2D-41D2-BB2E-E681018A573E}"/>
+              </a:ext>
+            </a:extLst>
+          </p:cNvPr>
+          <p:cNvSpPr>
+            <a:spLocks xmlns:a="http://schemas.openxmlformats.org/drawingml/2006/main" noGrp="1"/>
+          </p:cNvSpPr>
+          <p:nvPr/>
+        </p:nvSpPr>
+        <p:spPr>
+          <a:xfrm xmlns:a="http://schemas.openxmlformats.org/drawingml/2006/main">
+            <a:off x="393668" y="392240"/>
+            <a:ext cx="7239000" cy="649129"/>
+          </a:xfrm>
+          <a:prstGeom xmlns:a="http://schemas.openxmlformats.org/drawingml/2006/main" prst="rect">
+            <a:avLst/>
+          </a:prstGeom>
+        </p:spPr>
+        <p:txBody>
+          <a:bodyPr xmlns:a="http://schemas.openxmlformats.org/drawingml/2006/main" lIns="0" tIns="0" rIns="0" bIns="0">
+            <a:normAutofit fontScale="100000"/>
+          </a:bodyPr>
+          <a:lstStyle xmlns:a="http://schemas.openxmlformats.org/drawingml/2006/main"/>
+          <a:p xmlns:a="http://schemas.openxmlformats.org/drawingml/2006/main">
+            <a:pPr algn="l">
+              <a:buNone/>
+              <a:defRPr sz="2250">
+                <a:solidFill>
+                  <a:srgbClr val="000000"/>
+                </a:solidFill>
+                <a:latin typeface="Helvetica Neue"/>
+                <a:ea typeface="Helvetica Neue"/>
+                <a:cs typeface="Helvetica Neue"/>
+              </a:defRPr>
+            </a:pPr>
+            <a:r>
+              <a:t>LIT-MR-02.1 INSTANCE BATCH | 29 JUL 2026</a:t>
+            </a:r>
+          </a:p>
+        </p:txBody>
+      </p:sp>
+    </p:spTree>
+    <p:extLst>
+      <p:ext uri="{BB962C8B-B14F-4D97-AF65-F5344CB8AC3E}">
+        <p14:creationId xmlns:p14="http://schemas.microsoft.com/office/powerpoint/2010/main" val="2092893396"/>
+      </p:ext>
+    </p:extLst>
+  </p:cSld>
+</p:sld>
+</file>
+
+<file path=ppt/slides/slide35.xml><?xml version="1.0" encoding="utf-8"?>
+<p:sld xmlns:p="http://schemas.openxmlformats.org/presentationml/2006/main">
+  <p:cSld>
+    <p:spTree>
+      <p:nvGrpSpPr>
+        <p:cNvPr id="1" name=""/>
+        <p:cNvGrpSpPr/>
+        <p:nvPr/>
+      </p:nvGrpSpPr>
+      <p:grpSpPr>
+        <a:xfrm xmlns:a="http://schemas.openxmlformats.org/drawingml/2006/main"/>
+      </p:grpSpPr>
+      <p:sp>
+        <p:nvSpPr>
+          <p:cNvPr id="13" name="stat-card-1">
+            <a:extLst xmlns:a="http://schemas.openxmlformats.org/drawingml/2006/main">
+              <a:ext uri="{FF2B5EF4-FFF2-40B4-BE49-F238E27FC236}">
+                <a16:creationId xmlns:a16="http://schemas.microsoft.com/office/drawing/2014/main" id="{8D249104-692F-481F-82EC-326C84E9007D}"/>
+              </a:ext>
+            </a:extLst>
+          </p:cNvPr>
+          <p:cNvSpPr>
+            <a:spLocks xmlns:a="http://schemas.openxmlformats.org/drawingml/2006/main" noGrp="1"/>
+          </p:cNvSpPr>
+          <p:nvPr/>
+        </p:nvSpPr>
+        <p:spPr>
+          <a:xfrm xmlns:a="http://schemas.openxmlformats.org/drawingml/2006/main">
+            <a:off x="393668" y="3022568"/>
+            <a:ext cx="3568732" cy="2971800"/>
+          </a:xfrm>
+          <a:prstGeom xmlns:a="http://schemas.openxmlformats.org/drawingml/2006/main" prst="roundRect">
+            <a:avLst>
+              <a:gd name="adj" fmla="val 2564"/>
+            </a:avLst>
+          </a:prstGeom>
+          <a:solidFill xmlns:a="http://schemas.openxmlformats.org/drawingml/2006/main">
+            <a:srgbClr val="F2F2F2"/>
+          </a:solidFill>
+        </p:spPr>
+      </p:sp>
+      <p:sp>
+        <p:nvSpPr>
+          <p:cNvPr id="2" name="stat-card-2">
+            <a:extLst xmlns:a="http://schemas.openxmlformats.org/drawingml/2006/main">
+              <a:ext uri="{FF2B5EF4-FFF2-40B4-BE49-F238E27FC236}">
+                <a16:creationId xmlns:a16="http://schemas.microsoft.com/office/drawing/2014/main" id="{02412AD9-1F13-493C-BF6C-FD8BDE750CD9}"/>
+              </a:ext>
+            </a:extLst>
+          </p:cNvPr>
+          <p:cNvSpPr>
+            <a:spLocks xmlns:a="http://schemas.openxmlformats.org/drawingml/2006/main" noGrp="1"/>
+          </p:cNvSpPr>
+          <p:nvPr/>
+        </p:nvSpPr>
+        <p:spPr>
+          <a:xfrm xmlns:a="http://schemas.openxmlformats.org/drawingml/2006/main">
+            <a:off x="4311682" y="3022568"/>
+            <a:ext cx="3568732" cy="2971800"/>
+          </a:xfrm>
+          <a:prstGeom xmlns:a="http://schemas.openxmlformats.org/drawingml/2006/main" prst="roundRect">
+            <a:avLst>
+              <a:gd name="adj" fmla="val 2564"/>
+            </a:avLst>
+          </a:prstGeom>
+          <a:solidFill xmlns:a="http://schemas.openxmlformats.org/drawingml/2006/main">
+            <a:srgbClr val="F2F2F2"/>
+          </a:solidFill>
+        </p:spPr>
+      </p:sp>
+      <p:sp>
+        <p:nvSpPr>
+          <p:cNvPr id="3" name="stat-card-3">
+            <a:extLst xmlns:a="http://schemas.openxmlformats.org/drawingml/2006/main">
+              <a:ext uri="{FF2B5EF4-FFF2-40B4-BE49-F238E27FC236}">
+                <a16:creationId xmlns:a16="http://schemas.microsoft.com/office/drawing/2014/main" id="{63597CCF-F233-4A0C-BCFA-192F852FDBEA}"/>
+              </a:ext>
+            </a:extLst>
+          </p:cNvPr>
+          <p:cNvSpPr>
+            <a:spLocks xmlns:a="http://schemas.openxmlformats.org/drawingml/2006/main" noGrp="1"/>
+          </p:cNvSpPr>
+          <p:nvPr/>
+        </p:nvSpPr>
+        <p:spPr>
+          <a:xfrm xmlns:a="http://schemas.openxmlformats.org/drawingml/2006/main">
+            <a:off x="8232267" y="3022568"/>
+            <a:ext cx="3568732" cy="2971800"/>
+          </a:xfrm>
+          <a:prstGeom xmlns:a="http://schemas.openxmlformats.org/drawingml/2006/main" prst="roundRect">
+            <a:avLst>
+              <a:gd name="adj" fmla="val 2564"/>
+            </a:avLst>
+          </a:prstGeom>
+          <a:solidFill xmlns:a="http://schemas.openxmlformats.org/drawingml/2006/main">
+            <a:srgbClr val="F2F2F2"/>
+          </a:solidFill>
+        </p:spPr>
+      </p:sp>
+      <p:sp>
+        <p:nvSpPr>
+          <p:cNvPr id="4" name="footer">
+            <a:extLst xmlns:a="http://schemas.openxmlformats.org/drawingml/2006/main">
+              <a:ext uri="{FF2B5EF4-FFF2-40B4-BE49-F238E27FC236}">
+                <a16:creationId xmlns:a16="http://schemas.microsoft.com/office/drawing/2014/main" id="{11E272E4-82E7-4287-91C5-21E6B629F553}"/>
+              </a:ext>
+            </a:extLst>
+          </p:cNvPr>
+          <p:cNvSpPr>
+            <a:spLocks xmlns:a="http://schemas.openxmlformats.org/drawingml/2006/main" noGrp="1"/>
+          </p:cNvSpPr>
+          <p:nvPr/>
+        </p:nvSpPr>
+        <p:spPr>
+          <a:xfrm xmlns:a="http://schemas.openxmlformats.org/drawingml/2006/main">
+            <a:off x="11279315" y="6279261"/>
+            <a:ext cx="518922" cy="241268"/>
+          </a:xfrm>
+          <a:prstGeom xmlns:a="http://schemas.openxmlformats.org/drawingml/2006/main" prst="rect">
+            <a:avLst/>
+          </a:prstGeom>
+        </p:spPr>
+        <p:txBody>
+          <a:bodyPr xmlns:a="http://schemas.openxmlformats.org/drawingml/2006/main" lIns="0" tIns="0" rIns="0" bIns="0" anchor="b"/>
+          <a:lstStyle xmlns:a="http://schemas.openxmlformats.org/drawingml/2006/main"/>
+          <a:p xmlns:a="http://schemas.openxmlformats.org/drawingml/2006/main">
+            <a:pPr algn="r">
+              <a:buNone/>
+              <a:defRPr sz="1000">
+                <a:solidFill>
+                  <a:srgbClr val="000000"/>
+                </a:solidFill>
+                <a:latin typeface="Helvetica Neue"/>
+                <a:ea typeface="Helvetica Neue"/>
+                <a:cs typeface="Helvetica Neue"/>
+              </a:defRPr>
+            </a:pPr>
+            <a:r>
+              <a:t>35</a:t>
+            </a:r>
+          </a:p>
+        </p:txBody>
+      </p:sp>
+      <p:sp>
+        <p:nvSpPr>
+          <p:cNvPr id="5" name="title">
+            <a:extLst xmlns:a="http://schemas.openxmlformats.org/drawingml/2006/main">
+              <a:ext uri="{FF2B5EF4-FFF2-40B4-BE49-F238E27FC236}">
+                <a16:creationId xmlns:a16="http://schemas.microsoft.com/office/drawing/2014/main" id="{A0ED332F-4F42-421E-99CF-097B6CBB5C19}"/>
+              </a:ext>
+            </a:extLst>
+          </p:cNvPr>
+          <p:cNvSpPr>
+            <a:spLocks xmlns:a="http://schemas.openxmlformats.org/drawingml/2006/main" noGrp="1"/>
+          </p:cNvSpPr>
+          <p:nvPr/>
+        </p:nvSpPr>
+        <p:spPr>
+          <a:xfrm xmlns:a="http://schemas.openxmlformats.org/drawingml/2006/main">
+            <a:off x="393668" y="344043"/>
+            <a:ext cx="11404568" cy="1047464"/>
+          </a:xfrm>
+          <a:prstGeom xmlns:a="http://schemas.openxmlformats.org/drawingml/2006/main" prst="rect">
+            <a:avLst/>
+          </a:prstGeom>
+        </p:spPr>
+        <p:txBody>
+          <a:bodyPr xmlns:a="http://schemas.openxmlformats.org/drawingml/2006/main" lIns="0" tIns="0" rIns="0" bIns="0" anchor="t">
+            <a:normAutofit fontScale="100000"/>
+          </a:bodyPr>
+          <a:lstStyle xmlns:a="http://schemas.openxmlformats.org/drawingml/2006/main"/>
+          <a:p xmlns:a="http://schemas.openxmlformats.org/drawingml/2006/main">
+            <a:pPr algn="l">
+              <a:buNone/>
+              <a:defRPr sz="2900">
+                <a:solidFill>
+                  <a:srgbClr val="000000"/>
+                </a:solidFill>
+                <a:latin typeface="Helvetica Neue"/>
+                <a:ea typeface="Helvetica Neue"/>
+                <a:cs typeface="Helvetica Neue"/>
+              </a:defRPr>
+            </a:pPr>
+            <a:r>
+              <a:t>The atlas generates relationships before it sees returns</a:t>
+            </a:r>
+          </a:p>
+        </p:txBody>
+      </p:sp>
+      <p:sp>
+        <p:nvSpPr>
+          <p:cNvPr id="6" name="intro">
+            <a:extLst xmlns:a="http://schemas.openxmlformats.org/drawingml/2006/main">
+              <a:ext uri="{FF2B5EF4-FFF2-40B4-BE49-F238E27FC236}">
+                <a16:creationId xmlns:a16="http://schemas.microsoft.com/office/drawing/2014/main" id="{E3D1AF2D-950D-495D-BB07-182C768AD88F}"/>
+              </a:ext>
+            </a:extLst>
+          </p:cNvPr>
+          <p:cNvSpPr>
+            <a:spLocks xmlns:a="http://schemas.openxmlformats.org/drawingml/2006/main" noGrp="1"/>
+          </p:cNvSpPr>
+          <p:nvPr/>
+        </p:nvSpPr>
+        <p:spPr>
+          <a:xfrm xmlns:a="http://schemas.openxmlformats.org/drawingml/2006/main">
+            <a:off x="393668" y="1219200"/>
+            <a:ext cx="11404568" cy="1428750"/>
+          </a:xfrm>
+          <a:prstGeom xmlns:a="http://schemas.openxmlformats.org/drawingml/2006/main" prst="rect">
+            <a:avLst/>
+          </a:prstGeom>
+        </p:spPr>
+        <p:txBody>
+          <a:bodyPr xmlns:a="http://schemas.openxmlformats.org/drawingml/2006/main" lIns="0" tIns="0" rIns="0" bIns="0" anchor="t">
+            <a:normAutofit fontScale="100000"/>
+          </a:bodyPr>
+          <a:lstStyle xmlns:a="http://schemas.openxmlformats.org/drawingml/2006/main"/>
+          <a:p xmlns:a="http://schemas.openxmlformats.org/drawingml/2006/main">
+            <a:pPr algn="l">
+              <a:buNone/>
+              <a:defRPr sz="1650">
+                <a:solidFill>
+                  <a:srgbClr val="000000"/>
+                </a:solidFill>
+                <a:latin typeface="Helvetica Neue"/>
+                <a:ea typeface="Helvetica Neue"/>
+                <a:cs typeface="Helvetica Neue"/>
+              </a:defRPr>
+            </a:pPr>
+            <a:r>
+              <a:t>Each hypothesis receives an instrument topology, an economic mechanism, an orientation, and a rationale. Five candidates are frozen in each cell; repeated anchors remain visible rather than silently pooled.</a:t>
+            </a:r>
+          </a:p>
+        </p:txBody>
+      </p:sp>
+      <p:sp>
+        <p:nvSpPr>
+          <p:cNvPr id="7" name="stat-1">
+            <a:extLst xmlns:a="http://schemas.openxmlformats.org/drawingml/2006/main">
+              <a:ext uri="{FF2B5EF4-FFF2-40B4-BE49-F238E27FC236}">
+                <a16:creationId xmlns:a16="http://schemas.microsoft.com/office/drawing/2014/main" id="{447A29C0-2600-4241-BF6B-6797417FC507}"/>
+              </a:ext>
+            </a:extLst>
+          </p:cNvPr>
+          <p:cNvSpPr>
+            <a:spLocks xmlns:a="http://schemas.openxmlformats.org/drawingml/2006/main" noGrp="1"/>
+          </p:cNvSpPr>
+          <p:nvPr/>
+        </p:nvSpPr>
+        <p:spPr>
+          <a:xfrm xmlns:a="http://schemas.openxmlformats.org/drawingml/2006/main">
+            <a:off x="702374" y="3429000"/>
+            <a:ext cx="2940082" cy="1359313"/>
+          </a:xfrm>
+          <a:prstGeom xmlns:a="http://schemas.openxmlformats.org/drawingml/2006/main" prst="rect">
+            <a:avLst/>
+          </a:prstGeom>
+        </p:spPr>
+        <p:txBody>
+          <a:bodyPr xmlns:a="http://schemas.openxmlformats.org/drawingml/2006/main" lIns="0" tIns="0" rIns="0" bIns="0" anchor="b">
+            <a:normAutofit fontScale="100000"/>
+          </a:bodyPr>
+          <a:lstStyle xmlns:a="http://schemas.openxmlformats.org/drawingml/2006/main"/>
+          <a:p xmlns:a="http://schemas.openxmlformats.org/drawingml/2006/main">
+            <a:pPr algn="l">
+              <a:buNone/>
+              <a:defRPr sz="3225">
+                <a:solidFill>
+                  <a:srgbClr val="3D8DFF"/>
+                </a:solidFill>
+                <a:latin typeface="Helvetica Neue"/>
+                <a:ea typeface="Helvetica Neue"/>
+                <a:cs typeface="Helvetica Neue"/>
+              </a:defRPr>
+            </a:pPr>
+            <a:r>
+              <a:t>5 cells</a:t>
+            </a:r>
+          </a:p>
+        </p:txBody>
+      </p:sp>
+      <p:sp>
+        <p:nvSpPr>
+          <p:cNvPr id="8" name="stat-label-1">
+            <a:extLst xmlns:a="http://schemas.openxmlformats.org/drawingml/2006/main">
+              <a:ext uri="{FF2B5EF4-FFF2-40B4-BE49-F238E27FC236}">
+                <a16:creationId xmlns:a16="http://schemas.microsoft.com/office/drawing/2014/main" id="{1D2A853D-A304-477D-B8B8-F77F0101AC08}"/>
+              </a:ext>
+            </a:extLst>
+          </p:cNvPr>
+          <p:cNvSpPr>
+            <a:spLocks xmlns:a="http://schemas.openxmlformats.org/drawingml/2006/main" noGrp="1"/>
+          </p:cNvSpPr>
+          <p:nvPr/>
+        </p:nvSpPr>
+        <p:spPr>
+          <a:xfrm xmlns:a="http://schemas.openxmlformats.org/drawingml/2006/main">
+            <a:off x="702374" y="4900613"/>
+            <a:ext cx="2949607" cy="819150"/>
+          </a:xfrm>
+          <a:prstGeom xmlns:a="http://schemas.openxmlformats.org/drawingml/2006/main" prst="rect">
+            <a:avLst/>
+          </a:prstGeom>
+        </p:spPr>
+        <p:txBody>
+          <a:bodyPr xmlns:a="http://schemas.openxmlformats.org/drawingml/2006/main" lIns="0" tIns="45720" rIns="91440" bIns="45720" anchor="t">
+            <a:normAutofit fontScale="100000"/>
+          </a:bodyPr>
+          <a:lstStyle xmlns:a="http://schemas.openxmlformats.org/drawingml/2006/main"/>
+          <a:p xmlns:a="http://schemas.openxmlformats.org/drawingml/2006/main">
+            <a:pPr algn="l">
+              <a:buNone/>
+              <a:defRPr sz="1575">
+                <a:solidFill>
+                  <a:srgbClr val="000000"/>
+                </a:solidFill>
+                <a:latin typeface="Helvetica Neue"/>
+                <a:ea typeface="Helvetica Neue"/>
+                <a:cs typeface="Helvetica Neue"/>
+              </a:defRPr>
+            </a:pPr>
+            <a:r>
+              <a:t>ETF substitutes · related ETFs</a:t>
+            </a:r>
+          </a:p>
+          <a:p xmlns:a="http://schemas.openxmlformats.org/drawingml/2006/main">
+            <a:pPr algn="l">
+              <a:buNone/>
+              <a:defRPr sz="1575">
+                <a:solidFill>
+                  <a:srgbClr val="000000"/>
+                </a:solidFill>
+                <a:latin typeface="Helvetica Neue"/>
+                <a:ea typeface="Helvetica Neue"/>
+                <a:cs typeface="Helvetica Neue"/>
+              </a:defRPr>
+            </a:pPr>
+            <a:r>
+              <a:t>ETF–component · peers · asset proxies</a:t>
+            </a:r>
+          </a:p>
+        </p:txBody>
+      </p:sp>
+      <p:sp>
+        <p:nvSpPr>
+          <p:cNvPr id="9" name="stat-2">
+            <a:extLst xmlns:a="http://schemas.openxmlformats.org/drawingml/2006/main">
+              <a:ext uri="{FF2B5EF4-FFF2-40B4-BE49-F238E27FC236}">
+                <a16:creationId xmlns:a16="http://schemas.microsoft.com/office/drawing/2014/main" id="{342C60B8-5C35-4607-932D-DFD8E206B634}"/>
+              </a:ext>
+            </a:extLst>
+          </p:cNvPr>
+          <p:cNvSpPr>
+            <a:spLocks xmlns:a="http://schemas.openxmlformats.org/drawingml/2006/main" noGrp="1"/>
+          </p:cNvSpPr>
+          <p:nvPr/>
+        </p:nvSpPr>
+        <p:spPr>
+          <a:xfrm xmlns:a="http://schemas.openxmlformats.org/drawingml/2006/main">
+            <a:off x="4612958" y="3429000"/>
+            <a:ext cx="2940082" cy="1359313"/>
+          </a:xfrm>
+          <a:prstGeom xmlns:a="http://schemas.openxmlformats.org/drawingml/2006/main" prst="rect">
+            <a:avLst/>
+          </a:prstGeom>
+        </p:spPr>
+        <p:txBody>
+          <a:bodyPr xmlns:a="http://schemas.openxmlformats.org/drawingml/2006/main" lIns="0" tIns="0" rIns="0" bIns="0" anchor="b">
+            <a:normAutofit fontScale="100000"/>
+          </a:bodyPr>
+          <a:lstStyle xmlns:a="http://schemas.openxmlformats.org/drawingml/2006/main"/>
+          <a:p xmlns:a="http://schemas.openxmlformats.org/drawingml/2006/main">
+            <a:pPr algn="l">
+              <a:buNone/>
+              <a:defRPr sz="3225">
+                <a:solidFill>
+                  <a:srgbClr val="000000"/>
+                </a:solidFill>
+                <a:latin typeface="Helvetica Neue"/>
+                <a:ea typeface="Helvetica Neue"/>
+                <a:cs typeface="Helvetica Neue"/>
+              </a:defRPr>
+            </a:pPr>
+            <a:r>
+              <a:t>25 pairs</a:t>
+            </a:r>
+          </a:p>
+        </p:txBody>
+      </p:sp>
+      <p:sp>
+        <p:nvSpPr>
+          <p:cNvPr id="10" name="stat-label-2">
+            <a:extLst xmlns:a="http://schemas.openxmlformats.org/drawingml/2006/main">
+              <a:ext uri="{FF2B5EF4-FFF2-40B4-BE49-F238E27FC236}">
+                <a16:creationId xmlns:a16="http://schemas.microsoft.com/office/drawing/2014/main" id="{3123331A-6BB6-4FC3-B18C-EE98C6A8FF13}"/>
+              </a:ext>
+            </a:extLst>
+          </p:cNvPr>
+          <p:cNvSpPr>
+            <a:spLocks xmlns:a="http://schemas.openxmlformats.org/drawingml/2006/main" noGrp="1"/>
+          </p:cNvSpPr>
+          <p:nvPr/>
+        </p:nvSpPr>
+        <p:spPr>
+          <a:xfrm xmlns:a="http://schemas.openxmlformats.org/drawingml/2006/main">
+            <a:off x="4612958" y="4900613"/>
+            <a:ext cx="2949607" cy="819150"/>
+          </a:xfrm>
+          <a:prstGeom xmlns:a="http://schemas.openxmlformats.org/drawingml/2006/main" prst="rect">
+            <a:avLst/>
+          </a:prstGeom>
+        </p:spPr>
+        <p:txBody>
+          <a:bodyPr xmlns:a="http://schemas.openxmlformats.org/drawingml/2006/main" lIns="0" tIns="45720" rIns="91440" bIns="45720" anchor="t">
+            <a:normAutofit fontScale="100000"/>
+          </a:bodyPr>
+          <a:lstStyle xmlns:a="http://schemas.openxmlformats.org/drawingml/2006/main"/>
+          <a:p xmlns:a="http://schemas.openxmlformats.org/drawingml/2006/main">
+            <a:pPr algn="l">
+              <a:buNone/>
+              <a:defRPr sz="1575">
+                <a:solidFill>
+                  <a:srgbClr val="000000"/>
+                </a:solidFill>
+                <a:latin typeface="Helvetica Neue"/>
+                <a:ea typeface="Helvetica Neue"/>
+                <a:cs typeface="Helvetica Neue"/>
+              </a:defRPr>
+            </a:pPr>
+            <a:r>
+              <a:t>Five predeclared candidates per cell</a:t>
+            </a:r>
+          </a:p>
+          <a:p xmlns:a="http://schemas.openxmlformats.org/drawingml/2006/main">
+            <a:pPr algn="l">
+              <a:buNone/>
+              <a:defRPr sz="1575">
+                <a:solidFill>
+                  <a:srgbClr val="000000"/>
+                </a:solidFill>
+                <a:latin typeface="Helvetica Neue"/>
+                <a:ea typeface="Helvetica Neue"/>
+                <a:cs typeface="Helvetica Neue"/>
+              </a:defRPr>
+            </a:pPr>
+            <a:r>
+              <a:t>All outcomes retained</a:t>
+            </a:r>
+          </a:p>
+        </p:txBody>
+      </p:sp>
+      <p:sp>
+        <p:nvSpPr>
+          <p:cNvPr id="11" name="stat-3">
+            <a:extLst xmlns:a="http://schemas.openxmlformats.org/drawingml/2006/main">
+              <a:ext uri="{FF2B5EF4-FFF2-40B4-BE49-F238E27FC236}">
+                <a16:creationId xmlns:a16="http://schemas.microsoft.com/office/drawing/2014/main" id="{A0AD0C21-BC31-4957-B0CB-525311D4386F}"/>
+              </a:ext>
+            </a:extLst>
+          </p:cNvPr>
+          <p:cNvSpPr>
+            <a:spLocks xmlns:a="http://schemas.openxmlformats.org/drawingml/2006/main" noGrp="1"/>
+          </p:cNvSpPr>
+          <p:nvPr/>
+        </p:nvSpPr>
+        <p:spPr>
+          <a:xfrm xmlns:a="http://schemas.openxmlformats.org/drawingml/2006/main">
+            <a:off x="8562404" y="3429000"/>
+            <a:ext cx="2940082" cy="1359313"/>
+          </a:xfrm>
+          <a:prstGeom xmlns:a="http://schemas.openxmlformats.org/drawingml/2006/main" prst="rect">
+            <a:avLst/>
+          </a:prstGeom>
+        </p:spPr>
+        <p:txBody>
+          <a:bodyPr xmlns:a="http://schemas.openxmlformats.org/drawingml/2006/main" lIns="0" tIns="0" rIns="0" bIns="0" anchor="b">
+            <a:normAutofit fontScale="100000"/>
+          </a:bodyPr>
+          <a:lstStyle xmlns:a="http://schemas.openxmlformats.org/drawingml/2006/main"/>
+          <a:p xmlns:a="http://schemas.openxmlformats.org/drawingml/2006/main">
+            <a:pPr algn="l">
+              <a:buNone/>
+              <a:defRPr sz="3225">
+                <a:solidFill>
+                  <a:srgbClr val="000000"/>
+                </a:solidFill>
+                <a:latin typeface="Helvetica Neue"/>
+                <a:ea typeface="Helvetica Neue"/>
+                <a:cs typeface="Helvetica Neue"/>
+              </a:defRPr>
+            </a:pPr>
+            <a:r>
+              <a:t>1 rule</a:t>
+            </a:r>
+          </a:p>
+        </p:txBody>
+      </p:sp>
+      <p:sp>
+        <p:nvSpPr>
+          <p:cNvPr id="12" name="stat-label-3">
+            <a:extLst xmlns:a="http://schemas.openxmlformats.org/drawingml/2006/main">
+              <a:ext uri="{FF2B5EF4-FFF2-40B4-BE49-F238E27FC236}">
+                <a16:creationId xmlns:a16="http://schemas.microsoft.com/office/drawing/2014/main" id="{86C9D445-5711-4319-B967-D72E959CA06D}"/>
+              </a:ext>
+            </a:extLst>
+          </p:cNvPr>
+          <p:cNvSpPr>
+            <a:spLocks xmlns:a="http://schemas.openxmlformats.org/drawingml/2006/main" noGrp="1"/>
+          </p:cNvSpPr>
+          <p:nvPr/>
+        </p:nvSpPr>
+        <p:spPr>
+          <a:xfrm xmlns:a="http://schemas.openxmlformats.org/drawingml/2006/main">
+            <a:off x="8562404" y="4900613"/>
+            <a:ext cx="2949607" cy="819150"/>
+          </a:xfrm>
+          <a:prstGeom xmlns:a="http://schemas.openxmlformats.org/drawingml/2006/main" prst="rect">
+            <a:avLst/>
+          </a:prstGeom>
+        </p:spPr>
+        <p:txBody>
+          <a:bodyPr xmlns:a="http://schemas.openxmlformats.org/drawingml/2006/main" lIns="0" tIns="45720" rIns="91440" bIns="45720" anchor="t">
+            <a:normAutofit fontScale="100000"/>
+          </a:bodyPr>
+          <a:lstStyle xmlns:a="http://schemas.openxmlformats.org/drawingml/2006/main"/>
+          <a:p xmlns:a="http://schemas.openxmlformats.org/drawingml/2006/main">
+            <a:pPr algn="l">
+              <a:buNone/>
+              <a:defRPr sz="1575">
+                <a:solidFill>
+                  <a:srgbClr val="000000"/>
+                </a:solidFill>
+                <a:latin typeface="Helvetica Neue"/>
+                <a:ea typeface="Helvetica Neue"/>
+                <a:cs typeface="Helvetica Neue"/>
+              </a:defRPr>
+            </a:pPr>
+            <a:r>
+              <a:t>Unchanged 20-session adaptive spread</a:t>
+            </a:r>
+          </a:p>
+          <a:p xmlns:a="http://schemas.openxmlformats.org/drawingml/2006/main">
+            <a:pPr algn="l">
+              <a:buNone/>
+              <a:defRPr sz="1575">
+                <a:solidFill>
+                  <a:srgbClr val="000000"/>
+                </a:solidFill>
+                <a:latin typeface="Helvetica Neue"/>
+                <a:ea typeface="Helvetica Neue"/>
+                <a:cs typeface="Helvetica Neue"/>
+              </a:defRPr>
+            </a:pPr>
+            <a:r>
+              <a:t>Same costs and eight TRAIN gates</a:t>
+            </a:r>
+          </a:p>
+        </p:txBody>
+      </p:sp>
+    </p:spTree>
+    <p:extLst>
+      <p:ext uri="{BB962C8B-B14F-4D97-AF65-F5344CB8AC3E}">
+        <p14:creationId xmlns:p14="http://schemas.microsoft.com/office/powerpoint/2010/main" val="2098249639"/>
+      </p:ext>
+    </p:extLst>
+  </p:cSld>
+</p:sld>
+</file>
+
+<file path=ppt/slides/slide36.xml><?xml version="1.0" encoding="utf-8"?>
+<p:sld xmlns:p="http://schemas.openxmlformats.org/presentationml/2006/main">
+  <p:cSld>
+    <p:spTree>
+      <p:nvGrpSpPr>
+        <p:cNvPr id="1" name=""/>
+        <p:cNvGrpSpPr/>
+        <p:nvPr/>
+      </p:nvGrpSpPr>
+      <p:grpSpPr>
+        <a:xfrm xmlns:a="http://schemas.openxmlformats.org/drawingml/2006/main"/>
+      </p:grpSpPr>
+      <p:sp>
+        <p:nvSpPr>
+          <p:cNvPr id="6" name="footer">
+            <a:extLst xmlns:a="http://schemas.openxmlformats.org/drawingml/2006/main">
+              <a:ext uri="{FF2B5EF4-FFF2-40B4-BE49-F238E27FC236}">
+                <a16:creationId xmlns:a16="http://schemas.microsoft.com/office/drawing/2014/main" id="{5D1F4916-B18D-4F3F-8812-75A699D9A639}"/>
+              </a:ext>
+            </a:extLst>
+          </p:cNvPr>
+          <p:cNvSpPr>
+            <a:spLocks xmlns:a="http://schemas.openxmlformats.org/drawingml/2006/main" noGrp="1"/>
+          </p:cNvSpPr>
+          <p:nvPr/>
+        </p:nvSpPr>
+        <p:spPr>
+          <a:xfrm xmlns:a="http://schemas.openxmlformats.org/drawingml/2006/main">
+            <a:off x="11279315" y="6279261"/>
+            <a:ext cx="518922" cy="241268"/>
+          </a:xfrm>
+          <a:prstGeom xmlns:a="http://schemas.openxmlformats.org/drawingml/2006/main" prst="rect">
+            <a:avLst/>
+          </a:prstGeom>
+        </p:spPr>
+        <p:txBody>
+          <a:bodyPr xmlns:a="http://schemas.openxmlformats.org/drawingml/2006/main" lIns="0" tIns="0" rIns="0" bIns="0" anchor="b"/>
+          <a:lstStyle xmlns:a="http://schemas.openxmlformats.org/drawingml/2006/main"/>
+          <a:p xmlns:a="http://schemas.openxmlformats.org/drawingml/2006/main">
+            <a:pPr algn="r">
+              <a:buNone/>
+              <a:defRPr sz="1000">
+                <a:solidFill>
+                  <a:srgbClr val="000000"/>
+                </a:solidFill>
+                <a:latin typeface="Helvetica Neue"/>
+                <a:ea typeface="Helvetica Neue"/>
+                <a:cs typeface="Helvetica Neue"/>
+              </a:defRPr>
+            </a:pPr>
+            <a:r>
+              <a:t>36</a:t>
+            </a:r>
+          </a:p>
+        </p:txBody>
+      </p:sp>
+      <p:sp>
+        <p:nvSpPr>
+          <p:cNvPr id="2" name="title">
+            <a:extLst xmlns:a="http://schemas.openxmlformats.org/drawingml/2006/main">
+              <a:ext uri="{FF2B5EF4-FFF2-40B4-BE49-F238E27FC236}">
+                <a16:creationId xmlns:a16="http://schemas.microsoft.com/office/drawing/2014/main" id="{ECB77D9D-0CB0-4878-9A4A-2687A311CD30}"/>
+              </a:ext>
+            </a:extLst>
+          </p:cNvPr>
+          <p:cNvSpPr>
+            <a:spLocks xmlns:a="http://schemas.openxmlformats.org/drawingml/2006/main" noGrp="1"/>
+          </p:cNvSpPr>
+          <p:nvPr/>
+        </p:nvSpPr>
+        <p:spPr>
+          <a:xfrm xmlns:a="http://schemas.openxmlformats.org/drawingml/2006/main">
+            <a:off x="393668" y="295275"/>
+            <a:ext cx="11404568" cy="876300"/>
+          </a:xfrm>
+          <a:prstGeom xmlns:a="http://schemas.openxmlformats.org/drawingml/2006/main" prst="rect">
+            <a:avLst/>
+          </a:prstGeom>
+        </p:spPr>
+        <p:txBody>
+          <a:bodyPr xmlns:a="http://schemas.openxmlformats.org/drawingml/2006/main" lIns="0" tIns="0" rIns="0" bIns="0" anchor="t">
+            <a:normAutofit fontScale="100000"/>
+          </a:bodyPr>
+          <a:lstStyle xmlns:a="http://schemas.openxmlformats.org/drawingml/2006/main"/>
+          <a:p xmlns:a="http://schemas.openxmlformats.org/drawingml/2006/main">
+            <a:pPr algn="l">
+              <a:buNone/>
+              <a:defRPr sz="2900">
+                <a:solidFill>
+                  <a:srgbClr val="000000"/>
+                </a:solidFill>
+                <a:latin typeface="Helvetica Neue"/>
+                <a:ea typeface="Helvetica Neue"/>
+                <a:cs typeface="Helvetica Neue"/>
+              </a:defRPr>
+            </a:pPr>
+            <a:r>
+              <a:t>The categories reveal breadth, not a winner</a:t>
+            </a:r>
+          </a:p>
+        </p:txBody>
+      </p:sp>
+      <p:pic>
+        <p:nvPicPr>
+          <p:cNvPr id="12" name=""/>
+          <p:cNvPicPr>
+            <a:picLocks xmlns:a="http://schemas.openxmlformats.org/drawingml/2006/main" noChangeAspect="1"/>
+          </p:cNvPicPr>
+          <p:nvPr/>
+        </p:nvPicPr>
+        <p:blipFill>
+          <a:blip xmlns:r="http://schemas.openxmlformats.org/officeDocument/2006/relationships" xmlns:a="http://schemas.openxmlformats.org/drawingml/2006/main" r:embed="R99ef0d7b425c4d1e"/>
+          <a:stretch xmlns:a="http://schemas.openxmlformats.org/drawingml/2006/main"/>
+        </p:blipFill>
+        <p:spPr>
+          <a:xfrm xmlns:a="http://schemas.openxmlformats.org/drawingml/2006/main">
+            <a:off x="1891393" y="1162050"/>
+            <a:ext cx="8409214" cy="4905375"/>
+          </a:xfrm>
+          <a:prstGeom xmlns:a="http://schemas.openxmlformats.org/drawingml/2006/main" prst="rect">
+            <a:avLst/>
+          </a:prstGeom>
+        </p:spPr>
+      </p:pic>
+      <p:sp>
+        <p:nvSpPr>
+          <p:cNvPr id="8" name="">
+            <a:extLst xmlns:a="http://schemas.openxmlformats.org/drawingml/2006/main">
+              <a:ext uri="{FF2B5EF4-FFF2-40B4-BE49-F238E27FC236}">
+                <a16:creationId xmlns:a16="http://schemas.microsoft.com/office/drawing/2014/main" id="{F8EA68C6-EEAB-495D-AF3B-AF582E9F8557}"/>
+              </a:ext>
+            </a:extLst>
+          </p:cNvPr>
+          <p:cNvSpPr>
+            <a:spLocks xmlns:a="http://schemas.openxmlformats.org/drawingml/2006/main" noGrp="1"/>
+          </p:cNvSpPr>
+          <p:nvPr/>
+        </p:nvSpPr>
+        <p:spPr>
+          <a:xfrm xmlns:a="http://schemas.openxmlformats.org/drawingml/2006/main">
+            <a:off x="1891393" y="1162050"/>
+            <a:ext cx="8409214" cy="4905375"/>
+          </a:xfrm>
+          <a:prstGeom xmlns:a="http://schemas.openxmlformats.org/drawingml/2006/main" prst="rect">
+            <a:avLst/>
+          </a:prstGeom>
+          <a:solidFill xmlns:a="http://schemas.openxmlformats.org/drawingml/2006/main">
+            <a:srgbClr val="FFFFFF"/>
+          </a:solidFill>
+          <a:ln xmlns:a="http://schemas.openxmlformats.org/drawingml/2006/main" w="0">
+            <a:solidFill>
+              <a:srgbClr val="FFFFFF"/>
+            </a:solidFill>
+            <a:prstDash val="solid"/>
+          </a:ln>
+        </p:spPr>
+      </p:sp>
+      <p:pic>
+        <p:nvPicPr>
+          <p:cNvPr id="14" name=""/>
+          <p:cNvPicPr>
+            <a:picLocks xmlns:a="http://schemas.openxmlformats.org/drawingml/2006/main" noChangeAspect="1"/>
+          </p:cNvPicPr>
+          <p:nvPr/>
+        </p:nvPicPr>
+        <p:blipFill>
+          <a:blip xmlns:r="http://schemas.openxmlformats.org/officeDocument/2006/relationships" xmlns:a="http://schemas.openxmlformats.org/drawingml/2006/main" r:embed="R3da21b97373b4ac7"/>
+          <a:stretch xmlns:a="http://schemas.openxmlformats.org/drawingml/2006/main"/>
+        </p:blipFill>
+        <p:spPr>
+          <a:xfrm xmlns:a="http://schemas.openxmlformats.org/drawingml/2006/main">
+            <a:off x="1891393" y="1278845"/>
+            <a:ext cx="8409214" cy="4671786"/>
+          </a:xfrm>
+          <a:prstGeom xmlns:a="http://schemas.openxmlformats.org/drawingml/2006/main" prst="rect">
+            <a:avLst/>
+          </a:prstGeom>
+        </p:spPr>
+      </p:pic>
+    </p:spTree>
+    <p:extLst>
+      <p:ext uri="{BB962C8B-B14F-4D97-AF65-F5344CB8AC3E}">
+        <p14:creationId xmlns:p14="http://schemas.microsoft.com/office/powerpoint/2010/main" val="463436756"/>
+      </p:ext>
+    </p:extLst>
+  </p:cSld>
+</p:sld>
+</file>
+
+<file path=ppt/slides/slide37.xml><?xml version="1.0" encoding="utf-8"?>
+<p:sld xmlns:p="http://schemas.openxmlformats.org/presentationml/2006/main">
+  <p:cSld>
+    <p:spTree>
+      <p:nvGrpSpPr>
+        <p:cNvPr id="1" name=""/>
+        <p:cNvGrpSpPr/>
+        <p:nvPr/>
+      </p:nvGrpSpPr>
+      <p:grpSpPr>
+        <a:xfrm xmlns:a="http://schemas.openxmlformats.org/drawingml/2006/main"/>
+      </p:grpSpPr>
+      <p:sp>
+        <p:nvSpPr>
+          <p:cNvPr id="11" name="footer">
+            <a:extLst xmlns:a="http://schemas.openxmlformats.org/drawingml/2006/main">
+              <a:ext uri="{FF2B5EF4-FFF2-40B4-BE49-F238E27FC236}">
+                <a16:creationId xmlns:a16="http://schemas.microsoft.com/office/drawing/2014/main" id="{9833E848-7434-4F2E-A17C-B17541CAE597}"/>
+              </a:ext>
+            </a:extLst>
+          </p:cNvPr>
+          <p:cNvSpPr>
+            <a:spLocks xmlns:a="http://schemas.openxmlformats.org/drawingml/2006/main" noGrp="1"/>
+          </p:cNvSpPr>
+          <p:nvPr/>
+        </p:nvSpPr>
+        <p:spPr>
+          <a:xfrm xmlns:a="http://schemas.openxmlformats.org/drawingml/2006/main">
+            <a:off x="11279315" y="6279261"/>
+            <a:ext cx="518922" cy="241268"/>
+          </a:xfrm>
+          <a:prstGeom xmlns:a="http://schemas.openxmlformats.org/drawingml/2006/main" prst="rect">
+            <a:avLst/>
+          </a:prstGeom>
+        </p:spPr>
+        <p:txBody>
+          <a:bodyPr xmlns:a="http://schemas.openxmlformats.org/drawingml/2006/main" lIns="0" tIns="0" rIns="0" bIns="0" anchor="b"/>
+          <a:lstStyle xmlns:a="http://schemas.openxmlformats.org/drawingml/2006/main"/>
+          <a:p xmlns:a="http://schemas.openxmlformats.org/drawingml/2006/main">
+            <a:pPr algn="r">
+              <a:buNone/>
+              <a:defRPr sz="1000">
+                <a:solidFill>
+                  <a:srgbClr val="000000"/>
+                </a:solidFill>
+                <a:latin typeface="Helvetica Neue"/>
+                <a:ea typeface="Helvetica Neue"/>
+                <a:cs typeface="Helvetica Neue"/>
+              </a:defRPr>
+            </a:pPr>
+            <a:r>
+              <a:t>37</a:t>
+            </a:r>
+          </a:p>
+        </p:txBody>
+      </p:sp>
+      <p:sp>
+        <p:nvSpPr>
+          <p:cNvPr id="2" name="title">
+            <a:extLst xmlns:a="http://schemas.openxmlformats.org/drawingml/2006/main">
+              <a:ext uri="{FF2B5EF4-FFF2-40B4-BE49-F238E27FC236}">
+                <a16:creationId xmlns:a16="http://schemas.microsoft.com/office/drawing/2014/main" id="{317B658F-9EDE-4B04-B790-BFC2AB1127A9}"/>
+              </a:ext>
+            </a:extLst>
+          </p:cNvPr>
+          <p:cNvSpPr>
+            <a:spLocks xmlns:a="http://schemas.openxmlformats.org/drawingml/2006/main" noGrp="1"/>
+          </p:cNvSpPr>
+          <p:nvPr/>
+        </p:nvSpPr>
+        <p:spPr>
+          <a:xfrm xmlns:a="http://schemas.openxmlformats.org/drawingml/2006/main">
+            <a:off x="393668" y="344043"/>
+            <a:ext cx="11404568" cy="1047464"/>
+          </a:xfrm>
+          <a:prstGeom xmlns:a="http://schemas.openxmlformats.org/drawingml/2006/main" prst="rect">
+            <a:avLst/>
+          </a:prstGeom>
+        </p:spPr>
+        <p:txBody>
+          <a:bodyPr xmlns:a="http://schemas.openxmlformats.org/drawingml/2006/main" lIns="0" tIns="0" rIns="0" bIns="0" anchor="t">
+            <a:normAutofit fontScale="100000"/>
+          </a:bodyPr>
+          <a:lstStyle xmlns:a="http://schemas.openxmlformats.org/drawingml/2006/main"/>
+          <a:p xmlns:a="http://schemas.openxmlformats.org/drawingml/2006/main">
+            <a:pPr algn="l">
+              <a:buNone/>
+              <a:defRPr sz="2900">
+                <a:solidFill>
+                  <a:srgbClr val="000000"/>
+                </a:solidFill>
+                <a:latin typeface="Helvetica Neue"/>
+                <a:ea typeface="Helvetica Neue"/>
+                <a:cs typeface="Helvetica Neue"/>
+              </a:defRPr>
+            </a:pPr>
+            <a:r>
+              <a:t>One positive mean did not become a selected pair</a:t>
+            </a:r>
+          </a:p>
+        </p:txBody>
+      </p:sp>
+      <p:sp>
+        <p:nvSpPr>
+          <p:cNvPr id="3" name="left-stat-card">
+            <a:extLst xmlns:a="http://schemas.openxmlformats.org/drawingml/2006/main">
+              <a:ext uri="{FF2B5EF4-FFF2-40B4-BE49-F238E27FC236}">
+                <a16:creationId xmlns:a16="http://schemas.microsoft.com/office/drawing/2014/main" id="{CB5A1905-9B52-4859-9721-FAA37599F253}"/>
+              </a:ext>
+            </a:extLst>
+          </p:cNvPr>
+          <p:cNvSpPr>
+            <a:spLocks xmlns:a="http://schemas.openxmlformats.org/drawingml/2006/main" noGrp="1"/>
+          </p:cNvSpPr>
+          <p:nvPr/>
+        </p:nvSpPr>
+        <p:spPr>
+          <a:xfrm xmlns:a="http://schemas.openxmlformats.org/drawingml/2006/main">
+            <a:off x="6272022" y="3360039"/>
+            <a:ext cx="2581942" cy="2656523"/>
+          </a:xfrm>
+          <a:prstGeom xmlns:a="http://schemas.openxmlformats.org/drawingml/2006/main" prst="roundRect">
+            <a:avLst>
+              <a:gd name="adj" fmla="val 2951"/>
+            </a:avLst>
+          </a:prstGeom>
+          <a:solidFill xmlns:a="http://schemas.openxmlformats.org/drawingml/2006/main">
+            <a:srgbClr val="F2F2F2"/>
+          </a:solidFill>
+        </p:spPr>
+      </p:sp>
+      <p:sp>
+        <p:nvSpPr>
+          <p:cNvPr id="4" name="right-stat-card">
+            <a:extLst xmlns:a="http://schemas.openxmlformats.org/drawingml/2006/main">
+              <a:ext uri="{FF2B5EF4-FFF2-40B4-BE49-F238E27FC236}">
+                <a16:creationId xmlns:a16="http://schemas.microsoft.com/office/drawing/2014/main" id="{6D7A92E4-990F-443E-AA22-280485C87531}"/>
+              </a:ext>
+            </a:extLst>
+          </p:cNvPr>
+          <p:cNvSpPr>
+            <a:spLocks xmlns:a="http://schemas.openxmlformats.org/drawingml/2006/main" noGrp="1"/>
+          </p:cNvSpPr>
+          <p:nvPr/>
+        </p:nvSpPr>
+        <p:spPr>
+          <a:xfrm xmlns:a="http://schemas.openxmlformats.org/drawingml/2006/main">
+            <a:off x="9224201" y="3360039"/>
+            <a:ext cx="2581942" cy="2656523"/>
+          </a:xfrm>
+          <a:prstGeom xmlns:a="http://schemas.openxmlformats.org/drawingml/2006/main" prst="roundRect">
+            <a:avLst>
+              <a:gd name="adj" fmla="val 2951"/>
+            </a:avLst>
+          </a:prstGeom>
+          <a:solidFill xmlns:a="http://schemas.openxmlformats.org/drawingml/2006/main">
+            <a:srgbClr val="F2F2F2"/>
+          </a:solidFill>
+        </p:spPr>
+      </p:sp>
+      <p:sp>
+        <p:nvSpPr>
+          <p:cNvPr id="5" name="summary">
+            <a:extLst xmlns:a="http://schemas.openxmlformats.org/drawingml/2006/main">
+              <a:ext uri="{FF2B5EF4-FFF2-40B4-BE49-F238E27FC236}">
+                <a16:creationId xmlns:a16="http://schemas.microsoft.com/office/drawing/2014/main" id="{56D2558C-A20F-4C70-893B-6EAB7EAAD1B2}"/>
+              </a:ext>
+            </a:extLst>
+          </p:cNvPr>
+          <p:cNvSpPr>
+            <a:spLocks xmlns:a="http://schemas.openxmlformats.org/drawingml/2006/main" noGrp="1"/>
+          </p:cNvSpPr>
+          <p:nvPr/>
+        </p:nvSpPr>
+        <p:spPr>
+          <a:xfrm xmlns:a="http://schemas.openxmlformats.org/drawingml/2006/main">
+            <a:off x="6261068" y="1714500"/>
+            <a:ext cx="5539835" cy="1381125"/>
+          </a:xfrm>
+          <a:prstGeom xmlns:a="http://schemas.openxmlformats.org/drawingml/2006/main" prst="rect">
+            <a:avLst/>
+          </a:prstGeom>
+        </p:spPr>
+        <p:txBody>
+          <a:bodyPr xmlns:a="http://schemas.openxmlformats.org/drawingml/2006/main" lIns="0" tIns="0" rIns="0" bIns="0" anchor="t">
+            <a:normAutofit fontScale="100000"/>
+          </a:bodyPr>
+          <a:lstStyle xmlns:a="http://schemas.openxmlformats.org/drawingml/2006/main"/>
+          <a:p xmlns:a="http://schemas.openxmlformats.org/drawingml/2006/main">
+            <a:pPr algn="l">
+              <a:buNone/>
+              <a:defRPr sz="1800">
+                <a:solidFill>
+                  <a:srgbClr val="000000"/>
+                </a:solidFill>
+                <a:latin typeface="Helvetica Neue"/>
+                <a:ea typeface="Helvetica Neue"/>
+                <a:cs typeface="Helvetica Neue"/>
+              </a:defRPr>
+            </a:pPr>
+            <a:r>
+              <a:t>SIL–SLV produced a positive TRAIN mean, but its 95% moving-block interval crossed zero and the forward-convergence upper bound remained barely positive.</a:t>
+            </a:r>
+          </a:p>
+        </p:txBody>
+      </p:sp>
+      <p:sp>
+        <p:nvSpPr>
+          <p:cNvPr id="6" name="left-stat">
+            <a:extLst xmlns:a="http://schemas.openxmlformats.org/drawingml/2006/main">
+              <a:ext uri="{FF2B5EF4-FFF2-40B4-BE49-F238E27FC236}">
+                <a16:creationId xmlns:a16="http://schemas.microsoft.com/office/drawing/2014/main" id="{5C6C71CB-7475-4DF6-B7F0-0931DF047551}"/>
+              </a:ext>
+            </a:extLst>
+          </p:cNvPr>
+          <p:cNvSpPr>
+            <a:spLocks xmlns:a="http://schemas.openxmlformats.org/drawingml/2006/main" noGrp="1"/>
+          </p:cNvSpPr>
+          <p:nvPr/>
+        </p:nvSpPr>
+        <p:spPr>
+          <a:xfrm xmlns:a="http://schemas.openxmlformats.org/drawingml/2006/main">
+            <a:off x="6509385" y="3579971"/>
+            <a:ext cx="2133314" cy="1155859"/>
+          </a:xfrm>
+          <a:prstGeom xmlns:a="http://schemas.openxmlformats.org/drawingml/2006/main" prst="rect">
+            <a:avLst/>
+          </a:prstGeom>
+        </p:spPr>
+        <p:txBody>
+          <a:bodyPr xmlns:a="http://schemas.openxmlformats.org/drawingml/2006/main" lIns="0" tIns="0" rIns="0" bIns="0" anchor="b">
+            <a:normAutofit fontScale="100000"/>
+          </a:bodyPr>
+          <a:lstStyle xmlns:a="http://schemas.openxmlformats.org/drawingml/2006/main"/>
+          <a:p xmlns:a="http://schemas.openxmlformats.org/drawingml/2006/main">
+            <a:pPr algn="l">
+              <a:buNone/>
+              <a:defRPr sz="2700">
+                <a:solidFill>
+                  <a:srgbClr val="3D8DFF"/>
+                </a:solidFill>
+                <a:latin typeface="Helvetica Neue"/>
+                <a:ea typeface="Helvetica Neue"/>
+                <a:cs typeface="Helvetica Neue"/>
+              </a:defRPr>
+            </a:pPr>
+            <a:r>
+              <a:t>0 / 25</a:t>
+            </a:r>
+          </a:p>
+        </p:txBody>
+      </p:sp>
+      <p:sp>
+        <p:nvSpPr>
+          <p:cNvPr id="7" name="left-stat-label">
+            <a:extLst xmlns:a="http://schemas.openxmlformats.org/drawingml/2006/main">
+              <a:ext uri="{FF2B5EF4-FFF2-40B4-BE49-F238E27FC236}">
+                <a16:creationId xmlns:a16="http://schemas.microsoft.com/office/drawing/2014/main" id="{471C1151-75AF-40A2-A5A1-4F7713D23356}"/>
+              </a:ext>
+            </a:extLst>
+          </p:cNvPr>
+          <p:cNvSpPr>
+            <a:spLocks xmlns:a="http://schemas.openxmlformats.org/drawingml/2006/main" noGrp="1"/>
+          </p:cNvSpPr>
+          <p:nvPr/>
+        </p:nvSpPr>
+        <p:spPr>
+          <a:xfrm xmlns:a="http://schemas.openxmlformats.org/drawingml/2006/main">
+            <a:off x="6575965" y="4953000"/>
+            <a:ext cx="2066735" cy="762000"/>
+          </a:xfrm>
+          <a:prstGeom xmlns:a="http://schemas.openxmlformats.org/drawingml/2006/main" prst="rect">
+            <a:avLst/>
+          </a:prstGeom>
+        </p:spPr>
+        <p:txBody>
+          <a:bodyPr xmlns:a="http://schemas.openxmlformats.org/drawingml/2006/main" lIns="0" tIns="0" rIns="0" bIns="0">
+            <a:normAutofit fontScale="100000"/>
+          </a:bodyPr>
+          <a:lstStyle xmlns:a="http://schemas.openxmlformats.org/drawingml/2006/main"/>
+          <a:p xmlns:a="http://schemas.openxmlformats.org/drawingml/2006/main">
+            <a:pPr algn="l">
+              <a:buNone/>
+              <a:defRPr sz="1500">
+                <a:solidFill>
+                  <a:srgbClr val="000000"/>
+                </a:solidFill>
+                <a:latin typeface="Helvetica Neue"/>
+                <a:ea typeface="Helvetica Neue"/>
+                <a:cs typeface="Helvetica Neue"/>
+              </a:defRPr>
+            </a:pPr>
+            <a:r>
+              <a:t>Pairs passing</a:t>
+            </a:r>
+          </a:p>
+          <a:p xmlns:a="http://schemas.openxmlformats.org/drawingml/2006/main">
+            <a:pPr algn="l">
+              <a:buNone/>
+              <a:defRPr sz="1500">
+                <a:solidFill>
+                  <a:srgbClr val="000000"/>
+                </a:solidFill>
+                <a:latin typeface="Helvetica Neue"/>
+                <a:ea typeface="Helvetica Neue"/>
+                <a:cs typeface="Helvetica Neue"/>
+              </a:defRPr>
+            </a:pPr>
+            <a:r>
+              <a:t>all eight TRAIN gates</a:t>
+            </a:r>
+          </a:p>
+        </p:txBody>
+      </p:sp>
+      <p:sp>
+        <p:nvSpPr>
+          <p:cNvPr id="8" name="right-stat">
+            <a:extLst xmlns:a="http://schemas.openxmlformats.org/drawingml/2006/main">
+              <a:ext uri="{FF2B5EF4-FFF2-40B4-BE49-F238E27FC236}">
+                <a16:creationId xmlns:a16="http://schemas.microsoft.com/office/drawing/2014/main" id="{423A9D83-D670-4C26-B583-F1C469F9EC40}"/>
+              </a:ext>
+            </a:extLst>
+          </p:cNvPr>
+          <p:cNvSpPr>
+            <a:spLocks xmlns:a="http://schemas.openxmlformats.org/drawingml/2006/main" noGrp="1"/>
+          </p:cNvSpPr>
+          <p:nvPr/>
+        </p:nvSpPr>
+        <p:spPr>
+          <a:xfrm xmlns:a="http://schemas.openxmlformats.org/drawingml/2006/main">
+            <a:off x="9461564" y="3579971"/>
+            <a:ext cx="2133314" cy="1155859"/>
+          </a:xfrm>
+          <a:prstGeom xmlns:a="http://schemas.openxmlformats.org/drawingml/2006/main" prst="rect">
+            <a:avLst/>
+          </a:prstGeom>
+        </p:spPr>
+        <p:txBody>
+          <a:bodyPr xmlns:a="http://schemas.openxmlformats.org/drawingml/2006/main" lIns="0" tIns="0" rIns="0" bIns="0" anchor="b">
+            <a:normAutofit fontScale="100000"/>
+          </a:bodyPr>
+          <a:lstStyle xmlns:a="http://schemas.openxmlformats.org/drawingml/2006/main"/>
+          <a:p xmlns:a="http://schemas.openxmlformats.org/drawingml/2006/main">
+            <a:pPr algn="l">
+              <a:buNone/>
+              <a:defRPr sz="2700">
+                <a:solidFill>
+                  <a:srgbClr val="B42318"/>
+                </a:solidFill>
+                <a:latin typeface="Helvetica Neue"/>
+                <a:ea typeface="Helvetica Neue"/>
+                <a:cs typeface="Helvetica Neue"/>
+              </a:defRPr>
+            </a:pPr>
+            <a:r>
+              <a:t>1 / 25</a:t>
+            </a:r>
+          </a:p>
+        </p:txBody>
+      </p:sp>
+      <p:sp>
+        <p:nvSpPr>
+          <p:cNvPr id="9" name="right-stat-label">
+            <a:extLst xmlns:a="http://schemas.openxmlformats.org/drawingml/2006/main">
+              <a:ext uri="{FF2B5EF4-FFF2-40B4-BE49-F238E27FC236}">
+                <a16:creationId xmlns:a16="http://schemas.microsoft.com/office/drawing/2014/main" id="{F039A1C2-F7F7-4D0E-BDC1-2BD29C9D7E4C}"/>
+              </a:ext>
+            </a:extLst>
+          </p:cNvPr>
+          <p:cNvSpPr>
+            <a:spLocks xmlns:a="http://schemas.openxmlformats.org/drawingml/2006/main" noGrp="1"/>
+          </p:cNvSpPr>
+          <p:nvPr/>
+        </p:nvSpPr>
+        <p:spPr>
+          <a:xfrm xmlns:a="http://schemas.openxmlformats.org/drawingml/2006/main">
+            <a:off x="9528143" y="4953000"/>
+            <a:ext cx="2066735" cy="762000"/>
+          </a:xfrm>
+          <a:prstGeom xmlns:a="http://schemas.openxmlformats.org/drawingml/2006/main" prst="rect">
+            <a:avLst/>
+          </a:prstGeom>
+        </p:spPr>
+        <p:txBody>
+          <a:bodyPr xmlns:a="http://schemas.openxmlformats.org/drawingml/2006/main" lIns="0" tIns="0" rIns="0" bIns="0">
+            <a:normAutofit fontScale="100000"/>
+          </a:bodyPr>
+          <a:lstStyle xmlns:a="http://schemas.openxmlformats.org/drawingml/2006/main"/>
+          <a:p xmlns:a="http://schemas.openxmlformats.org/drawingml/2006/main">
+            <a:pPr algn="l">
+              <a:buNone/>
+              <a:defRPr sz="1500">
+                <a:solidFill>
+                  <a:srgbClr val="000000"/>
+                </a:solidFill>
+                <a:latin typeface="Helvetica Neue"/>
+                <a:ea typeface="Helvetica Neue"/>
+                <a:cs typeface="Helvetica Neue"/>
+              </a:defRPr>
+            </a:pPr>
+            <a:r>
+              <a:t>Positive mean net return</a:t>
+            </a:r>
+          </a:p>
+          <a:p xmlns:a="http://schemas.openxmlformats.org/drawingml/2006/main">
+            <a:pPr algn="l">
+              <a:buNone/>
+              <a:defRPr sz="1500">
+                <a:solidFill>
+                  <a:srgbClr val="000000"/>
+                </a:solidFill>
+                <a:latin typeface="Helvetica Neue"/>
+                <a:ea typeface="Helvetica Neue"/>
+                <a:cs typeface="Helvetica Neue"/>
+              </a:defRPr>
+            </a:pPr>
+            <a:r>
+              <a:t>SIL–SLV only</a:t>
+            </a:r>
+          </a:p>
+        </p:txBody>
+      </p:sp>
+      <p:pic>
+        <p:nvPicPr>
+          <p:cNvPr id="31" name=""/>
+          <p:cNvPicPr>
+            <a:picLocks xmlns:a="http://schemas.openxmlformats.org/drawingml/2006/main" noChangeAspect="1"/>
+          </p:cNvPicPr>
+          <p:nvPr/>
+        </p:nvPicPr>
+        <p:blipFill>
+          <a:blip xmlns:r="http://schemas.openxmlformats.org/officeDocument/2006/relationships" xmlns:a="http://schemas.openxmlformats.org/drawingml/2006/main" r:embed="Rad16f3415ede4ac9"/>
+          <a:stretch xmlns:a="http://schemas.openxmlformats.org/drawingml/2006/main"/>
+        </p:blipFill>
+        <p:spPr>
+          <a:xfrm xmlns:a="http://schemas.openxmlformats.org/drawingml/2006/main">
+            <a:off x="385858" y="2576472"/>
+            <a:ext cx="5534216" cy="2371807"/>
+          </a:xfrm>
+          <a:prstGeom xmlns:a="http://schemas.openxmlformats.org/drawingml/2006/main" prst="rect">
+            <a:avLst/>
+          </a:prstGeom>
+        </p:spPr>
+      </p:pic>
+      <p:sp>
+        <p:nvSpPr>
+          <p:cNvPr id="13" name="">
+            <a:extLst xmlns:a="http://schemas.openxmlformats.org/drawingml/2006/main">
+              <a:ext uri="{FF2B5EF4-FFF2-40B4-BE49-F238E27FC236}">
+                <a16:creationId xmlns:a16="http://schemas.microsoft.com/office/drawing/2014/main" id="{D95C8B50-6D11-41E2-81BC-7768CA7E2749}"/>
+              </a:ext>
+            </a:extLst>
+          </p:cNvPr>
+          <p:cNvSpPr>
+            <a:spLocks xmlns:a="http://schemas.openxmlformats.org/drawingml/2006/main" noGrp="1"/>
+          </p:cNvSpPr>
+          <p:nvPr/>
+        </p:nvSpPr>
+        <p:spPr>
+          <a:xfrm xmlns:a="http://schemas.openxmlformats.org/drawingml/2006/main">
+            <a:off x="385858" y="2576472"/>
+            <a:ext cx="5534216" cy="2371807"/>
+          </a:xfrm>
+          <a:prstGeom xmlns:a="http://schemas.openxmlformats.org/drawingml/2006/main" prst="rect">
+            <a:avLst/>
+          </a:prstGeom>
+          <a:solidFill xmlns:a="http://schemas.openxmlformats.org/drawingml/2006/main">
+            <a:srgbClr val="FFFFFF"/>
+          </a:solidFill>
+          <a:ln xmlns:a="http://schemas.openxmlformats.org/drawingml/2006/main" w="0">
+            <a:solidFill>
+              <a:srgbClr val="FFFFFF"/>
+            </a:solidFill>
+            <a:prstDash val="solid"/>
+          </a:ln>
+        </p:spPr>
+      </p:sp>
+      <p:pic>
+        <p:nvPicPr>
+          <p:cNvPr id="33" name=""/>
+          <p:cNvPicPr>
+            <a:picLocks xmlns:a="http://schemas.openxmlformats.org/drawingml/2006/main" noChangeAspect="1"/>
+          </p:cNvPicPr>
+          <p:nvPr/>
+        </p:nvPicPr>
+        <p:blipFill>
+          <a:blip xmlns:r="http://schemas.openxmlformats.org/officeDocument/2006/relationships" xmlns:a="http://schemas.openxmlformats.org/drawingml/2006/main" r:embed="R4745c8f8a8cf4504"/>
+          <a:stretch xmlns:a="http://schemas.openxmlformats.org/drawingml/2006/main"/>
+        </p:blipFill>
+        <p:spPr>
+          <a:xfrm xmlns:a="http://schemas.openxmlformats.org/drawingml/2006/main">
+            <a:off x="1350393" y="2576472"/>
+            <a:ext cx="3605147" cy="2371807"/>
+          </a:xfrm>
+          <a:prstGeom xmlns:a="http://schemas.openxmlformats.org/drawingml/2006/main" prst="rect">
+            <a:avLst/>
+          </a:prstGeom>
+        </p:spPr>
+      </p:pic>
+      <p:sp>
+        <p:nvSpPr>
+          <p:cNvPr id="16" name="">
+            <a:extLst xmlns:a="http://schemas.openxmlformats.org/drawingml/2006/main">
+              <a:ext uri="{FF2B5EF4-FFF2-40B4-BE49-F238E27FC236}">
+                <a16:creationId xmlns:a16="http://schemas.microsoft.com/office/drawing/2014/main" id="{BCF1971E-0797-4B2A-9D4E-EA0B3D57963F}"/>
+              </a:ext>
+            </a:extLst>
+          </p:cNvPr>
+          <p:cNvSpPr>
+            <a:spLocks xmlns:a="http://schemas.openxmlformats.org/drawingml/2006/main" noGrp="1"/>
+          </p:cNvSpPr>
+          <p:nvPr/>
+        </p:nvSpPr>
+        <p:spPr>
+          <a:xfrm xmlns:a="http://schemas.openxmlformats.org/drawingml/2006/main">
+            <a:off x="385858" y="2576472"/>
+            <a:ext cx="5534216" cy="2371807"/>
+          </a:xfrm>
+          <a:prstGeom xmlns:a="http://schemas.openxmlformats.org/drawingml/2006/main" prst="rect">
+            <a:avLst/>
+          </a:prstGeom>
+          <a:solidFill xmlns:a="http://schemas.openxmlformats.org/drawingml/2006/main">
+            <a:srgbClr val="FFFFFF"/>
+          </a:solidFill>
+          <a:ln xmlns:a="http://schemas.openxmlformats.org/drawingml/2006/main" w="0">
+            <a:solidFill>
+              <a:srgbClr val="FFFFFF"/>
+            </a:solidFill>
+            <a:prstDash val="solid"/>
+          </a:ln>
+        </p:spPr>
+      </p:sp>
+      <p:pic>
+        <p:nvPicPr>
+          <p:cNvPr id="35" name=""/>
+          <p:cNvPicPr>
+            <a:picLocks xmlns:a="http://schemas.openxmlformats.org/drawingml/2006/main" noChangeAspect="1"/>
+          </p:cNvPicPr>
+          <p:nvPr/>
+        </p:nvPicPr>
+        <p:blipFill>
+          <a:blip xmlns:r="http://schemas.openxmlformats.org/officeDocument/2006/relationships" xmlns:a="http://schemas.openxmlformats.org/drawingml/2006/main" r:embed="R4296510ff1f4416f"/>
+          <a:stretch xmlns:a="http://schemas.openxmlformats.org/drawingml/2006/main"/>
+        </p:blipFill>
+        <p:spPr>
+          <a:xfrm xmlns:a="http://schemas.openxmlformats.org/drawingml/2006/main">
+            <a:off x="1350393" y="2576472"/>
+            <a:ext cx="3605147" cy="2371807"/>
+          </a:xfrm>
+          <a:prstGeom xmlns:a="http://schemas.openxmlformats.org/drawingml/2006/main" prst="rect">
+            <a:avLst/>
+          </a:prstGeom>
+        </p:spPr>
+      </p:pic>
+      <p:sp>
+        <p:nvSpPr>
+          <p:cNvPr id="20" name="">
+            <a:extLst xmlns:a="http://schemas.openxmlformats.org/drawingml/2006/main">
+              <a:ext uri="{FF2B5EF4-FFF2-40B4-BE49-F238E27FC236}">
+                <a16:creationId xmlns:a16="http://schemas.microsoft.com/office/drawing/2014/main" id="{8557D367-3D9B-468C-8B37-92E7AED724CE}"/>
+              </a:ext>
+            </a:extLst>
+          </p:cNvPr>
+          <p:cNvSpPr>
+            <a:spLocks xmlns:a="http://schemas.openxmlformats.org/drawingml/2006/main" noGrp="1"/>
+          </p:cNvSpPr>
+          <p:nvPr/>
+        </p:nvSpPr>
+        <p:spPr>
+          <a:xfrm xmlns:a="http://schemas.openxmlformats.org/drawingml/2006/main">
+            <a:off x="385858" y="2576472"/>
+            <a:ext cx="5534216" cy="2371807"/>
+          </a:xfrm>
+          <a:prstGeom xmlns:a="http://schemas.openxmlformats.org/drawingml/2006/main" prst="rect">
+            <a:avLst/>
+          </a:prstGeom>
+          <a:solidFill xmlns:a="http://schemas.openxmlformats.org/drawingml/2006/main">
+            <a:srgbClr val="FFFFFF"/>
+          </a:solidFill>
+          <a:ln xmlns:a="http://schemas.openxmlformats.org/drawingml/2006/main" w="0">
+            <a:solidFill>
+              <a:srgbClr val="FFFFFF"/>
+            </a:solidFill>
+            <a:prstDash val="solid"/>
+          </a:ln>
+        </p:spPr>
+      </p:sp>
+      <p:pic>
+        <p:nvPicPr>
+          <p:cNvPr id="37" name=""/>
+          <p:cNvPicPr>
+            <a:picLocks xmlns:a="http://schemas.openxmlformats.org/drawingml/2006/main" noChangeAspect="1"/>
+          </p:cNvPicPr>
+          <p:nvPr/>
+        </p:nvPicPr>
+        <p:blipFill>
+          <a:blip xmlns:r="http://schemas.openxmlformats.org/officeDocument/2006/relationships" xmlns:a="http://schemas.openxmlformats.org/drawingml/2006/main" r:embed="Rc4379cb2e5594c8f"/>
+          <a:stretch xmlns:a="http://schemas.openxmlformats.org/drawingml/2006/main"/>
+        </p:blipFill>
+        <p:spPr>
+          <a:xfrm xmlns:a="http://schemas.openxmlformats.org/drawingml/2006/main">
+            <a:off x="1350393" y="2576472"/>
+            <a:ext cx="3605147" cy="2371807"/>
+          </a:xfrm>
+          <a:prstGeom xmlns:a="http://schemas.openxmlformats.org/drawingml/2006/main" prst="rect">
+            <a:avLst/>
+          </a:prstGeom>
+        </p:spPr>
+      </p:pic>
+    </p:spTree>
+    <p:extLst>
+      <p:ext uri="{BB962C8B-B14F-4D97-AF65-F5344CB8AC3E}">
+        <p14:creationId xmlns:p14="http://schemas.microsoft.com/office/powerpoint/2010/main" val="227946046"/>
+      </p:ext>
+    </p:extLst>
+  </p:cSld>
+</p:sld>
+</file>
+
+<file path=ppt/slides/slide38.xml><?xml version="1.0" encoding="utf-8"?>
+<p:sld xmlns:p="http://schemas.openxmlformats.org/presentationml/2006/main">
+  <p:cSld>
+    <p:spTree>
+      <p:nvGrpSpPr>
+        <p:cNvPr id="1" name=""/>
+        <p:cNvGrpSpPr/>
+        <p:nvPr/>
+      </p:nvGrpSpPr>
+      <p:grpSpPr>
+        <a:xfrm xmlns:a="http://schemas.openxmlformats.org/drawingml/2006/main"/>
+      </p:grpSpPr>
+      <p:sp>
+        <p:nvSpPr>
+          <p:cNvPr id="6" name="footer">
+            <a:extLst xmlns:a="http://schemas.openxmlformats.org/drawingml/2006/main">
+              <a:ext uri="{FF2B5EF4-FFF2-40B4-BE49-F238E27FC236}">
+                <a16:creationId xmlns:a16="http://schemas.microsoft.com/office/drawing/2014/main" id="{5D1F4916-B18D-4F3F-8812-75A699D9A639}"/>
+              </a:ext>
+            </a:extLst>
+          </p:cNvPr>
+          <p:cNvSpPr>
+            <a:spLocks xmlns:a="http://schemas.openxmlformats.org/drawingml/2006/main" noGrp="1"/>
+          </p:cNvSpPr>
+          <p:nvPr/>
+        </p:nvSpPr>
+        <p:spPr>
+          <a:xfrm xmlns:a="http://schemas.openxmlformats.org/drawingml/2006/main">
+            <a:off x="11279315" y="6279261"/>
+            <a:ext cx="518922" cy="241268"/>
+          </a:xfrm>
+          <a:prstGeom xmlns:a="http://schemas.openxmlformats.org/drawingml/2006/main" prst="rect">
+            <a:avLst/>
+          </a:prstGeom>
+        </p:spPr>
+        <p:txBody>
+          <a:bodyPr xmlns:a="http://schemas.openxmlformats.org/drawingml/2006/main" lIns="0" tIns="0" rIns="0" bIns="0" anchor="b"/>
+          <a:lstStyle xmlns:a="http://schemas.openxmlformats.org/drawingml/2006/main"/>
+          <a:p xmlns:a="http://schemas.openxmlformats.org/drawingml/2006/main">
+            <a:pPr algn="r">
+              <a:buNone/>
+              <a:defRPr sz="1000">
+                <a:solidFill>
+                  <a:srgbClr val="000000"/>
+                </a:solidFill>
+                <a:latin typeface="Helvetica Neue"/>
+                <a:ea typeface="Helvetica Neue"/>
+                <a:cs typeface="Helvetica Neue"/>
+              </a:defRPr>
+            </a:pPr>
+            <a:r>
+              <a:t>38</a:t>
+            </a:r>
+          </a:p>
+        </p:txBody>
+      </p:sp>
+      <p:sp>
+        <p:nvSpPr>
+          <p:cNvPr id="2" name="title">
+            <a:extLst xmlns:a="http://schemas.openxmlformats.org/drawingml/2006/main">
+              <a:ext uri="{FF2B5EF4-FFF2-40B4-BE49-F238E27FC236}">
+                <a16:creationId xmlns:a16="http://schemas.microsoft.com/office/drawing/2014/main" id="{ECB77D9D-0CB0-4878-9A4A-2687A311CD30}"/>
+              </a:ext>
+            </a:extLst>
+          </p:cNvPr>
+          <p:cNvSpPr>
+            <a:spLocks xmlns:a="http://schemas.openxmlformats.org/drawingml/2006/main" noGrp="1"/>
+          </p:cNvSpPr>
+          <p:nvPr/>
+        </p:nvSpPr>
+        <p:spPr>
+          <a:xfrm xmlns:a="http://schemas.openxmlformats.org/drawingml/2006/main">
+            <a:off x="393668" y="344043"/>
+            <a:ext cx="5537168" cy="1143000"/>
+          </a:xfrm>
+          <a:prstGeom xmlns:a="http://schemas.openxmlformats.org/drawingml/2006/main" prst="rect">
+            <a:avLst/>
+          </a:prstGeom>
+        </p:spPr>
+        <p:txBody>
+          <a:bodyPr xmlns:a="http://schemas.openxmlformats.org/drawingml/2006/main" lIns="0" tIns="0" rIns="0" bIns="0" anchor="t">
+            <a:normAutofit fontScale="100000"/>
+          </a:bodyPr>
+          <a:lstStyle xmlns:a="http://schemas.openxmlformats.org/drawingml/2006/main"/>
+          <a:p xmlns:a="http://schemas.openxmlformats.org/drawingml/2006/main">
+            <a:pPr algn="l">
+              <a:buNone/>
+              <a:defRPr sz="2900">
+                <a:solidFill>
+                  <a:srgbClr val="000000"/>
+                </a:solidFill>
+                <a:latin typeface="Helvetica Neue"/>
+                <a:ea typeface="Helvetica Neue"/>
+                <a:cs typeface="Helvetica Neue"/>
+              </a:defRPr>
+            </a:pPr>
+            <a:r>
+              <a:t>Validity and activity were common; robust economics were not</a:t>
+            </a:r>
+          </a:p>
+        </p:txBody>
+      </p:sp>
+      <p:sp>
+        <p:nvSpPr>
+          <p:cNvPr id="3" name="image-backing">
+            <a:extLst xmlns:a="http://schemas.openxmlformats.org/drawingml/2006/main">
+              <a:ext uri="{FF2B5EF4-FFF2-40B4-BE49-F238E27FC236}">
+                <a16:creationId xmlns:a16="http://schemas.microsoft.com/office/drawing/2014/main" id="{6220C938-B9AD-4B79-90E3-107E303A9D02}"/>
+              </a:ext>
+            </a:extLst>
+          </p:cNvPr>
+          <p:cNvSpPr>
+            <a:spLocks xmlns:a="http://schemas.openxmlformats.org/drawingml/2006/main" noGrp="1"/>
+          </p:cNvSpPr>
+          <p:nvPr/>
+        </p:nvSpPr>
+        <p:spPr>
+          <a:xfrm xmlns:a="http://schemas.openxmlformats.org/drawingml/2006/main">
+            <a:off x="6269069" y="396431"/>
+            <a:ext cx="5539740" cy="5602034"/>
+          </a:xfrm>
+          <a:prstGeom xmlns:a="http://schemas.openxmlformats.org/drawingml/2006/main" prst="roundRect">
+            <a:avLst>
+              <a:gd name="adj" fmla="val 1376"/>
+            </a:avLst>
+          </a:prstGeom>
+          <a:solidFill xmlns:a="http://schemas.openxmlformats.org/drawingml/2006/main">
+            <a:srgbClr val="EAF5FB"/>
+          </a:solidFill>
+          <a:ln xmlns:a="http://schemas.openxmlformats.org/drawingml/2006/main" w="9525">
+            <a:solidFill>
+              <a:srgbClr val="B8BCC4"/>
+            </a:solidFill>
+            <a:prstDash val="solid"/>
+          </a:ln>
+        </p:spPr>
+      </p:sp>
+      <p:sp>
+        <p:nvSpPr>
+          <p:cNvPr id="4" name="body">
+            <a:extLst xmlns:a="http://schemas.openxmlformats.org/drawingml/2006/main">
+              <a:ext uri="{FF2B5EF4-FFF2-40B4-BE49-F238E27FC236}">
+                <a16:creationId xmlns:a16="http://schemas.microsoft.com/office/drawing/2014/main" id="{3F760EC2-C6B5-4968-A4B1-EBAD286BA351}"/>
+              </a:ext>
+            </a:extLst>
+          </p:cNvPr>
+          <p:cNvSpPr>
+            <a:spLocks xmlns:a="http://schemas.openxmlformats.org/drawingml/2006/main" noGrp="1"/>
+          </p:cNvSpPr>
+          <p:nvPr/>
+        </p:nvSpPr>
+        <p:spPr>
+          <a:xfrm xmlns:a="http://schemas.openxmlformats.org/drawingml/2006/main">
+            <a:off x="393668" y="1695450"/>
+            <a:ext cx="5537168" cy="4238625"/>
+          </a:xfrm>
+          <a:prstGeom xmlns:a="http://schemas.openxmlformats.org/drawingml/2006/main" prst="rect">
+            <a:avLst/>
+          </a:prstGeom>
+        </p:spPr>
+        <p:txBody>
+          <a:bodyPr xmlns:a="http://schemas.openxmlformats.org/drawingml/2006/main" lIns="0" tIns="0" rIns="0" bIns="0" anchor="t">
+            <a:normAutofit fontScale="100000"/>
+          </a:bodyPr>
+          <a:lstStyle xmlns:a="http://schemas.openxmlformats.org/drawingml/2006/main"/>
+          <a:p xmlns:a="http://schemas.openxmlformats.org/drawingml/2006/main">
+            <a:pPr algn="l">
+              <a:buNone/>
+              <a:defRPr sz="1950">
+                <a:solidFill>
+                  <a:srgbClr val="000000"/>
+                </a:solidFill>
+                <a:latin typeface="Helvetica Neue"/>
+                <a:ea typeface="Helvetica Neue"/>
+                <a:cs typeface="Helvetica Neue"/>
+              </a:defRPr>
+            </a:pPr>
+            <a:r>
+              <a:t>All 25 pairs passed integrity and two-sided trade support. Most retained positive-beta semantics.</a:t>
+            </a:r>
+          </a:p>
+          <a:p xmlns:a="http://schemas.openxmlformats.org/drawingml/2006/main">
+            <a:pPr algn="l">
+              <a:buNone/>
+              <a:defRPr sz="1950">
+                <a:solidFill>
+                  <a:srgbClr val="000000"/>
+                </a:solidFill>
+                <a:latin typeface="Helvetica Neue"/>
+                <a:ea typeface="Helvetica Neue"/>
+                <a:cs typeface="Helvetica Neue"/>
+              </a:defRPr>
+            </a:pPr>
+            <a:r>
+              <a:t/>
+            </a:r>
+          </a:p>
+          <a:p xmlns:a="http://schemas.openxmlformats.org/drawingml/2006/main">
+            <a:pPr algn="l">
+              <a:buNone/>
+              <a:defRPr sz="1950">
+                <a:solidFill>
+                  <a:srgbClr val="000000"/>
+                </a:solidFill>
+                <a:latin typeface="Helvetica Neue"/>
+                <a:ea typeface="Helvetica Neue"/>
+                <a:cs typeface="Helvetica Neue"/>
+              </a:defRPr>
+            </a:pPr>
+            <a:r>
+              <a:t>Only one had a positive net mean; none cleared its uncertainty interval. Three had negative forward-correlation point estimates, but none had a robust upper bound below zero.</a:t>
+            </a:r>
+          </a:p>
+          <a:p xmlns:a="http://schemas.openxmlformats.org/drawingml/2006/main">
+            <a:pPr algn="l">
+              <a:buNone/>
+              <a:defRPr sz="1950">
+                <a:solidFill>
+                  <a:srgbClr val="000000"/>
+                </a:solidFill>
+                <a:latin typeface="Helvetica Neue"/>
+                <a:ea typeface="Helvetica Neue"/>
+                <a:cs typeface="Helvetica Neue"/>
+              </a:defRPr>
+            </a:pPr>
+            <a:r>
+              <a:t/>
+            </a:r>
+          </a:p>
+          <a:p xmlns:a="http://schemas.openxmlformats.org/drawingml/2006/main">
+            <a:pPr algn="l">
+              <a:buNone/>
+              <a:defRPr sz="1950">
+                <a:solidFill>
+                  <a:srgbClr val="000000"/>
+                </a:solidFill>
+                <a:latin typeface="Helvetica Neue"/>
+                <a:ea typeface="Helvetica Neue"/>
+                <a:cs typeface="Helvetica Neue"/>
+              </a:defRPr>
+            </a:pPr>
+            <a:r>
+              <a:t>Because no pair cleared TRAIN, DEVELOPMENT was never opened.</a:t>
+            </a:r>
+          </a:p>
+        </p:txBody>
+      </p:sp>
+      <p:pic>
+        <p:nvPicPr>
+          <p:cNvPr id="21" name=""/>
+          <p:cNvPicPr>
+            <a:picLocks xmlns:a="http://schemas.openxmlformats.org/drawingml/2006/main" noChangeAspect="1"/>
+          </p:cNvPicPr>
+          <p:nvPr/>
+        </p:nvPicPr>
+        <p:blipFill>
+          <a:blip xmlns:r="http://schemas.openxmlformats.org/officeDocument/2006/relationships" xmlns:a="http://schemas.openxmlformats.org/drawingml/2006/main" r:embed="Rd9e589070cce4cf0"/>
+          <a:stretch xmlns:a="http://schemas.openxmlformats.org/drawingml/2006/main"/>
+        </p:blipFill>
+        <p:spPr>
+          <a:xfrm xmlns:a="http://schemas.openxmlformats.org/drawingml/2006/main">
+            <a:off x="6381750" y="1595005"/>
+            <a:ext cx="5314950" cy="3382241"/>
+          </a:xfrm>
+          <a:prstGeom xmlns:a="http://schemas.openxmlformats.org/drawingml/2006/main" prst="roundRect">
+            <a:avLst/>
+          </a:prstGeom>
+        </p:spPr>
+      </p:pic>
+      <p:sp>
+        <p:nvSpPr>
+          <p:cNvPr id="8" name="">
+            <a:extLst xmlns:a="http://schemas.openxmlformats.org/drawingml/2006/main">
+              <a:ext uri="{FF2B5EF4-FFF2-40B4-BE49-F238E27FC236}">
+                <a16:creationId xmlns:a16="http://schemas.microsoft.com/office/drawing/2014/main" id="{5F1B8A64-ACC9-4498-AEAE-0060DC180571}"/>
+              </a:ext>
+            </a:extLst>
+          </p:cNvPr>
+          <p:cNvSpPr>
+            <a:spLocks xmlns:a="http://schemas.openxmlformats.org/drawingml/2006/main" noGrp="1"/>
+          </p:cNvSpPr>
+          <p:nvPr/>
+        </p:nvSpPr>
+        <p:spPr>
+          <a:xfrm xmlns:a="http://schemas.openxmlformats.org/drawingml/2006/main">
+            <a:off x="6381750" y="1595005"/>
+            <a:ext cx="5314950" cy="3382241"/>
+          </a:xfrm>
+          <a:prstGeom xmlns:a="http://schemas.openxmlformats.org/drawingml/2006/main" prst="rect">
+            <a:avLst/>
+          </a:prstGeom>
+          <a:solidFill xmlns:a="http://schemas.openxmlformats.org/drawingml/2006/main">
+            <a:srgbClr val="FFFFFF"/>
+          </a:solidFill>
+          <a:ln xmlns:a="http://schemas.openxmlformats.org/drawingml/2006/main" w="0">
+            <a:solidFill>
+              <a:srgbClr val="FFFFFF"/>
+            </a:solidFill>
+            <a:prstDash val="solid"/>
+          </a:ln>
+        </p:spPr>
+      </p:sp>
+      <p:pic>
+        <p:nvPicPr>
+          <p:cNvPr id="23" name=""/>
+          <p:cNvPicPr>
+            <a:picLocks xmlns:a="http://schemas.openxmlformats.org/drawingml/2006/main" noChangeAspect="1"/>
+          </p:cNvPicPr>
+          <p:nvPr/>
+        </p:nvPicPr>
+        <p:blipFill>
+          <a:blip xmlns:r="http://schemas.openxmlformats.org/officeDocument/2006/relationships" xmlns:a="http://schemas.openxmlformats.org/drawingml/2006/main" r:embed="R1ba8deee89174e90"/>
+          <a:stretch xmlns:a="http://schemas.openxmlformats.org/drawingml/2006/main"/>
+        </p:blipFill>
+        <p:spPr>
+          <a:xfrm xmlns:a="http://schemas.openxmlformats.org/drawingml/2006/main">
+            <a:off x="6381750" y="1704295"/>
+            <a:ext cx="5314950" cy="3163661"/>
+          </a:xfrm>
+          <a:prstGeom xmlns:a="http://schemas.openxmlformats.org/drawingml/2006/main" prst="roundRect">
+            <a:avLst/>
+          </a:prstGeom>
+        </p:spPr>
+      </p:pic>
+      <p:sp>
+        <p:nvSpPr>
+          <p:cNvPr id="11" name="">
+            <a:extLst xmlns:a="http://schemas.openxmlformats.org/drawingml/2006/main">
+              <a:ext uri="{FF2B5EF4-FFF2-40B4-BE49-F238E27FC236}">
+                <a16:creationId xmlns:a16="http://schemas.microsoft.com/office/drawing/2014/main" id="{25209D2C-E63E-4C2B-9C87-FE274541976C}"/>
+              </a:ext>
+            </a:extLst>
+          </p:cNvPr>
+          <p:cNvSpPr>
+            <a:spLocks xmlns:a="http://schemas.openxmlformats.org/drawingml/2006/main" noGrp="1"/>
+          </p:cNvSpPr>
+          <p:nvPr/>
+        </p:nvSpPr>
+        <p:spPr>
+          <a:xfrm xmlns:a="http://schemas.openxmlformats.org/drawingml/2006/main">
+            <a:off x="6381750" y="1595005"/>
+            <a:ext cx="5314950" cy="3382241"/>
+          </a:xfrm>
+          <a:prstGeom xmlns:a="http://schemas.openxmlformats.org/drawingml/2006/main" prst="rect">
+            <a:avLst/>
+          </a:prstGeom>
+          <a:solidFill xmlns:a="http://schemas.openxmlformats.org/drawingml/2006/main">
+            <a:srgbClr val="FFFFFF"/>
+          </a:solidFill>
+          <a:ln xmlns:a="http://schemas.openxmlformats.org/drawingml/2006/main" w="0">
+            <a:solidFill>
+              <a:srgbClr val="FFFFFF"/>
+            </a:solidFill>
+            <a:prstDash val="solid"/>
+          </a:ln>
+        </p:spPr>
+      </p:sp>
+      <p:pic>
+        <p:nvPicPr>
+          <p:cNvPr id="25" name=""/>
+          <p:cNvPicPr>
+            <a:picLocks xmlns:a="http://schemas.openxmlformats.org/drawingml/2006/main" noChangeAspect="1"/>
+          </p:cNvPicPr>
+          <p:nvPr/>
+        </p:nvPicPr>
+        <p:blipFill>
+          <a:blip xmlns:r="http://schemas.openxmlformats.org/officeDocument/2006/relationships" xmlns:a="http://schemas.openxmlformats.org/drawingml/2006/main" r:embed="Rb8d99f43d31046ca"/>
+          <a:stretch xmlns:a="http://schemas.openxmlformats.org/drawingml/2006/main"/>
+        </p:blipFill>
+        <p:spPr>
+          <a:xfrm xmlns:a="http://schemas.openxmlformats.org/drawingml/2006/main">
+            <a:off x="6381750" y="1704295"/>
+            <a:ext cx="5314950" cy="3163661"/>
+          </a:xfrm>
+          <a:prstGeom xmlns:a="http://schemas.openxmlformats.org/drawingml/2006/main" prst="roundRect">
+            <a:avLst/>
+          </a:prstGeom>
+        </p:spPr>
+      </p:pic>
+      <p:sp>
+        <p:nvSpPr>
+          <p:cNvPr id="15" name="">
+            <a:extLst xmlns:a="http://schemas.openxmlformats.org/drawingml/2006/main">
+              <a:ext uri="{FF2B5EF4-FFF2-40B4-BE49-F238E27FC236}">
+                <a16:creationId xmlns:a16="http://schemas.microsoft.com/office/drawing/2014/main" id="{ABCED5F4-E309-4080-8AA8-7707B7312AEC}"/>
+              </a:ext>
+            </a:extLst>
+          </p:cNvPr>
+          <p:cNvSpPr>
+            <a:spLocks xmlns:a="http://schemas.openxmlformats.org/drawingml/2006/main" noGrp="1"/>
+          </p:cNvSpPr>
+          <p:nvPr/>
+        </p:nvSpPr>
+        <p:spPr>
+          <a:xfrm xmlns:a="http://schemas.openxmlformats.org/drawingml/2006/main">
+            <a:off x="6381750" y="1595005"/>
+            <a:ext cx="5314950" cy="3382241"/>
+          </a:xfrm>
+          <a:prstGeom xmlns:a="http://schemas.openxmlformats.org/drawingml/2006/main" prst="rect">
+            <a:avLst/>
+          </a:prstGeom>
+          <a:solidFill xmlns:a="http://schemas.openxmlformats.org/drawingml/2006/main">
+            <a:srgbClr val="FFFFFF"/>
+          </a:solidFill>
+          <a:ln xmlns:a="http://schemas.openxmlformats.org/drawingml/2006/main" w="0">
+            <a:solidFill>
+              <a:srgbClr val="FFFFFF"/>
+            </a:solidFill>
+            <a:prstDash val="solid"/>
+          </a:ln>
+        </p:spPr>
+      </p:sp>
+      <p:pic>
+        <p:nvPicPr>
+          <p:cNvPr id="27" name=""/>
+          <p:cNvPicPr>
+            <a:picLocks xmlns:a="http://schemas.openxmlformats.org/drawingml/2006/main" noChangeAspect="1"/>
+          </p:cNvPicPr>
+          <p:nvPr/>
+        </p:nvPicPr>
+        <p:blipFill>
+          <a:blip xmlns:r="http://schemas.openxmlformats.org/officeDocument/2006/relationships" xmlns:a="http://schemas.openxmlformats.org/drawingml/2006/main" r:embed="Rf2801f54a9f64a86"/>
+          <a:stretch xmlns:a="http://schemas.openxmlformats.org/drawingml/2006/main"/>
+        </p:blipFill>
+        <p:spPr>
+          <a:xfrm xmlns:a="http://schemas.openxmlformats.org/drawingml/2006/main">
+            <a:off x="6381750" y="1704295"/>
+            <a:ext cx="5314950" cy="3163661"/>
+          </a:xfrm>
+          <a:prstGeom xmlns:a="http://schemas.openxmlformats.org/drawingml/2006/main" prst="roundRect">
+            <a:avLst/>
+          </a:prstGeom>
+        </p:spPr>
+      </p:pic>
+    </p:spTree>
+    <p:extLst>
+      <p:ext uri="{BB962C8B-B14F-4D97-AF65-F5344CB8AC3E}">
+        <p14:creationId xmlns:p14="http://schemas.microsoft.com/office/powerpoint/2010/main" val="463436756"/>
+      </p:ext>
+    </p:extLst>
+  </p:cSld>
+</p:sld>
+</file>
+
+<file path=ppt/slides/slide39.xml><?xml version="1.0" encoding="utf-8"?>
+<p:sld xmlns:p="http://schemas.openxmlformats.org/presentationml/2006/main">
+  <p:cSld>
+    <p:spTree>
+      <p:nvGrpSpPr>
+        <p:cNvPr id="1" name=""/>
+        <p:cNvGrpSpPr/>
+        <p:nvPr/>
+      </p:nvGrpSpPr>
+      <p:grpSpPr>
+        <a:xfrm xmlns:a="http://schemas.openxmlformats.org/drawingml/2006/main"/>
+      </p:grpSpPr>
+      <p:sp>
+        <p:nvSpPr>
+          <p:cNvPr id="4" name="cover-headline">
+            <a:extLst xmlns:a="http://schemas.openxmlformats.org/drawingml/2006/main">
+              <a:ext uri="{FF2B5EF4-FFF2-40B4-BE49-F238E27FC236}">
+                <a16:creationId xmlns:a16="http://schemas.microsoft.com/office/drawing/2014/main" id="{E9F43BB9-4202-4A42-9916-7A06678333BD}"/>
+              </a:ext>
+            </a:extLst>
+          </p:cNvPr>
+          <p:cNvSpPr>
+            <a:spLocks xmlns:a="http://schemas.openxmlformats.org/drawingml/2006/main" noGrp="1"/>
+          </p:cNvSpPr>
+          <p:nvPr/>
+        </p:nvSpPr>
+        <p:spPr>
+          <a:xfrm xmlns:a="http://schemas.openxmlformats.org/drawingml/2006/main">
+            <a:off x="393668" y="1738789"/>
+            <a:ext cx="10287000" cy="2491454"/>
+          </a:xfrm>
+          <a:prstGeom xmlns:a="http://schemas.openxmlformats.org/drawingml/2006/main" prst="rect">
+            <a:avLst/>
+          </a:prstGeom>
+        </p:spPr>
+        <p:txBody>
+          <a:bodyPr xmlns:a="http://schemas.openxmlformats.org/drawingml/2006/main" lIns="0" tIns="0" rIns="0" bIns="0" anchor="b">
+            <a:normAutofit fontScale="100000"/>
+          </a:bodyPr>
+          <a:lstStyle xmlns:a="http://schemas.openxmlformats.org/drawingml/2006/main"/>
+          <a:p xmlns:a="http://schemas.openxmlformats.org/drawingml/2006/main">
+            <a:pPr algn="l">
+              <a:buNone/>
+              <a:defRPr sz="5700">
+                <a:solidFill>
+                  <a:srgbClr val="000000"/>
+                </a:solidFill>
+                <a:latin typeface="Helvetica Neue"/>
+                <a:ea typeface="Helvetica Neue"/>
+                <a:cs typeface="Helvetica Neue"/>
+              </a:defRPr>
+            </a:pPr>
+            <a:r>
+              <a:t>The atlas worked.</a:t>
+            </a:r>
+          </a:p>
+          <a:p xmlns:a="http://schemas.openxmlformats.org/drawingml/2006/main">
+            <a:pPr algn="l">
+              <a:buNone/>
+              <a:defRPr sz="5700">
+                <a:solidFill>
+                  <a:srgbClr val="000000"/>
+                </a:solidFill>
+                <a:latin typeface="Helvetica Neue"/>
+                <a:ea typeface="Helvetica Neue"/>
+                <a:cs typeface="Helvetica Neue"/>
+              </a:defRPr>
+            </a:pPr>
+            <a:r>
+              <a:t>The pair rule still did not.</a:t>
+            </a:r>
+          </a:p>
+        </p:txBody>
+      </p:sp>
+      <p:sp>
+        <p:nvSpPr>
+          <p:cNvPr id="2" name="cover-subtitle">
+            <a:extLst xmlns:a="http://schemas.openxmlformats.org/drawingml/2006/main">
+              <a:ext uri="{FF2B5EF4-FFF2-40B4-BE49-F238E27FC236}">
+                <a16:creationId xmlns:a16="http://schemas.microsoft.com/office/drawing/2014/main" id="{F6F90063-BA30-438B-9FD3-13AA22719785}"/>
+              </a:ext>
+            </a:extLst>
+          </p:cNvPr>
+          <p:cNvSpPr>
+            <a:spLocks xmlns:a="http://schemas.openxmlformats.org/drawingml/2006/main" noGrp="1"/>
+          </p:cNvSpPr>
+          <p:nvPr/>
+        </p:nvSpPr>
+        <p:spPr>
+          <a:xfrm xmlns:a="http://schemas.openxmlformats.org/drawingml/2006/main">
+            <a:off x="393668" y="4762500"/>
+            <a:ext cx="8001000" cy="1238250"/>
+          </a:xfrm>
+          <a:prstGeom xmlns:a="http://schemas.openxmlformats.org/drawingml/2006/main" prst="rect">
+            <a:avLst/>
+          </a:prstGeom>
+        </p:spPr>
+        <p:txBody>
+          <a:bodyPr xmlns:a="http://schemas.openxmlformats.org/drawingml/2006/main" lIns="0" tIns="0" rIns="0" bIns="0">
+            <a:normAutofit fontScale="100000"/>
+          </a:bodyPr>
+          <a:lstStyle xmlns:a="http://schemas.openxmlformats.org/drawingml/2006/main"/>
+          <a:p xmlns:a="http://schemas.openxmlformats.org/drawingml/2006/main">
+            <a:pPr algn="l">
+              <a:buNone/>
+              <a:defRPr sz="2250">
+                <a:solidFill>
+                  <a:srgbClr val="000000"/>
+                </a:solidFill>
+                <a:latin typeface="Helvetica Neue"/>
+                <a:ea typeface="Helvetica Neue"/>
+                <a:cs typeface="Helvetica Neue"/>
+              </a:defRPr>
+            </a:pPr>
+            <a:r>
+              <a:t>We now have a reusable, category-labeled generator and a stronger falsification result: 0 of 25 new instances cleared TRAIN, so no OOS performance claim was made.</a:t>
+            </a:r>
+          </a:p>
+        </p:txBody>
+      </p:sp>
+      <p:sp>
+        <p:nvSpPr>
+          <p:cNvPr id="3" name="cover-eyebrow">
+            <a:extLst xmlns:a="http://schemas.openxmlformats.org/drawingml/2006/main">
+              <a:ext uri="{FF2B5EF4-FFF2-40B4-BE49-F238E27FC236}">
+                <a16:creationId xmlns:a16="http://schemas.microsoft.com/office/drawing/2014/main" id="{45129715-75DE-4D50-B44D-3AFE3EBA3F0E}"/>
+              </a:ext>
+            </a:extLst>
+          </p:cNvPr>
+          <p:cNvSpPr>
+            <a:spLocks xmlns:a="http://schemas.openxmlformats.org/drawingml/2006/main" noGrp="1"/>
+          </p:cNvSpPr>
+          <p:nvPr/>
+        </p:nvSpPr>
+        <p:spPr>
+          <a:xfrm xmlns:a="http://schemas.openxmlformats.org/drawingml/2006/main">
+            <a:off x="393668" y="392240"/>
+            <a:ext cx="7239000" cy="649129"/>
+          </a:xfrm>
+          <a:prstGeom xmlns:a="http://schemas.openxmlformats.org/drawingml/2006/main" prst="rect">
+            <a:avLst/>
+          </a:prstGeom>
+        </p:spPr>
+        <p:txBody>
+          <a:bodyPr xmlns:a="http://schemas.openxmlformats.org/drawingml/2006/main" lIns="0" tIns="0" rIns="0" bIns="0">
+            <a:normAutofit fontScale="100000"/>
+          </a:bodyPr>
+          <a:lstStyle xmlns:a="http://schemas.openxmlformats.org/drawingml/2006/main"/>
+          <a:p xmlns:a="http://schemas.openxmlformats.org/drawingml/2006/main">
+            <a:pPr algn="l">
+              <a:buNone/>
+              <a:defRPr sz="2250">
+                <a:solidFill>
+                  <a:srgbClr val="000000"/>
+                </a:solidFill>
+                <a:latin typeface="Helvetica Neue"/>
+                <a:ea typeface="Helvetica Neue"/>
+                <a:cs typeface="Helvetica Neue"/>
+              </a:defRPr>
+            </a:pPr>
+            <a:r>
+              <a:t>RELATIONSHIP ATLAS 01 | STOP AT TRAIN</a:t>
+            </a:r>
+          </a:p>
+        </p:txBody>
+      </p:sp>
+    </p:spTree>
+    <p:extLst>
+      <p:ext uri="{BB962C8B-B14F-4D97-AF65-F5344CB8AC3E}">
+        <p14:creationId xmlns:p14="http://schemas.microsoft.com/office/powerpoint/2010/main" val="1664240194"/>
+      </p:ext>
+    </p:extLst>
+  </p:cSld>
+</p:sld>
+</file>
+
 <file path=ppt/slides/slide4.xml><?xml version="1.0" encoding="utf-8"?>
 <p:sld xmlns:p="http://schemas.openxmlformats.org/presentationml/2006/main">
   <p:cSld>
@@ -14528,7 +17282,7 @@
           <p:nvPr/>
         </p:nvPicPr>
         <p:blipFill>
-          <a:blip xmlns:r="http://schemas.openxmlformats.org/officeDocument/2006/relationships" xmlns:a="http://schemas.openxmlformats.org/drawingml/2006/main" r:embed="Rf426af2b6bc94e07"/>
+          <a:blip xmlns:r="http://schemas.openxmlformats.org/officeDocument/2006/relationships" xmlns:a="http://schemas.openxmlformats.org/drawingml/2006/main" r:embed="R06a40f276fdd442c"/>
           <a:stretch xmlns:a="http://schemas.openxmlformats.org/drawingml/2006/main"/>
         </p:blipFill>
         <p:spPr>
@@ -14583,7 +17337,7 @@
           <p:nvPr/>
         </p:nvPicPr>
         <p:blipFill>
-          <a:blip xmlns:r="http://schemas.openxmlformats.org/officeDocument/2006/relationships" xmlns:a="http://schemas.openxmlformats.org/drawingml/2006/main" r:embed="R26ea4091070d4101"/>
+          <a:blip xmlns:r="http://schemas.openxmlformats.org/officeDocument/2006/relationships" xmlns:a="http://schemas.openxmlformats.org/drawingml/2006/main" r:embed="R9c08206f5a464b58"/>
           <a:stretch xmlns:a="http://schemas.openxmlformats.org/drawingml/2006/main"/>
         </p:blipFill>
         <p:spPr>

</xml_diff>